<commit_message>
feat: release GradientCIO plugin 5.2.0
Co-authored-by: Cursor <cursoragent@cursor.com>
</commit_message>
<xml_diff>
--- a/plugins/gradient-cio/assets/examples/gradient-idd-manager-performance-compare.pptx
+++ b/plugins/gradient-cio/assets/examples/gradient-idd-manager-performance-compare.pptx
@@ -13,6 +13,7 @@
     <ns0:sldId id="261" ns1:id="rId12"/>
     <ns0:sldId id="262" ns1:id="rId13"/>
     <ns0:sldId id="263" ns1:id="rId14"/>
+    <ns0:sldId id="264" ns1:id="rId15"/>
   </ns0:sldIdLst>
   <ns0:sldSz cx="12191695" cy="6858000" type="screen16x9"/>
   <ns0:notesSz cx="6858000" cy="9144000"/>
@@ -8350,7 +8351,7 @@
               <a:rPr>
                 <a:latin typeface="Inter"/>
               </a:rPr>
-              <a:t>Appendix A — Sources and methods</a:t>
+              <a:t>Appendix — Sources and methods</a:t>
             </a:r>
           </a:p>
         </p:txBody>
@@ -8490,7 +8491,7 @@
               <a:rPr>
                 <a:latin typeface="Inter"/>
               </a:rPr>
-              <a:t>07</a:t>
+              <a:t>A</a:t>
             </a:r>
           </a:p>
         </p:txBody>
@@ -8515,8 +8516,14 @@
               </a:tblPr>
               <a:tblGrid>
                 <a:gridCol w="2011680"/>
-                <a:gridCol w="4448556"/>
-                <a:gridCol w="4448556"/>
+                <a:gridCol w="1112139"/>
+                <a:gridCol w="1112139"/>
+                <a:gridCol w="1112139"/>
+                <a:gridCol w="1112139"/>
+                <a:gridCol w="1112139"/>
+                <a:gridCol w="1112139"/>
+                <a:gridCol w="1112139"/>
+                <a:gridCol w="1112139"/>
               </a:tblGrid>
               <a:tr h="584831">
                 <a:tc>
@@ -8590,7 +8597,169 @@
                         <a:rPr>
                           <a:latin typeface="Inter"/>
                         </a:rPr>
-                        <a:t>Tool</a:t>
+                        <a:t>Basis</a:t>
+                      </a:r>
+                    </a:p>
+                  </a:txBody>
+                  <a:tcPr marL="54864" marR="54864" marT="27432" marB="27432" anchor="ctr">
+                    <a:solidFill>
+                      <a:srgbClr val="0D1117"/>
+                    </a:solidFill>
+                  </a:tcPr>
+                </a:tc>
+                <a:tc>
+                  <a:txBody>
+                    <a:bodyPr/>
+                    <a:lstStyle/>
+                    <a:p>
+                      <a:pPr>
+                        <a:defRPr sz="750" b="1">
+                          <a:solidFill>
+                            <a:srgbClr val="FFFFFF"/>
+                          </a:solidFill>
+                          <a:latin typeface="Inter"/>
+                        </a:defRPr>
+                      </a:pPr>
+                      <a:r>
+                        <a:rPr>
+                          <a:latin typeface="Inter"/>
+                        </a:rPr>
+                        <a:t>Tool / view</a:t>
+                      </a:r>
+                    </a:p>
+                  </a:txBody>
+                  <a:tcPr marL="54864" marR="54864" marT="27432" marB="27432" anchor="ctr">
+                    <a:solidFill>
+                      <a:srgbClr val="0D1117"/>
+                    </a:solidFill>
+                  </a:tcPr>
+                </a:tc>
+                <a:tc>
+                  <a:txBody>
+                    <a:bodyPr/>
+                    <a:lstStyle/>
+                    <a:p>
+                      <a:pPr>
+                        <a:defRPr sz="750" b="1">
+                          <a:solidFill>
+                            <a:srgbClr val="FFFFFF"/>
+                          </a:solidFill>
+                          <a:latin typeface="Inter"/>
+                        </a:defRPr>
+                      </a:pPr>
+                      <a:r>
+                        <a:rPr>
+                          <a:latin typeface="Inter"/>
+                        </a:rPr>
+                        <a:t>Key parameters</a:t>
+                      </a:r>
+                    </a:p>
+                  </a:txBody>
+                  <a:tcPr marL="54864" marR="54864" marT="27432" marB="27432" anchor="ctr">
+                    <a:solidFill>
+                      <a:srgbClr val="0D1117"/>
+                    </a:solidFill>
+                  </a:tcPr>
+                </a:tc>
+                <a:tc>
+                  <a:txBody>
+                    <a:bodyPr/>
+                    <a:lstStyle/>
+                    <a:p>
+                      <a:pPr>
+                        <a:defRPr sz="750" b="1">
+                          <a:solidFill>
+                            <a:srgbClr val="FFFFFF"/>
+                          </a:solidFill>
+                          <a:latin typeface="Inter"/>
+                        </a:defRPr>
+                      </a:pPr>
+                      <a:r>
+                        <a:rPr>
+                          <a:latin typeface="Inter"/>
+                        </a:rPr>
+                        <a:t>As of</a:t>
+                      </a:r>
+                    </a:p>
+                  </a:txBody>
+                  <a:tcPr marL="54864" marR="54864" marT="27432" marB="27432" anchor="ctr">
+                    <a:solidFill>
+                      <a:srgbClr val="0D1117"/>
+                    </a:solidFill>
+                  </a:tcPr>
+                </a:tc>
+                <a:tc>
+                  <a:txBody>
+                    <a:bodyPr/>
+                    <a:lstStyle/>
+                    <a:p>
+                      <a:pPr>
+                        <a:defRPr sz="750" b="1">
+                          <a:solidFill>
+                            <a:srgbClr val="FFFFFF"/>
+                          </a:solidFill>
+                          <a:latin typeface="Inter"/>
+                        </a:defRPr>
+                      </a:pPr>
+                      <a:r>
+                        <a:rPr>
+                          <a:latin typeface="Inter"/>
+                        </a:rPr>
+                        <a:t>Data scope</a:t>
+                      </a:r>
+                    </a:p>
+                  </a:txBody>
+                  <a:tcPr marL="54864" marR="54864" marT="27432" marB="27432" anchor="ctr">
+                    <a:solidFill>
+                      <a:srgbClr val="0D1117"/>
+                    </a:solidFill>
+                  </a:tcPr>
+                </a:tc>
+                <a:tc>
+                  <a:txBody>
+                    <a:bodyPr/>
+                    <a:lstStyle/>
+                    <a:p>
+                      <a:pPr>
+                        <a:defRPr sz="750" b="1">
+                          <a:solidFill>
+                            <a:srgbClr val="FFFFFF"/>
+                          </a:solidFill>
+                          <a:latin typeface="Inter"/>
+                        </a:defRPr>
+                      </a:pPr>
+                      <a:r>
+                        <a:rPr>
+                          <a:latin typeface="Inter"/>
+                        </a:rPr>
+                        <a:t>Validation</a:t>
+                      </a:r>
+                    </a:p>
+                  </a:txBody>
+                  <a:tcPr marL="54864" marR="54864" marT="27432" marB="27432" anchor="ctr">
+                    <a:solidFill>
+                      <a:srgbClr val="0D1117"/>
+                    </a:solidFill>
+                  </a:tcPr>
+                </a:tc>
+                <a:tc>
+                  <a:txBody>
+                    <a:bodyPr/>
+                    <a:lstStyle/>
+                    <a:p>
+                      <a:pPr>
+                        <a:defRPr sz="750" b="1">
+                          <a:solidFill>
+                            <a:srgbClr val="FFFFFF"/>
+                          </a:solidFill>
+                          <a:latin typeface="Inter"/>
+                        </a:defRPr>
+                      </a:pPr>
+                      <a:r>
+                        <a:rPr>
+                          <a:latin typeface="Inter"/>
+                        </a:rPr>
+                        <a:t>Digest</a:t>
                       </a:r>
                     </a:p>
                   </a:txBody>
@@ -8608,7 +8777,7 @@
                     <a:lstStyle/>
                     <a:p>
                       <a:pPr>
-                        <a:defRPr sz="800" b="1">
+                        <a:defRPr sz="650" b="1">
                           <a:solidFill>
                             <a:srgbClr val="0D1117"/>
                           </a:solidFill>
@@ -8635,7 +8804,7 @@
                     <a:lstStyle/>
                     <a:p>
                       <a:pPr>
-                        <a:defRPr sz="800" b="0">
+                        <a:defRPr sz="650" b="0">
                           <a:solidFill>
                             <a:srgbClr val="0D1117"/>
                           </a:solidFill>
@@ -8662,7 +8831,34 @@
                     <a:lstStyle/>
                     <a:p>
                       <a:pPr>
-                        <a:defRPr sz="800" b="0">
+                        <a:defRPr sz="650" b="0">
+                          <a:solidFill>
+                            <a:srgbClr val="0D1117"/>
+                          </a:solidFill>
+                          <a:latin typeface="Inter"/>
+                        </a:defRPr>
+                      </a:pPr>
+                      <a:r>
+                        <a:rPr>
+                          <a:latin typeface="Inter"/>
+                        </a:rPr>
+                        <a:t>gradient_tool</a:t>
+                      </a:r>
+                    </a:p>
+                  </a:txBody>
+                  <a:tcPr marL="54864" marR="54864" marT="27432" marB="27432" anchor="ctr">
+                    <a:solidFill>
+                      <a:srgbClr val="FFFFFF"/>
+                    </a:solidFill>
+                  </a:tcPr>
+                </a:tc>
+                <a:tc>
+                  <a:txBody>
+                    <a:bodyPr/>
+                    <a:lstStyle/>
+                    <a:p>
+                      <a:pPr>
+                        <a:defRPr sz="650" b="0">
                           <a:solidFill>
                             <a:srgbClr val="0D1117"/>
                           </a:solidFill>
@@ -8683,6 +8879,141 @@
                     </a:solidFill>
                   </a:tcPr>
                 </a:tc>
+                <a:tc>
+                  <a:txBody>
+                    <a:bodyPr/>
+                    <a:lstStyle/>
+                    <a:p>
+                      <a:pPr>
+                        <a:defRPr sz="650" b="0">
+                          <a:solidFill>
+                            <a:srgbClr val="0D1117"/>
+                          </a:solidFill>
+                          <a:latin typeface="Inter"/>
+                        </a:defRPr>
+                      </a:pPr>
+                      <a:r>
+                        <a:rPr>
+                          <a:latin typeface="Inter"/>
+                        </a:rPr>
+                        <a:t>fixture=true</a:t>
+                      </a:r>
+                    </a:p>
+                  </a:txBody>
+                  <a:tcPr marL="54864" marR="54864" marT="27432" marB="27432" anchor="ctr">
+                    <a:solidFill>
+                      <a:srgbClr val="FFFFFF"/>
+                    </a:solidFill>
+                  </a:tcPr>
+                </a:tc>
+                <a:tc>
+                  <a:txBody>
+                    <a:bodyPr/>
+                    <a:lstStyle/>
+                    <a:p>
+                      <a:pPr>
+                        <a:defRPr sz="650" b="0">
+                          <a:solidFill>
+                            <a:srgbClr val="0D1117"/>
+                          </a:solidFill>
+                          <a:latin typeface="Inter"/>
+                        </a:defRPr>
+                      </a:pPr>
+                      <a:r>
+                        <a:rPr>
+                          <a:latin typeface="Inter"/>
+                        </a:rPr>
+                        <a:t>2025-12-31</a:t>
+                      </a:r>
+                    </a:p>
+                  </a:txBody>
+                  <a:tcPr marL="54864" marR="54864" marT="27432" marB="27432" anchor="ctr">
+                    <a:solidFill>
+                      <a:srgbClr val="FFFFFF"/>
+                    </a:solidFill>
+                  </a:tcPr>
+                </a:tc>
+                <a:tc>
+                  <a:txBody>
+                    <a:bodyPr/>
+                    <a:lstStyle/>
+                    <a:p>
+                      <a:pPr>
+                        <a:defRPr sz="650" b="0">
+                          <a:solidFill>
+                            <a:srgbClr val="0D1117"/>
+                          </a:solidFill>
+                          <a:latin typeface="Inter"/>
+                        </a:defRPr>
+                      </a:pPr>
+                      <a:r>
+                        <a:rPr>
+                          <a:latin typeface="Inter"/>
+                        </a:rPr>
+                        <a:t>Gradient-governed TEST evidence</a:t>
+                      </a:r>
+                    </a:p>
+                  </a:txBody>
+                  <a:tcPr marL="54864" marR="54864" marT="27432" marB="27432" anchor="ctr">
+                    <a:solidFill>
+                      <a:srgbClr val="FFFFFF"/>
+                    </a:solidFill>
+                  </a:tcPr>
+                </a:tc>
+                <a:tc>
+                  <a:txBody>
+                    <a:bodyPr/>
+                    <a:lstStyle/>
+                    <a:p>
+                      <a:pPr>
+                        <a:defRPr sz="650" b="0">
+                          <a:solidFill>
+                            <a:srgbClr val="0D1117"/>
+                          </a:solidFill>
+                          <a:latin typeface="Inter"/>
+                        </a:defRPr>
+                      </a:pPr>
+                      <a:r>
+                        <a:rPr>
+                          <a:latin typeface="Inter"/>
+                        </a:rPr>
+                        <a:t>passed</a:t>
+                      </a:r>
+                    </a:p>
+                  </a:txBody>
+                  <a:tcPr marL="54864" marR="54864" marT="27432" marB="27432" anchor="ctr">
+                    <a:solidFill>
+                      <a:srgbClr val="FFFFFF"/>
+                    </a:solidFill>
+                  </a:tcPr>
+                </a:tc>
+                <a:tc>
+                  <a:txBody>
+                    <a:bodyPr/>
+                    <a:lstStyle/>
+                    <a:p>
+                      <a:pPr>
+                        <a:defRPr sz="650" b="0">
+                          <a:solidFill>
+                            <a:srgbClr val="0D1117"/>
+                          </a:solidFill>
+                          <a:latin typeface="Inter"/>
+                        </a:defRPr>
+                      </a:pPr>
+                      <a:r>
+                        <a:rPr>
+                          <a:latin typeface="Inter"/>
+                        </a:rPr>
+                        <a:t>sha256:aaaaaaaaaaaaaaaaaaaaaaaaaaaaaaaaaaaaaaaaaaaaaaaaaaaaaaaaaaaaaaaa</a:t>
+                      </a:r>
+                    </a:p>
+                  </a:txBody>
+                  <a:tcPr marL="54864" marR="54864" marT="27432" marB="27432" anchor="ctr">
+                    <a:solidFill>
+                      <a:srgbClr val="FFFFFF"/>
+                    </a:solidFill>
+                  </a:tcPr>
+                </a:tc>
               </a:tr>
             </a:tbl>
           </a:graphicData>
@@ -9223,6 +9554,654 @@
                 <a:latin typeface="Inter"/>
               </a:rPr>
               <a:t>8</a:t>
+            </a:r>
+          </a:p>
+        </p:txBody>
+      </p:sp>
+    </p:spTree>
+  </p:cSld>
+  <p:clrMapOvr>
+    <a:masterClrMapping/>
+  </p:clrMapOvr>
+</p:sld>
+</file>
+
+<file path=ppt/slides/slide9.xml><?xml version="1.0" encoding="utf-8"?>
+<p:sld xmlns:a="http://schemas.openxmlformats.org/drawingml/2006/main" xmlns:p="http://schemas.openxmlformats.org/presentationml/2006/main" xmlns:r="http://schemas.openxmlformats.org/officeDocument/2006/relationships">
+  <p:cSld>
+    <p:spTree>
+      <p:nvGrpSpPr>
+        <p:cNvPr id="1" name=""/>
+        <p:cNvGrpSpPr/>
+        <p:nvPr/>
+      </p:nvGrpSpPr>
+      <p:grpSpPr/>
+      <p:sp>
+        <p:nvSpPr>
+          <p:cNvPr id="2" name="Rectangle 1"/>
+          <p:cNvSpPr/>
+          <p:nvPr/>
+        </p:nvSpPr>
+        <p:spPr>
+          <a:xfrm>
+            <a:off x="0" y="0"/>
+            <a:ext cx="12191695" cy="6858000"/>
+          </a:xfrm>
+          <a:prstGeom prst="rect">
+            <a:avLst/>
+          </a:prstGeom>
+          <a:solidFill>
+            <a:srgbClr val="FFFFFF"/>
+          </a:solidFill>
+          <a:ln>
+            <a:solidFill>
+              <a:srgbClr val="FFFFFF"/>
+            </a:solidFill>
+          </a:ln>
+        </p:spPr>
+        <p:style>
+          <a:lnRef idx="1">
+            <a:schemeClr val="accent1"/>
+          </a:lnRef>
+          <a:fillRef idx="3">
+            <a:schemeClr val="accent1"/>
+          </a:fillRef>
+          <a:effectRef idx="2">
+            <a:schemeClr val="accent1"/>
+          </a:effectRef>
+          <a:fontRef idx="minor">
+            <a:schemeClr val="lt1"/>
+          </a:fontRef>
+        </p:style>
+        <p:txBody>
+          <a:bodyPr rtlCol="0" anchor="ctr"/>
+          <a:lstStyle/>
+          <a:p>
+            <a:pPr algn="ctr">
+              <a:defRPr>
+                <a:latin typeface="Inter"/>
+              </a:defRPr>
+            </a:pPr>
+          </a:p>
+        </p:txBody>
+      </p:sp>
+      <p:sp>
+        <p:nvSpPr>
+          <p:cNvPr id="3" name="TextBox 2"/>
+          <p:cNvSpPr txBox="1"/>
+          <p:nvPr/>
+        </p:nvSpPr>
+        <p:spPr>
+          <a:xfrm>
+            <a:off x="640080" y="329184"/>
+            <a:ext cx="9875520" cy="182880"/>
+          </a:xfrm>
+          <a:prstGeom prst="rect">
+            <a:avLst/>
+          </a:prstGeom>
+          <a:noFill/>
+        </p:spPr>
+        <p:txBody>
+          <a:bodyPr wrap="none" lIns="9144" rIns="9144" tIns="9144" bIns="9144" anchor="t">
+            <a:spAutoFit/>
+          </a:bodyPr>
+          <a:lstStyle/>
+          <a:p>
+            <a:pPr algn="l">
+              <a:spcAft>
+                <a:spcPts val="0"/>
+              </a:spcAft>
+              <a:defRPr sz="750" b="1">
+                <a:solidFill>
+                  <a:srgbClr val="4F6B00"/>
+                </a:solidFill>
+                <a:latin typeface="Inter"/>
+              </a:defRPr>
+            </a:pPr>
+            <a:r>
+              <a:rPr>
+                <a:latin typeface="Inter"/>
+              </a:rPr>
+              <a:t>SAVED FICTIONAL TEST EVIDENCE</a:t>
+            </a:r>
+          </a:p>
+        </p:txBody>
+      </p:sp>
+      <p:sp>
+        <p:nvSpPr>
+          <p:cNvPr id="4" name="TextBox 3"/>
+          <p:cNvSpPr txBox="1"/>
+          <p:nvPr/>
+        </p:nvSpPr>
+        <p:spPr>
+          <a:xfrm>
+            <a:off x="640080" y="566928"/>
+            <a:ext cx="10058400" cy="530352"/>
+          </a:xfrm>
+          <a:prstGeom prst="rect">
+            <a:avLst/>
+          </a:prstGeom>
+          <a:noFill/>
+        </p:spPr>
+        <p:txBody>
+          <a:bodyPr wrap="none" lIns="9144" rIns="9144" tIns="9144" bIns="9144" anchor="t">
+            <a:spAutoFit/>
+          </a:bodyPr>
+          <a:lstStyle/>
+          <a:p>
+            <a:pPr algn="l">
+              <a:spcAft>
+                <a:spcPts val="0"/>
+              </a:spcAft>
+              <a:defRPr sz="2300" b="1">
+                <a:solidFill>
+                  <a:srgbClr val="0D1117"/>
+                </a:solidFill>
+                <a:latin typeface="Inter"/>
+              </a:defRPr>
+            </a:pPr>
+            <a:r>
+              <a:rPr>
+                <a:latin typeface="Inter"/>
+              </a:rPr>
+              <a:t>Appendix — Sources and methods — continued</a:t>
+            </a:r>
+          </a:p>
+        </p:txBody>
+      </p:sp>
+      <p:sp>
+        <p:nvSpPr>
+          <p:cNvPr id="5" name="Rectangle 4"/>
+          <p:cNvSpPr/>
+          <p:nvPr/>
+        </p:nvSpPr>
+        <p:spPr>
+          <a:xfrm>
+            <a:off x="640080" y="1115568"/>
+            <a:ext cx="10908792" cy="18288"/>
+          </a:xfrm>
+          <a:prstGeom prst="rect">
+            <a:avLst/>
+          </a:prstGeom>
+          <a:solidFill>
+            <a:srgbClr val="0D1117"/>
+          </a:solidFill>
+          <a:ln>
+            <a:solidFill>
+              <a:srgbClr val="0D1117"/>
+            </a:solidFill>
+          </a:ln>
+        </p:spPr>
+        <p:style>
+          <a:lnRef idx="1">
+            <a:schemeClr val="accent1"/>
+          </a:lnRef>
+          <a:fillRef idx="3">
+            <a:schemeClr val="accent1"/>
+          </a:fillRef>
+          <a:effectRef idx="2">
+            <a:schemeClr val="accent1"/>
+          </a:effectRef>
+          <a:fontRef idx="minor">
+            <a:schemeClr val="lt1"/>
+          </a:fontRef>
+        </p:style>
+        <p:txBody>
+          <a:bodyPr rtlCol="0" anchor="ctr"/>
+          <a:lstStyle/>
+          <a:p>
+            <a:pPr algn="ctr">
+              <a:defRPr>
+                <a:latin typeface="Inter"/>
+              </a:defRPr>
+            </a:pPr>
+          </a:p>
+        </p:txBody>
+      </p:sp>
+      <p:sp>
+        <p:nvSpPr>
+          <p:cNvPr id="6" name="Rectangle 5"/>
+          <p:cNvSpPr/>
+          <p:nvPr/>
+        </p:nvSpPr>
+        <p:spPr>
+          <a:xfrm>
+            <a:off x="11018520" y="502920"/>
+            <a:ext cx="530352" cy="393192"/>
+          </a:xfrm>
+          <a:prstGeom prst="rect">
+            <a:avLst/>
+          </a:prstGeom>
+          <a:solidFill>
+            <a:srgbClr val="9AA5B1"/>
+          </a:solidFill>
+          <a:ln>
+            <a:solidFill>
+              <a:srgbClr val="9AA5B1"/>
+            </a:solidFill>
+          </a:ln>
+        </p:spPr>
+        <p:style>
+          <a:lnRef idx="1">
+            <a:schemeClr val="accent1"/>
+          </a:lnRef>
+          <a:fillRef idx="3">
+            <a:schemeClr val="accent1"/>
+          </a:fillRef>
+          <a:effectRef idx="2">
+            <a:schemeClr val="accent1"/>
+          </a:effectRef>
+          <a:fontRef idx="minor">
+            <a:schemeClr val="lt1"/>
+          </a:fontRef>
+        </p:style>
+        <p:txBody>
+          <a:bodyPr rtlCol="0" anchor="ctr"/>
+          <a:lstStyle/>
+          <a:p>
+            <a:pPr algn="ctr">
+              <a:defRPr>
+                <a:latin typeface="Inter"/>
+              </a:defRPr>
+            </a:pPr>
+          </a:p>
+        </p:txBody>
+      </p:sp>
+      <p:sp>
+        <p:nvSpPr>
+          <p:cNvPr id="7" name="TextBox 6"/>
+          <p:cNvSpPr txBox="1"/>
+          <p:nvPr/>
+        </p:nvSpPr>
+        <p:spPr>
+          <a:xfrm>
+            <a:off x="11045952" y="557784"/>
+            <a:ext cx="475488" cy="182880"/>
+          </a:xfrm>
+          <a:prstGeom prst="rect">
+            <a:avLst/>
+          </a:prstGeom>
+          <a:noFill/>
+        </p:spPr>
+        <p:txBody>
+          <a:bodyPr wrap="none" lIns="9144" rIns="9144" tIns="9144" bIns="9144" anchor="t">
+            <a:spAutoFit/>
+          </a:bodyPr>
+          <a:lstStyle/>
+          <a:p>
+            <a:pPr algn="ctr">
+              <a:spcAft>
+                <a:spcPts val="0"/>
+              </a:spcAft>
+              <a:defRPr sz="1000" b="1">
+                <a:solidFill>
+                  <a:srgbClr val="0D1117"/>
+                </a:solidFill>
+                <a:latin typeface="Inter"/>
+              </a:defRPr>
+            </a:pPr>
+            <a:r>
+              <a:rPr>
+                <a:latin typeface="Inter"/>
+              </a:rPr>
+              <a:t>A</a:t>
+            </a:r>
+          </a:p>
+        </p:txBody>
+      </p:sp>
+      <p:sp>
+        <p:nvSpPr>
+          <p:cNvPr id="8" name="Rectangle 7"/>
+          <p:cNvSpPr/>
+          <p:nvPr/>
+        </p:nvSpPr>
+        <p:spPr>
+          <a:xfrm>
+            <a:off x="640080" y="1325880"/>
+            <a:ext cx="10908792" cy="4892040"/>
+          </a:xfrm>
+          <a:prstGeom prst="rect">
+            <a:avLst/>
+          </a:prstGeom>
+          <a:solidFill>
+            <a:srgbClr val="F5F7F9"/>
+          </a:solidFill>
+          <a:ln>
+            <a:solidFill>
+              <a:srgbClr val="E3E7EC"/>
+            </a:solidFill>
+          </a:ln>
+        </p:spPr>
+        <p:style>
+          <a:lnRef idx="1">
+            <a:schemeClr val="accent1"/>
+          </a:lnRef>
+          <a:fillRef idx="3">
+            <a:schemeClr val="accent1"/>
+          </a:fillRef>
+          <a:effectRef idx="2">
+            <a:schemeClr val="accent1"/>
+          </a:effectRef>
+          <a:fontRef idx="minor">
+            <a:schemeClr val="lt1"/>
+          </a:fontRef>
+        </p:style>
+        <p:txBody>
+          <a:bodyPr rtlCol="0" anchor="ctr"/>
+          <a:lstStyle/>
+          <a:p>
+            <a:pPr algn="ctr">
+              <a:defRPr>
+                <a:latin typeface="Inter"/>
+              </a:defRPr>
+            </a:pPr>
+          </a:p>
+        </p:txBody>
+      </p:sp>
+      <p:sp>
+        <p:nvSpPr>
+          <p:cNvPr id="9" name="Rectangle 8"/>
+          <p:cNvSpPr/>
+          <p:nvPr/>
+        </p:nvSpPr>
+        <p:spPr>
+          <a:xfrm>
+            <a:off x="640080" y="1325880"/>
+            <a:ext cx="54864" cy="4892040"/>
+          </a:xfrm>
+          <a:prstGeom prst="rect">
+            <a:avLst/>
+          </a:prstGeom>
+          <a:solidFill>
+            <a:srgbClr val="0D1117"/>
+          </a:solidFill>
+          <a:ln>
+            <a:solidFill>
+              <a:srgbClr val="0D1117"/>
+            </a:solidFill>
+          </a:ln>
+        </p:spPr>
+        <p:style>
+          <a:lnRef idx="1">
+            <a:schemeClr val="accent1"/>
+          </a:lnRef>
+          <a:fillRef idx="3">
+            <a:schemeClr val="accent1"/>
+          </a:fillRef>
+          <a:effectRef idx="2">
+            <a:schemeClr val="accent1"/>
+          </a:effectRef>
+          <a:fontRef idx="minor">
+            <a:schemeClr val="lt1"/>
+          </a:fontRef>
+        </p:style>
+        <p:txBody>
+          <a:bodyPr rtlCol="0" anchor="ctr"/>
+          <a:lstStyle/>
+          <a:p>
+            <a:pPr algn="ctr">
+              <a:defRPr>
+                <a:latin typeface="Inter"/>
+              </a:defRPr>
+            </a:pPr>
+          </a:p>
+        </p:txBody>
+      </p:sp>
+      <p:sp>
+        <p:nvSpPr>
+          <p:cNvPr id="10" name="TextBox 9"/>
+          <p:cNvSpPr txBox="1"/>
+          <p:nvPr/>
+        </p:nvSpPr>
+        <p:spPr>
+          <a:xfrm>
+            <a:off x="804671" y="1435607"/>
+            <a:ext cx="10616184" cy="228600"/>
+          </a:xfrm>
+          <a:prstGeom prst="rect">
+            <a:avLst/>
+          </a:prstGeom>
+          <a:noFill/>
+        </p:spPr>
+        <p:txBody>
+          <a:bodyPr wrap="none" lIns="9144" rIns="9144" tIns="9144" bIns="9144" anchor="t">
+            <a:spAutoFit/>
+          </a:bodyPr>
+          <a:lstStyle/>
+          <a:p>
+            <a:pPr algn="l">
+              <a:spcAft>
+                <a:spcPts val="0"/>
+              </a:spcAft>
+              <a:defRPr sz="1000" b="1">
+                <a:solidFill>
+                  <a:srgbClr val="0D1117"/>
+                </a:solidFill>
+                <a:latin typeface="Inter"/>
+              </a:defRPr>
+            </a:pPr>
+            <a:r>
+              <a:rPr>
+                <a:latin typeface="Inter"/>
+              </a:rPr>
+              <a:t>Metric and digest interpretation</a:t>
+            </a:r>
+          </a:p>
+        </p:txBody>
+      </p:sp>
+      <p:sp>
+        <p:nvSpPr>
+          <p:cNvPr id="11" name="TextBox 10"/>
+          <p:cNvSpPr txBox="1"/>
+          <p:nvPr/>
+        </p:nvSpPr>
+        <p:spPr>
+          <a:xfrm>
+            <a:off x="804671" y="1719072"/>
+            <a:ext cx="10616184" cy="4407408"/>
+          </a:xfrm>
+          <a:prstGeom prst="rect">
+            <a:avLst/>
+          </a:prstGeom>
+          <a:noFill/>
+        </p:spPr>
+        <p:txBody>
+          <a:bodyPr wrap="none" lIns="9144" rIns="9144" tIns="9144" bIns="9144" anchor="t">
+            <a:spAutoFit/>
+          </a:bodyPr>
+          <a:lstStyle/>
+          <a:p>
+            <a:pPr algn="l">
+              <a:spcAft>
+                <a:spcPts val="0"/>
+              </a:spcAft>
+              <a:defRPr sz="950" b="0">
+                <a:solidFill>
+                  <a:srgbClr val="4A5563"/>
+                </a:solidFill>
+                <a:latin typeface="Inter"/>
+              </a:defRPr>
+            </a:pPr>
+            <a:r>
+              <a:rPr>
+                <a:latin typeface="Inter"/>
+              </a:rPr>
+              <a:t>Historical claims must use returned realized metrics with their exact periods, while path-distribution statistics must remain explicitly simulated [S1]. Successful tool evidence records the SHA-256 digest of the saved response; a failed call instead uses the typed no-payload sentinel and preserves its error code and request ID in the validation field. These controls prevent simulated statistics or request identifiers from being presented as observed evidence. The source row also retains the tool name, key parameters, as-of date and data scope so a reviewer can reproduce the evidence boundary without treating an unavailable payload as a successful observation. Advisory benchmark selections remain visibly advisory throughout the report and handoff. This distinction tells reviewers which comparisons are server-matched and which still require independent benchmark confirmation.</a:t>
+            </a:r>
+          </a:p>
+        </p:txBody>
+      </p:sp>
+      <p:sp>
+        <p:nvSpPr>
+          <p:cNvPr id="12" name="Rectangle 11"/>
+          <p:cNvSpPr/>
+          <p:nvPr/>
+        </p:nvSpPr>
+        <p:spPr>
+          <a:xfrm>
+            <a:off x="640080" y="6446520"/>
+            <a:ext cx="10908792" cy="9144"/>
+          </a:xfrm>
+          <a:prstGeom prst="rect">
+            <a:avLst/>
+          </a:prstGeom>
+          <a:solidFill>
+            <a:srgbClr val="E3E7EC"/>
+          </a:solidFill>
+          <a:ln>
+            <a:solidFill>
+              <a:srgbClr val="E3E7EC"/>
+            </a:solidFill>
+          </a:ln>
+        </p:spPr>
+        <p:style>
+          <a:lnRef idx="1">
+            <a:schemeClr val="accent1"/>
+          </a:lnRef>
+          <a:fillRef idx="3">
+            <a:schemeClr val="accent1"/>
+          </a:fillRef>
+          <a:effectRef idx="2">
+            <a:schemeClr val="accent1"/>
+          </a:effectRef>
+          <a:fontRef idx="minor">
+            <a:schemeClr val="lt1"/>
+          </a:fontRef>
+        </p:style>
+        <p:txBody>
+          <a:bodyPr rtlCol="0" anchor="ctr"/>
+          <a:lstStyle/>
+          <a:p>
+            <a:pPr algn="ctr">
+              <a:defRPr>
+                <a:latin typeface="Inter"/>
+              </a:defRPr>
+            </a:pPr>
+          </a:p>
+        </p:txBody>
+      </p:sp>
+      <p:sp>
+        <p:nvSpPr>
+          <p:cNvPr id="13" name="TextBox 12"/>
+          <p:cNvSpPr txBox="1"/>
+          <p:nvPr/>
+        </p:nvSpPr>
+        <p:spPr>
+          <a:xfrm>
+            <a:off x="640080" y="6501384"/>
+            <a:ext cx="4297680" cy="146304"/>
+          </a:xfrm>
+          <a:prstGeom prst="rect">
+            <a:avLst/>
+          </a:prstGeom>
+          <a:noFill/>
+        </p:spPr>
+        <p:txBody>
+          <a:bodyPr wrap="none" lIns="9144" rIns="9144" tIns="9144" bIns="9144" anchor="t">
+            <a:spAutoFit/>
+          </a:bodyPr>
+          <a:lstStyle/>
+          <a:p>
+            <a:pPr algn="l">
+              <a:spcAft>
+                <a:spcPts val="0"/>
+              </a:spcAft>
+              <a:defRPr sz="650" b="0">
+                <a:solidFill>
+                  <a:srgbClr val="8A94A1"/>
+                </a:solidFill>
+                <a:latin typeface="Inter"/>
+              </a:defRPr>
+            </a:pPr>
+            <a:r>
+              <a:rPr>
+                <a:latin typeface="Inter"/>
+              </a:rPr>
+              <a:t>Sources: S1</a:t>
+            </a:r>
+          </a:p>
+        </p:txBody>
+      </p:sp>
+      <p:sp>
+        <p:nvSpPr>
+          <p:cNvPr id="14" name="TextBox 13"/>
+          <p:cNvSpPr txBox="1"/>
+          <p:nvPr/>
+        </p:nvSpPr>
+        <p:spPr>
+          <a:xfrm>
+            <a:off x="4480560" y="6501384"/>
+            <a:ext cx="5303520" cy="146304"/>
+          </a:xfrm>
+          <a:prstGeom prst="rect">
+            <a:avLst/>
+          </a:prstGeom>
+          <a:noFill/>
+        </p:spPr>
+        <p:txBody>
+          <a:bodyPr wrap="none" lIns="9144" rIns="9144" tIns="9144" bIns="9144" anchor="t">
+            <a:spAutoFit/>
+          </a:bodyPr>
+          <a:lstStyle/>
+          <a:p>
+            <a:pPr algn="ctr">
+              <a:spcAft>
+                <a:spcPts val="0"/>
+              </a:spcAft>
+              <a:defRPr sz="650" b="0">
+                <a:solidFill>
+                  <a:srgbClr val="8A94A1"/>
+                </a:solidFill>
+                <a:latin typeface="Inter"/>
+              </a:defRPr>
+            </a:pPr>
+            <a:r>
+              <a:rPr>
+                <a:latin typeface="Inter"/>
+              </a:rPr>
+              <a:t>Confidential — prepared for internal investment use · Data as of 2025-12-31</a:t>
+            </a:r>
+          </a:p>
+        </p:txBody>
+      </p:sp>
+      <p:sp>
+        <p:nvSpPr>
+          <p:cNvPr id="15" name="TextBox 14"/>
+          <p:cNvSpPr txBox="1"/>
+          <p:nvPr/>
+        </p:nvSpPr>
+        <p:spPr>
+          <a:xfrm>
+            <a:off x="10287000" y="6501384"/>
+            <a:ext cx="1261872" cy="146304"/>
+          </a:xfrm>
+          <a:prstGeom prst="rect">
+            <a:avLst/>
+          </a:prstGeom>
+          <a:noFill/>
+        </p:spPr>
+        <p:txBody>
+          <a:bodyPr wrap="none" lIns="9144" rIns="9144" tIns="9144" bIns="9144" anchor="t">
+            <a:spAutoFit/>
+          </a:bodyPr>
+          <a:lstStyle/>
+          <a:p>
+            <a:pPr algn="r">
+              <a:spcAft>
+                <a:spcPts val="0"/>
+              </a:spcAft>
+              <a:defRPr sz="650" b="0">
+                <a:solidFill>
+                  <a:srgbClr val="8A94A1"/>
+                </a:solidFill>
+                <a:latin typeface="Inter"/>
+              </a:defRPr>
+            </a:pPr>
+            <a:r>
+              <a:rPr>
+                <a:latin typeface="Inter"/>
+              </a:rPr>
+              <a:t>9</a:t>
             </a:r>
           </a:p>
         </p:txBody>

</xml_diff>

<commit_message>
feat: release GradientCIO plugin 5.2.0 (#37)
Co-authored-by: shbryx <sbryant@gradientao.com>
Co-authored-by: Cursor <cursoragent@cursor.com>
</commit_message>
<xml_diff>
--- a/plugins/gradient-cio/assets/examples/gradient-idd-manager-performance-compare.pptx
+++ b/plugins/gradient-cio/assets/examples/gradient-idd-manager-performance-compare.pptx
@@ -13,6 +13,7 @@
     <ns0:sldId id="261" ns1:id="rId12"/>
     <ns0:sldId id="262" ns1:id="rId13"/>
     <ns0:sldId id="263" ns1:id="rId14"/>
+    <ns0:sldId id="264" ns1:id="rId15"/>
   </ns0:sldIdLst>
   <ns0:sldSz cx="12191695" cy="6858000" type="screen16x9"/>
   <ns0:notesSz cx="6858000" cy="9144000"/>
@@ -8350,7 +8351,7 @@
               <a:rPr>
                 <a:latin typeface="Inter"/>
               </a:rPr>
-              <a:t>Appendix A — Sources and methods</a:t>
+              <a:t>Appendix — Sources and methods</a:t>
             </a:r>
           </a:p>
         </p:txBody>
@@ -8490,7 +8491,7 @@
               <a:rPr>
                 <a:latin typeface="Inter"/>
               </a:rPr>
-              <a:t>07</a:t>
+              <a:t>A</a:t>
             </a:r>
           </a:p>
         </p:txBody>
@@ -8515,8 +8516,14 @@
               </a:tblPr>
               <a:tblGrid>
                 <a:gridCol w="2011680"/>
-                <a:gridCol w="4448556"/>
-                <a:gridCol w="4448556"/>
+                <a:gridCol w="1112139"/>
+                <a:gridCol w="1112139"/>
+                <a:gridCol w="1112139"/>
+                <a:gridCol w="1112139"/>
+                <a:gridCol w="1112139"/>
+                <a:gridCol w="1112139"/>
+                <a:gridCol w="1112139"/>
+                <a:gridCol w="1112139"/>
               </a:tblGrid>
               <a:tr h="584831">
                 <a:tc>
@@ -8590,7 +8597,169 @@
                         <a:rPr>
                           <a:latin typeface="Inter"/>
                         </a:rPr>
-                        <a:t>Tool</a:t>
+                        <a:t>Basis</a:t>
+                      </a:r>
+                    </a:p>
+                  </a:txBody>
+                  <a:tcPr marL="54864" marR="54864" marT="27432" marB="27432" anchor="ctr">
+                    <a:solidFill>
+                      <a:srgbClr val="0D1117"/>
+                    </a:solidFill>
+                  </a:tcPr>
+                </a:tc>
+                <a:tc>
+                  <a:txBody>
+                    <a:bodyPr/>
+                    <a:lstStyle/>
+                    <a:p>
+                      <a:pPr>
+                        <a:defRPr sz="750" b="1">
+                          <a:solidFill>
+                            <a:srgbClr val="FFFFFF"/>
+                          </a:solidFill>
+                          <a:latin typeface="Inter"/>
+                        </a:defRPr>
+                      </a:pPr>
+                      <a:r>
+                        <a:rPr>
+                          <a:latin typeface="Inter"/>
+                        </a:rPr>
+                        <a:t>Tool / view</a:t>
+                      </a:r>
+                    </a:p>
+                  </a:txBody>
+                  <a:tcPr marL="54864" marR="54864" marT="27432" marB="27432" anchor="ctr">
+                    <a:solidFill>
+                      <a:srgbClr val="0D1117"/>
+                    </a:solidFill>
+                  </a:tcPr>
+                </a:tc>
+                <a:tc>
+                  <a:txBody>
+                    <a:bodyPr/>
+                    <a:lstStyle/>
+                    <a:p>
+                      <a:pPr>
+                        <a:defRPr sz="750" b="1">
+                          <a:solidFill>
+                            <a:srgbClr val="FFFFFF"/>
+                          </a:solidFill>
+                          <a:latin typeface="Inter"/>
+                        </a:defRPr>
+                      </a:pPr>
+                      <a:r>
+                        <a:rPr>
+                          <a:latin typeface="Inter"/>
+                        </a:rPr>
+                        <a:t>Key parameters</a:t>
+                      </a:r>
+                    </a:p>
+                  </a:txBody>
+                  <a:tcPr marL="54864" marR="54864" marT="27432" marB="27432" anchor="ctr">
+                    <a:solidFill>
+                      <a:srgbClr val="0D1117"/>
+                    </a:solidFill>
+                  </a:tcPr>
+                </a:tc>
+                <a:tc>
+                  <a:txBody>
+                    <a:bodyPr/>
+                    <a:lstStyle/>
+                    <a:p>
+                      <a:pPr>
+                        <a:defRPr sz="750" b="1">
+                          <a:solidFill>
+                            <a:srgbClr val="FFFFFF"/>
+                          </a:solidFill>
+                          <a:latin typeface="Inter"/>
+                        </a:defRPr>
+                      </a:pPr>
+                      <a:r>
+                        <a:rPr>
+                          <a:latin typeface="Inter"/>
+                        </a:rPr>
+                        <a:t>As of</a:t>
+                      </a:r>
+                    </a:p>
+                  </a:txBody>
+                  <a:tcPr marL="54864" marR="54864" marT="27432" marB="27432" anchor="ctr">
+                    <a:solidFill>
+                      <a:srgbClr val="0D1117"/>
+                    </a:solidFill>
+                  </a:tcPr>
+                </a:tc>
+                <a:tc>
+                  <a:txBody>
+                    <a:bodyPr/>
+                    <a:lstStyle/>
+                    <a:p>
+                      <a:pPr>
+                        <a:defRPr sz="750" b="1">
+                          <a:solidFill>
+                            <a:srgbClr val="FFFFFF"/>
+                          </a:solidFill>
+                          <a:latin typeface="Inter"/>
+                        </a:defRPr>
+                      </a:pPr>
+                      <a:r>
+                        <a:rPr>
+                          <a:latin typeface="Inter"/>
+                        </a:rPr>
+                        <a:t>Data scope</a:t>
+                      </a:r>
+                    </a:p>
+                  </a:txBody>
+                  <a:tcPr marL="54864" marR="54864" marT="27432" marB="27432" anchor="ctr">
+                    <a:solidFill>
+                      <a:srgbClr val="0D1117"/>
+                    </a:solidFill>
+                  </a:tcPr>
+                </a:tc>
+                <a:tc>
+                  <a:txBody>
+                    <a:bodyPr/>
+                    <a:lstStyle/>
+                    <a:p>
+                      <a:pPr>
+                        <a:defRPr sz="750" b="1">
+                          <a:solidFill>
+                            <a:srgbClr val="FFFFFF"/>
+                          </a:solidFill>
+                          <a:latin typeface="Inter"/>
+                        </a:defRPr>
+                      </a:pPr>
+                      <a:r>
+                        <a:rPr>
+                          <a:latin typeface="Inter"/>
+                        </a:rPr>
+                        <a:t>Validation</a:t>
+                      </a:r>
+                    </a:p>
+                  </a:txBody>
+                  <a:tcPr marL="54864" marR="54864" marT="27432" marB="27432" anchor="ctr">
+                    <a:solidFill>
+                      <a:srgbClr val="0D1117"/>
+                    </a:solidFill>
+                  </a:tcPr>
+                </a:tc>
+                <a:tc>
+                  <a:txBody>
+                    <a:bodyPr/>
+                    <a:lstStyle/>
+                    <a:p>
+                      <a:pPr>
+                        <a:defRPr sz="750" b="1">
+                          <a:solidFill>
+                            <a:srgbClr val="FFFFFF"/>
+                          </a:solidFill>
+                          <a:latin typeface="Inter"/>
+                        </a:defRPr>
+                      </a:pPr>
+                      <a:r>
+                        <a:rPr>
+                          <a:latin typeface="Inter"/>
+                        </a:rPr>
+                        <a:t>Digest</a:t>
                       </a:r>
                     </a:p>
                   </a:txBody>
@@ -8608,7 +8777,7 @@
                     <a:lstStyle/>
                     <a:p>
                       <a:pPr>
-                        <a:defRPr sz="800" b="1">
+                        <a:defRPr sz="650" b="1">
                           <a:solidFill>
                             <a:srgbClr val="0D1117"/>
                           </a:solidFill>
@@ -8635,7 +8804,7 @@
                     <a:lstStyle/>
                     <a:p>
                       <a:pPr>
-                        <a:defRPr sz="800" b="0">
+                        <a:defRPr sz="650" b="0">
                           <a:solidFill>
                             <a:srgbClr val="0D1117"/>
                           </a:solidFill>
@@ -8662,7 +8831,34 @@
                     <a:lstStyle/>
                     <a:p>
                       <a:pPr>
-                        <a:defRPr sz="800" b="0">
+                        <a:defRPr sz="650" b="0">
+                          <a:solidFill>
+                            <a:srgbClr val="0D1117"/>
+                          </a:solidFill>
+                          <a:latin typeface="Inter"/>
+                        </a:defRPr>
+                      </a:pPr>
+                      <a:r>
+                        <a:rPr>
+                          <a:latin typeface="Inter"/>
+                        </a:rPr>
+                        <a:t>gradient_tool</a:t>
+                      </a:r>
+                    </a:p>
+                  </a:txBody>
+                  <a:tcPr marL="54864" marR="54864" marT="27432" marB="27432" anchor="ctr">
+                    <a:solidFill>
+                      <a:srgbClr val="FFFFFF"/>
+                    </a:solidFill>
+                  </a:tcPr>
+                </a:tc>
+                <a:tc>
+                  <a:txBody>
+                    <a:bodyPr/>
+                    <a:lstStyle/>
+                    <a:p>
+                      <a:pPr>
+                        <a:defRPr sz="650" b="0">
                           <a:solidFill>
                             <a:srgbClr val="0D1117"/>
                           </a:solidFill>
@@ -8683,6 +8879,141 @@
                     </a:solidFill>
                   </a:tcPr>
                 </a:tc>
+                <a:tc>
+                  <a:txBody>
+                    <a:bodyPr/>
+                    <a:lstStyle/>
+                    <a:p>
+                      <a:pPr>
+                        <a:defRPr sz="650" b="0">
+                          <a:solidFill>
+                            <a:srgbClr val="0D1117"/>
+                          </a:solidFill>
+                          <a:latin typeface="Inter"/>
+                        </a:defRPr>
+                      </a:pPr>
+                      <a:r>
+                        <a:rPr>
+                          <a:latin typeface="Inter"/>
+                        </a:rPr>
+                        <a:t>fixture=true</a:t>
+                      </a:r>
+                    </a:p>
+                  </a:txBody>
+                  <a:tcPr marL="54864" marR="54864" marT="27432" marB="27432" anchor="ctr">
+                    <a:solidFill>
+                      <a:srgbClr val="FFFFFF"/>
+                    </a:solidFill>
+                  </a:tcPr>
+                </a:tc>
+                <a:tc>
+                  <a:txBody>
+                    <a:bodyPr/>
+                    <a:lstStyle/>
+                    <a:p>
+                      <a:pPr>
+                        <a:defRPr sz="650" b="0">
+                          <a:solidFill>
+                            <a:srgbClr val="0D1117"/>
+                          </a:solidFill>
+                          <a:latin typeface="Inter"/>
+                        </a:defRPr>
+                      </a:pPr>
+                      <a:r>
+                        <a:rPr>
+                          <a:latin typeface="Inter"/>
+                        </a:rPr>
+                        <a:t>2025-12-31</a:t>
+                      </a:r>
+                    </a:p>
+                  </a:txBody>
+                  <a:tcPr marL="54864" marR="54864" marT="27432" marB="27432" anchor="ctr">
+                    <a:solidFill>
+                      <a:srgbClr val="FFFFFF"/>
+                    </a:solidFill>
+                  </a:tcPr>
+                </a:tc>
+                <a:tc>
+                  <a:txBody>
+                    <a:bodyPr/>
+                    <a:lstStyle/>
+                    <a:p>
+                      <a:pPr>
+                        <a:defRPr sz="650" b="0">
+                          <a:solidFill>
+                            <a:srgbClr val="0D1117"/>
+                          </a:solidFill>
+                          <a:latin typeface="Inter"/>
+                        </a:defRPr>
+                      </a:pPr>
+                      <a:r>
+                        <a:rPr>
+                          <a:latin typeface="Inter"/>
+                        </a:rPr>
+                        <a:t>Gradient-governed TEST evidence</a:t>
+                      </a:r>
+                    </a:p>
+                  </a:txBody>
+                  <a:tcPr marL="54864" marR="54864" marT="27432" marB="27432" anchor="ctr">
+                    <a:solidFill>
+                      <a:srgbClr val="FFFFFF"/>
+                    </a:solidFill>
+                  </a:tcPr>
+                </a:tc>
+                <a:tc>
+                  <a:txBody>
+                    <a:bodyPr/>
+                    <a:lstStyle/>
+                    <a:p>
+                      <a:pPr>
+                        <a:defRPr sz="650" b="0">
+                          <a:solidFill>
+                            <a:srgbClr val="0D1117"/>
+                          </a:solidFill>
+                          <a:latin typeface="Inter"/>
+                        </a:defRPr>
+                      </a:pPr>
+                      <a:r>
+                        <a:rPr>
+                          <a:latin typeface="Inter"/>
+                        </a:rPr>
+                        <a:t>passed</a:t>
+                      </a:r>
+                    </a:p>
+                  </a:txBody>
+                  <a:tcPr marL="54864" marR="54864" marT="27432" marB="27432" anchor="ctr">
+                    <a:solidFill>
+                      <a:srgbClr val="FFFFFF"/>
+                    </a:solidFill>
+                  </a:tcPr>
+                </a:tc>
+                <a:tc>
+                  <a:txBody>
+                    <a:bodyPr/>
+                    <a:lstStyle/>
+                    <a:p>
+                      <a:pPr>
+                        <a:defRPr sz="650" b="0">
+                          <a:solidFill>
+                            <a:srgbClr val="0D1117"/>
+                          </a:solidFill>
+                          <a:latin typeface="Inter"/>
+                        </a:defRPr>
+                      </a:pPr>
+                      <a:r>
+                        <a:rPr>
+                          <a:latin typeface="Inter"/>
+                        </a:rPr>
+                        <a:t>sha256:aaaaaaaaaaaaaaaaaaaaaaaaaaaaaaaaaaaaaaaaaaaaaaaaaaaaaaaaaaaaaaaa</a:t>
+                      </a:r>
+                    </a:p>
+                  </a:txBody>
+                  <a:tcPr marL="54864" marR="54864" marT="27432" marB="27432" anchor="ctr">
+                    <a:solidFill>
+                      <a:srgbClr val="FFFFFF"/>
+                    </a:solidFill>
+                  </a:tcPr>
+                </a:tc>
               </a:tr>
             </a:tbl>
           </a:graphicData>
@@ -9223,6 +9554,654 @@
                 <a:latin typeface="Inter"/>
               </a:rPr>
               <a:t>8</a:t>
+            </a:r>
+          </a:p>
+        </p:txBody>
+      </p:sp>
+    </p:spTree>
+  </p:cSld>
+  <p:clrMapOvr>
+    <a:masterClrMapping/>
+  </p:clrMapOvr>
+</p:sld>
+</file>
+
+<file path=ppt/slides/slide9.xml><?xml version="1.0" encoding="utf-8"?>
+<p:sld xmlns:a="http://schemas.openxmlformats.org/drawingml/2006/main" xmlns:p="http://schemas.openxmlformats.org/presentationml/2006/main" xmlns:r="http://schemas.openxmlformats.org/officeDocument/2006/relationships">
+  <p:cSld>
+    <p:spTree>
+      <p:nvGrpSpPr>
+        <p:cNvPr id="1" name=""/>
+        <p:cNvGrpSpPr/>
+        <p:nvPr/>
+      </p:nvGrpSpPr>
+      <p:grpSpPr/>
+      <p:sp>
+        <p:nvSpPr>
+          <p:cNvPr id="2" name="Rectangle 1"/>
+          <p:cNvSpPr/>
+          <p:nvPr/>
+        </p:nvSpPr>
+        <p:spPr>
+          <a:xfrm>
+            <a:off x="0" y="0"/>
+            <a:ext cx="12191695" cy="6858000"/>
+          </a:xfrm>
+          <a:prstGeom prst="rect">
+            <a:avLst/>
+          </a:prstGeom>
+          <a:solidFill>
+            <a:srgbClr val="FFFFFF"/>
+          </a:solidFill>
+          <a:ln>
+            <a:solidFill>
+              <a:srgbClr val="FFFFFF"/>
+            </a:solidFill>
+          </a:ln>
+        </p:spPr>
+        <p:style>
+          <a:lnRef idx="1">
+            <a:schemeClr val="accent1"/>
+          </a:lnRef>
+          <a:fillRef idx="3">
+            <a:schemeClr val="accent1"/>
+          </a:fillRef>
+          <a:effectRef idx="2">
+            <a:schemeClr val="accent1"/>
+          </a:effectRef>
+          <a:fontRef idx="minor">
+            <a:schemeClr val="lt1"/>
+          </a:fontRef>
+        </p:style>
+        <p:txBody>
+          <a:bodyPr rtlCol="0" anchor="ctr"/>
+          <a:lstStyle/>
+          <a:p>
+            <a:pPr algn="ctr">
+              <a:defRPr>
+                <a:latin typeface="Inter"/>
+              </a:defRPr>
+            </a:pPr>
+          </a:p>
+        </p:txBody>
+      </p:sp>
+      <p:sp>
+        <p:nvSpPr>
+          <p:cNvPr id="3" name="TextBox 2"/>
+          <p:cNvSpPr txBox="1"/>
+          <p:nvPr/>
+        </p:nvSpPr>
+        <p:spPr>
+          <a:xfrm>
+            <a:off x="640080" y="329184"/>
+            <a:ext cx="9875520" cy="182880"/>
+          </a:xfrm>
+          <a:prstGeom prst="rect">
+            <a:avLst/>
+          </a:prstGeom>
+          <a:noFill/>
+        </p:spPr>
+        <p:txBody>
+          <a:bodyPr wrap="none" lIns="9144" rIns="9144" tIns="9144" bIns="9144" anchor="t">
+            <a:spAutoFit/>
+          </a:bodyPr>
+          <a:lstStyle/>
+          <a:p>
+            <a:pPr algn="l">
+              <a:spcAft>
+                <a:spcPts val="0"/>
+              </a:spcAft>
+              <a:defRPr sz="750" b="1">
+                <a:solidFill>
+                  <a:srgbClr val="4F6B00"/>
+                </a:solidFill>
+                <a:latin typeface="Inter"/>
+              </a:defRPr>
+            </a:pPr>
+            <a:r>
+              <a:rPr>
+                <a:latin typeface="Inter"/>
+              </a:rPr>
+              <a:t>SAVED FICTIONAL TEST EVIDENCE</a:t>
+            </a:r>
+          </a:p>
+        </p:txBody>
+      </p:sp>
+      <p:sp>
+        <p:nvSpPr>
+          <p:cNvPr id="4" name="TextBox 3"/>
+          <p:cNvSpPr txBox="1"/>
+          <p:nvPr/>
+        </p:nvSpPr>
+        <p:spPr>
+          <a:xfrm>
+            <a:off x="640080" y="566928"/>
+            <a:ext cx="10058400" cy="530352"/>
+          </a:xfrm>
+          <a:prstGeom prst="rect">
+            <a:avLst/>
+          </a:prstGeom>
+          <a:noFill/>
+        </p:spPr>
+        <p:txBody>
+          <a:bodyPr wrap="none" lIns="9144" rIns="9144" tIns="9144" bIns="9144" anchor="t">
+            <a:spAutoFit/>
+          </a:bodyPr>
+          <a:lstStyle/>
+          <a:p>
+            <a:pPr algn="l">
+              <a:spcAft>
+                <a:spcPts val="0"/>
+              </a:spcAft>
+              <a:defRPr sz="2300" b="1">
+                <a:solidFill>
+                  <a:srgbClr val="0D1117"/>
+                </a:solidFill>
+                <a:latin typeface="Inter"/>
+              </a:defRPr>
+            </a:pPr>
+            <a:r>
+              <a:rPr>
+                <a:latin typeface="Inter"/>
+              </a:rPr>
+              <a:t>Appendix — Sources and methods — continued</a:t>
+            </a:r>
+          </a:p>
+        </p:txBody>
+      </p:sp>
+      <p:sp>
+        <p:nvSpPr>
+          <p:cNvPr id="5" name="Rectangle 4"/>
+          <p:cNvSpPr/>
+          <p:nvPr/>
+        </p:nvSpPr>
+        <p:spPr>
+          <a:xfrm>
+            <a:off x="640080" y="1115568"/>
+            <a:ext cx="10908792" cy="18288"/>
+          </a:xfrm>
+          <a:prstGeom prst="rect">
+            <a:avLst/>
+          </a:prstGeom>
+          <a:solidFill>
+            <a:srgbClr val="0D1117"/>
+          </a:solidFill>
+          <a:ln>
+            <a:solidFill>
+              <a:srgbClr val="0D1117"/>
+            </a:solidFill>
+          </a:ln>
+        </p:spPr>
+        <p:style>
+          <a:lnRef idx="1">
+            <a:schemeClr val="accent1"/>
+          </a:lnRef>
+          <a:fillRef idx="3">
+            <a:schemeClr val="accent1"/>
+          </a:fillRef>
+          <a:effectRef idx="2">
+            <a:schemeClr val="accent1"/>
+          </a:effectRef>
+          <a:fontRef idx="minor">
+            <a:schemeClr val="lt1"/>
+          </a:fontRef>
+        </p:style>
+        <p:txBody>
+          <a:bodyPr rtlCol="0" anchor="ctr"/>
+          <a:lstStyle/>
+          <a:p>
+            <a:pPr algn="ctr">
+              <a:defRPr>
+                <a:latin typeface="Inter"/>
+              </a:defRPr>
+            </a:pPr>
+          </a:p>
+        </p:txBody>
+      </p:sp>
+      <p:sp>
+        <p:nvSpPr>
+          <p:cNvPr id="6" name="Rectangle 5"/>
+          <p:cNvSpPr/>
+          <p:nvPr/>
+        </p:nvSpPr>
+        <p:spPr>
+          <a:xfrm>
+            <a:off x="11018520" y="502920"/>
+            <a:ext cx="530352" cy="393192"/>
+          </a:xfrm>
+          <a:prstGeom prst="rect">
+            <a:avLst/>
+          </a:prstGeom>
+          <a:solidFill>
+            <a:srgbClr val="9AA5B1"/>
+          </a:solidFill>
+          <a:ln>
+            <a:solidFill>
+              <a:srgbClr val="9AA5B1"/>
+            </a:solidFill>
+          </a:ln>
+        </p:spPr>
+        <p:style>
+          <a:lnRef idx="1">
+            <a:schemeClr val="accent1"/>
+          </a:lnRef>
+          <a:fillRef idx="3">
+            <a:schemeClr val="accent1"/>
+          </a:fillRef>
+          <a:effectRef idx="2">
+            <a:schemeClr val="accent1"/>
+          </a:effectRef>
+          <a:fontRef idx="minor">
+            <a:schemeClr val="lt1"/>
+          </a:fontRef>
+        </p:style>
+        <p:txBody>
+          <a:bodyPr rtlCol="0" anchor="ctr"/>
+          <a:lstStyle/>
+          <a:p>
+            <a:pPr algn="ctr">
+              <a:defRPr>
+                <a:latin typeface="Inter"/>
+              </a:defRPr>
+            </a:pPr>
+          </a:p>
+        </p:txBody>
+      </p:sp>
+      <p:sp>
+        <p:nvSpPr>
+          <p:cNvPr id="7" name="TextBox 6"/>
+          <p:cNvSpPr txBox="1"/>
+          <p:nvPr/>
+        </p:nvSpPr>
+        <p:spPr>
+          <a:xfrm>
+            <a:off x="11045952" y="557784"/>
+            <a:ext cx="475488" cy="182880"/>
+          </a:xfrm>
+          <a:prstGeom prst="rect">
+            <a:avLst/>
+          </a:prstGeom>
+          <a:noFill/>
+        </p:spPr>
+        <p:txBody>
+          <a:bodyPr wrap="none" lIns="9144" rIns="9144" tIns="9144" bIns="9144" anchor="t">
+            <a:spAutoFit/>
+          </a:bodyPr>
+          <a:lstStyle/>
+          <a:p>
+            <a:pPr algn="ctr">
+              <a:spcAft>
+                <a:spcPts val="0"/>
+              </a:spcAft>
+              <a:defRPr sz="1000" b="1">
+                <a:solidFill>
+                  <a:srgbClr val="0D1117"/>
+                </a:solidFill>
+                <a:latin typeface="Inter"/>
+              </a:defRPr>
+            </a:pPr>
+            <a:r>
+              <a:rPr>
+                <a:latin typeface="Inter"/>
+              </a:rPr>
+              <a:t>A</a:t>
+            </a:r>
+          </a:p>
+        </p:txBody>
+      </p:sp>
+      <p:sp>
+        <p:nvSpPr>
+          <p:cNvPr id="8" name="Rectangle 7"/>
+          <p:cNvSpPr/>
+          <p:nvPr/>
+        </p:nvSpPr>
+        <p:spPr>
+          <a:xfrm>
+            <a:off x="640080" y="1325880"/>
+            <a:ext cx="10908792" cy="4892040"/>
+          </a:xfrm>
+          <a:prstGeom prst="rect">
+            <a:avLst/>
+          </a:prstGeom>
+          <a:solidFill>
+            <a:srgbClr val="F5F7F9"/>
+          </a:solidFill>
+          <a:ln>
+            <a:solidFill>
+              <a:srgbClr val="E3E7EC"/>
+            </a:solidFill>
+          </a:ln>
+        </p:spPr>
+        <p:style>
+          <a:lnRef idx="1">
+            <a:schemeClr val="accent1"/>
+          </a:lnRef>
+          <a:fillRef idx="3">
+            <a:schemeClr val="accent1"/>
+          </a:fillRef>
+          <a:effectRef idx="2">
+            <a:schemeClr val="accent1"/>
+          </a:effectRef>
+          <a:fontRef idx="minor">
+            <a:schemeClr val="lt1"/>
+          </a:fontRef>
+        </p:style>
+        <p:txBody>
+          <a:bodyPr rtlCol="0" anchor="ctr"/>
+          <a:lstStyle/>
+          <a:p>
+            <a:pPr algn="ctr">
+              <a:defRPr>
+                <a:latin typeface="Inter"/>
+              </a:defRPr>
+            </a:pPr>
+          </a:p>
+        </p:txBody>
+      </p:sp>
+      <p:sp>
+        <p:nvSpPr>
+          <p:cNvPr id="9" name="Rectangle 8"/>
+          <p:cNvSpPr/>
+          <p:nvPr/>
+        </p:nvSpPr>
+        <p:spPr>
+          <a:xfrm>
+            <a:off x="640080" y="1325880"/>
+            <a:ext cx="54864" cy="4892040"/>
+          </a:xfrm>
+          <a:prstGeom prst="rect">
+            <a:avLst/>
+          </a:prstGeom>
+          <a:solidFill>
+            <a:srgbClr val="0D1117"/>
+          </a:solidFill>
+          <a:ln>
+            <a:solidFill>
+              <a:srgbClr val="0D1117"/>
+            </a:solidFill>
+          </a:ln>
+        </p:spPr>
+        <p:style>
+          <a:lnRef idx="1">
+            <a:schemeClr val="accent1"/>
+          </a:lnRef>
+          <a:fillRef idx="3">
+            <a:schemeClr val="accent1"/>
+          </a:fillRef>
+          <a:effectRef idx="2">
+            <a:schemeClr val="accent1"/>
+          </a:effectRef>
+          <a:fontRef idx="minor">
+            <a:schemeClr val="lt1"/>
+          </a:fontRef>
+        </p:style>
+        <p:txBody>
+          <a:bodyPr rtlCol="0" anchor="ctr"/>
+          <a:lstStyle/>
+          <a:p>
+            <a:pPr algn="ctr">
+              <a:defRPr>
+                <a:latin typeface="Inter"/>
+              </a:defRPr>
+            </a:pPr>
+          </a:p>
+        </p:txBody>
+      </p:sp>
+      <p:sp>
+        <p:nvSpPr>
+          <p:cNvPr id="10" name="TextBox 9"/>
+          <p:cNvSpPr txBox="1"/>
+          <p:nvPr/>
+        </p:nvSpPr>
+        <p:spPr>
+          <a:xfrm>
+            <a:off x="804671" y="1435607"/>
+            <a:ext cx="10616184" cy="228600"/>
+          </a:xfrm>
+          <a:prstGeom prst="rect">
+            <a:avLst/>
+          </a:prstGeom>
+          <a:noFill/>
+        </p:spPr>
+        <p:txBody>
+          <a:bodyPr wrap="none" lIns="9144" rIns="9144" tIns="9144" bIns="9144" anchor="t">
+            <a:spAutoFit/>
+          </a:bodyPr>
+          <a:lstStyle/>
+          <a:p>
+            <a:pPr algn="l">
+              <a:spcAft>
+                <a:spcPts val="0"/>
+              </a:spcAft>
+              <a:defRPr sz="1000" b="1">
+                <a:solidFill>
+                  <a:srgbClr val="0D1117"/>
+                </a:solidFill>
+                <a:latin typeface="Inter"/>
+              </a:defRPr>
+            </a:pPr>
+            <a:r>
+              <a:rPr>
+                <a:latin typeface="Inter"/>
+              </a:rPr>
+              <a:t>Metric and digest interpretation</a:t>
+            </a:r>
+          </a:p>
+        </p:txBody>
+      </p:sp>
+      <p:sp>
+        <p:nvSpPr>
+          <p:cNvPr id="11" name="TextBox 10"/>
+          <p:cNvSpPr txBox="1"/>
+          <p:nvPr/>
+        </p:nvSpPr>
+        <p:spPr>
+          <a:xfrm>
+            <a:off x="804671" y="1719072"/>
+            <a:ext cx="10616184" cy="4407408"/>
+          </a:xfrm>
+          <a:prstGeom prst="rect">
+            <a:avLst/>
+          </a:prstGeom>
+          <a:noFill/>
+        </p:spPr>
+        <p:txBody>
+          <a:bodyPr wrap="none" lIns="9144" rIns="9144" tIns="9144" bIns="9144" anchor="t">
+            <a:spAutoFit/>
+          </a:bodyPr>
+          <a:lstStyle/>
+          <a:p>
+            <a:pPr algn="l">
+              <a:spcAft>
+                <a:spcPts val="0"/>
+              </a:spcAft>
+              <a:defRPr sz="950" b="0">
+                <a:solidFill>
+                  <a:srgbClr val="4A5563"/>
+                </a:solidFill>
+                <a:latin typeface="Inter"/>
+              </a:defRPr>
+            </a:pPr>
+            <a:r>
+              <a:rPr>
+                <a:latin typeface="Inter"/>
+              </a:rPr>
+              <a:t>Historical claims must use returned realized metrics with their exact periods, while path-distribution statistics must remain explicitly simulated [S1]. Successful tool evidence records the SHA-256 digest of the saved response; a failed call instead uses the typed no-payload sentinel and preserves its error code and request ID in the validation field. These controls prevent simulated statistics or request identifiers from being presented as observed evidence. The source row also retains the tool name, key parameters, as-of date and data scope so a reviewer can reproduce the evidence boundary without treating an unavailable payload as a successful observation. Advisory benchmark selections remain visibly advisory throughout the report and handoff. This distinction tells reviewers which comparisons are server-matched and which still require independent benchmark confirmation.</a:t>
+            </a:r>
+          </a:p>
+        </p:txBody>
+      </p:sp>
+      <p:sp>
+        <p:nvSpPr>
+          <p:cNvPr id="12" name="Rectangle 11"/>
+          <p:cNvSpPr/>
+          <p:nvPr/>
+        </p:nvSpPr>
+        <p:spPr>
+          <a:xfrm>
+            <a:off x="640080" y="6446520"/>
+            <a:ext cx="10908792" cy="9144"/>
+          </a:xfrm>
+          <a:prstGeom prst="rect">
+            <a:avLst/>
+          </a:prstGeom>
+          <a:solidFill>
+            <a:srgbClr val="E3E7EC"/>
+          </a:solidFill>
+          <a:ln>
+            <a:solidFill>
+              <a:srgbClr val="E3E7EC"/>
+            </a:solidFill>
+          </a:ln>
+        </p:spPr>
+        <p:style>
+          <a:lnRef idx="1">
+            <a:schemeClr val="accent1"/>
+          </a:lnRef>
+          <a:fillRef idx="3">
+            <a:schemeClr val="accent1"/>
+          </a:fillRef>
+          <a:effectRef idx="2">
+            <a:schemeClr val="accent1"/>
+          </a:effectRef>
+          <a:fontRef idx="minor">
+            <a:schemeClr val="lt1"/>
+          </a:fontRef>
+        </p:style>
+        <p:txBody>
+          <a:bodyPr rtlCol="0" anchor="ctr"/>
+          <a:lstStyle/>
+          <a:p>
+            <a:pPr algn="ctr">
+              <a:defRPr>
+                <a:latin typeface="Inter"/>
+              </a:defRPr>
+            </a:pPr>
+          </a:p>
+        </p:txBody>
+      </p:sp>
+      <p:sp>
+        <p:nvSpPr>
+          <p:cNvPr id="13" name="TextBox 12"/>
+          <p:cNvSpPr txBox="1"/>
+          <p:nvPr/>
+        </p:nvSpPr>
+        <p:spPr>
+          <a:xfrm>
+            <a:off x="640080" y="6501384"/>
+            <a:ext cx="4297680" cy="146304"/>
+          </a:xfrm>
+          <a:prstGeom prst="rect">
+            <a:avLst/>
+          </a:prstGeom>
+          <a:noFill/>
+        </p:spPr>
+        <p:txBody>
+          <a:bodyPr wrap="none" lIns="9144" rIns="9144" tIns="9144" bIns="9144" anchor="t">
+            <a:spAutoFit/>
+          </a:bodyPr>
+          <a:lstStyle/>
+          <a:p>
+            <a:pPr algn="l">
+              <a:spcAft>
+                <a:spcPts val="0"/>
+              </a:spcAft>
+              <a:defRPr sz="650" b="0">
+                <a:solidFill>
+                  <a:srgbClr val="8A94A1"/>
+                </a:solidFill>
+                <a:latin typeface="Inter"/>
+              </a:defRPr>
+            </a:pPr>
+            <a:r>
+              <a:rPr>
+                <a:latin typeface="Inter"/>
+              </a:rPr>
+              <a:t>Sources: S1</a:t>
+            </a:r>
+          </a:p>
+        </p:txBody>
+      </p:sp>
+      <p:sp>
+        <p:nvSpPr>
+          <p:cNvPr id="14" name="TextBox 13"/>
+          <p:cNvSpPr txBox="1"/>
+          <p:nvPr/>
+        </p:nvSpPr>
+        <p:spPr>
+          <a:xfrm>
+            <a:off x="4480560" y="6501384"/>
+            <a:ext cx="5303520" cy="146304"/>
+          </a:xfrm>
+          <a:prstGeom prst="rect">
+            <a:avLst/>
+          </a:prstGeom>
+          <a:noFill/>
+        </p:spPr>
+        <p:txBody>
+          <a:bodyPr wrap="none" lIns="9144" rIns="9144" tIns="9144" bIns="9144" anchor="t">
+            <a:spAutoFit/>
+          </a:bodyPr>
+          <a:lstStyle/>
+          <a:p>
+            <a:pPr algn="ctr">
+              <a:spcAft>
+                <a:spcPts val="0"/>
+              </a:spcAft>
+              <a:defRPr sz="650" b="0">
+                <a:solidFill>
+                  <a:srgbClr val="8A94A1"/>
+                </a:solidFill>
+                <a:latin typeface="Inter"/>
+              </a:defRPr>
+            </a:pPr>
+            <a:r>
+              <a:rPr>
+                <a:latin typeface="Inter"/>
+              </a:rPr>
+              <a:t>Confidential — prepared for internal investment use · Data as of 2025-12-31</a:t>
+            </a:r>
+          </a:p>
+        </p:txBody>
+      </p:sp>
+      <p:sp>
+        <p:nvSpPr>
+          <p:cNvPr id="15" name="TextBox 14"/>
+          <p:cNvSpPr txBox="1"/>
+          <p:nvPr/>
+        </p:nvSpPr>
+        <p:spPr>
+          <a:xfrm>
+            <a:off x="10287000" y="6501384"/>
+            <a:ext cx="1261872" cy="146304"/>
+          </a:xfrm>
+          <a:prstGeom prst="rect">
+            <a:avLst/>
+          </a:prstGeom>
+          <a:noFill/>
+        </p:spPr>
+        <p:txBody>
+          <a:bodyPr wrap="none" lIns="9144" rIns="9144" tIns="9144" bIns="9144" anchor="t">
+            <a:spAutoFit/>
+          </a:bodyPr>
+          <a:lstStyle/>
+          <a:p>
+            <a:pPr algn="r">
+              <a:spcAft>
+                <a:spcPts val="0"/>
+              </a:spcAft>
+              <a:defRPr sz="650" b="0">
+                <a:solidFill>
+                  <a:srgbClr val="8A94A1"/>
+                </a:solidFill>
+                <a:latin typeface="Inter"/>
+              </a:defRPr>
+            </a:pPr>
+            <a:r>
+              <a:rPr>
+                <a:latin typeface="Inter"/>
+              </a:rPr>
+              <a:t>9</a:t>
             </a:r>
           </a:p>
         </p:txBody>

</xml_diff>

<commit_message>
feat: release GradientCIO plugin 5.7.0
Co-authored-by: Cursor <cursoragent@cursor.com>
</commit_message>
<xml_diff>
--- a/plugins/gradient-cio/assets/examples/gradient-idd-manager-performance-compare.pptx
+++ b/plugins/gradient-cio/assets/examples/gradient-idd-manager-performance-compare.pptx
@@ -2935,7 +2935,7 @@
         </p:nvSpPr>
         <p:spPr>
           <a:xfrm>
-            <a:off x="685800" y="1828800"/>
+            <a:off x="685800" y="1664208"/>
             <a:ext cx="9966960" cy="274320"/>
           </a:xfrm>
           <a:prstGeom prst="rect">
@@ -2953,7 +2953,7 @@
               <a:spcAft>
                 <a:spcPts val="0"/>
               </a:spcAft>
-              <a:defRPr sz="900" b="1">
+              <a:defRPr sz="850" b="1">
                 <a:solidFill>
                   <a:srgbClr val="C6F432"/>
                 </a:solidFill>
@@ -2977,7 +2977,7 @@
         </p:nvSpPr>
         <p:spPr>
           <a:xfrm>
-            <a:off x="685800" y="2176272"/>
+            <a:off x="685800" y="2011680"/>
             <a:ext cx="9966960" cy="1234440"/>
           </a:xfrm>
           <a:prstGeom prst="rect">
@@ -2995,7 +2995,7 @@
               <a:spcAft>
                 <a:spcPts val="0"/>
               </a:spcAft>
-              <a:defRPr sz="3400" b="1">
+              <a:defRPr sz="3300" b="1">
                 <a:solidFill>
                   <a:srgbClr val="FFFFFF"/>
                 </a:solidFill>
@@ -3006,7 +3006,7 @@
               <a:rPr>
                 <a:latin typeface="Inter"/>
               </a:rPr>
-              <a:t>Northstar Manager Comparison (TEST)</a:t>
+              <a:t>Northstar Manager Comparison</a:t>
             </a:r>
           </a:p>
         </p:txBody>
@@ -3019,8 +3019,8 @@
         </p:nvSpPr>
         <p:spPr>
           <a:xfrm>
-            <a:off x="685800" y="3456432"/>
-            <a:ext cx="9692640" cy="640080"/>
+            <a:off x="685800" y="3273552"/>
+            <a:ext cx="9692640" cy="594360"/>
           </a:xfrm>
           <a:prstGeom prst="rect">
             <a:avLst/>
@@ -3037,7 +3037,7 @@
               <a:spcAft>
                 <a:spcPts val="0"/>
               </a:spcAft>
-              <a:defRPr sz="1500" b="0">
+              <a:defRPr sz="1400" b="0">
                 <a:solidFill>
                   <a:srgbClr val="9AA5B1"/>
                 </a:solidFill>
@@ -3048,7 +3048,7 @@
               <a:rPr>
                 <a:latin typeface="Inter"/>
               </a:rPr>
-              <a:t>Governed return evidence</a:t>
+              <a:t>Comparative performance and benchmark assessment</a:t>
             </a:r>
           </a:p>
         </p:txBody>
@@ -3061,8 +3061,8 @@
         </p:nvSpPr>
         <p:spPr>
           <a:xfrm>
-            <a:off x="685800" y="4251960"/>
-            <a:ext cx="1005840" cy="54864"/>
+            <a:off x="685800" y="4005072"/>
+            <a:ext cx="822960" cy="45720"/>
           </a:xfrm>
           <a:prstGeom prst="rect">
             <a:avLst/>
@@ -3110,8 +3110,8 @@
         </p:nvSpPr>
         <p:spPr>
           <a:xfrm>
-            <a:off x="685800" y="4572000"/>
-            <a:ext cx="3063240" cy="182880"/>
+            <a:off x="685800" y="4315968"/>
+            <a:ext cx="4709160" cy="182880"/>
           </a:xfrm>
           <a:prstGeom prst="rect">
             <a:avLst/>
@@ -3139,7 +3139,7 @@
               <a:rPr>
                 <a:latin typeface="Inter"/>
               </a:rPr>
-              <a:t>MODE</a:t>
+              <a:t>REVIEW</a:t>
             </a:r>
           </a:p>
         </p:txBody>
@@ -3152,8 +3152,8 @@
         </p:nvSpPr>
         <p:spPr>
           <a:xfrm>
-            <a:off x="685800" y="4773168"/>
-            <a:ext cx="3063240" cy="320040"/>
+            <a:off x="685800" y="4507992"/>
+            <a:ext cx="4709160" cy="310896"/>
           </a:xfrm>
           <a:prstGeom prst="rect">
             <a:avLst/>
@@ -3181,7 +3181,7 @@
               <a:rPr>
                 <a:latin typeface="Inter"/>
               </a:rPr>
-              <a:t>Compare</a:t>
+              <a:t>Manager comparison</a:t>
             </a:r>
           </a:p>
         </p:txBody>
@@ -3194,8 +3194,8 @@
         </p:nvSpPr>
         <p:spPr>
           <a:xfrm>
-            <a:off x="4160520" y="4572000"/>
-            <a:ext cx="3063240" cy="182880"/>
+            <a:off x="5852160" y="4315968"/>
+            <a:ext cx="4709160" cy="182880"/>
           </a:xfrm>
           <a:prstGeom prst="rect">
             <a:avLst/>
@@ -3223,7 +3223,7 @@
               <a:rPr>
                 <a:latin typeface="Inter"/>
               </a:rPr>
-              <a:t>SCOPE</a:t>
+              <a:t>EVIDENCE</a:t>
             </a:r>
           </a:p>
         </p:txBody>
@@ -3236,8 +3236,8 @@
         </p:nvSpPr>
         <p:spPr>
           <a:xfrm>
-            <a:off x="4160520" y="4773168"/>
-            <a:ext cx="3063240" cy="320040"/>
+            <a:off x="5852160" y="4507992"/>
+            <a:ext cx="4709160" cy="310896"/>
           </a:xfrm>
           <a:prstGeom prst="rect">
             <a:avLst/>
@@ -3265,21 +3265,189 @@
               <a:rPr>
                 <a:latin typeface="Inter"/>
               </a:rPr>
-              <a:t>Fictional TEST managers</a:t>
-            </a:r>
-          </a:p>
-        </p:txBody>
-      </p:sp>
-      <p:sp>
-        <p:nvSpPr>
-          <p:cNvPr id="13" name="Rectangle 12"/>
+              <a:t>Governed return series</a:t>
+            </a:r>
+          </a:p>
+        </p:txBody>
+      </p:sp>
+      <p:sp>
+        <p:nvSpPr>
+          <p:cNvPr id="13" name="TextBox 12"/>
+          <p:cNvSpPr txBox="1"/>
+          <p:nvPr/>
+        </p:nvSpPr>
+        <p:spPr>
+          <a:xfrm>
+            <a:off x="685800" y="4937759"/>
+            <a:ext cx="4709160" cy="182880"/>
+          </a:xfrm>
+          <a:prstGeom prst="rect">
+            <a:avLst/>
+          </a:prstGeom>
+          <a:noFill/>
+        </p:spPr>
+        <p:txBody>
+          <a:bodyPr wrap="none" lIns="9144" rIns="9144" tIns="9144" bIns="9144" anchor="t">
+            <a:spAutoFit/>
+          </a:bodyPr>
+          <a:lstStyle/>
+          <a:p>
+            <a:pPr algn="l">
+              <a:spcAft>
+                <a:spcPts val="0"/>
+              </a:spcAft>
+              <a:defRPr sz="700" b="1">
+                <a:solidFill>
+                  <a:srgbClr val="8A94A1"/>
+                </a:solidFill>
+                <a:latin typeface="Inter"/>
+              </a:defRPr>
+            </a:pPr>
+            <a:r>
+              <a:rPr>
+                <a:latin typeface="Inter"/>
+              </a:rPr>
+              <a:t>AUDIENCE</a:t>
+            </a:r>
+          </a:p>
+        </p:txBody>
+      </p:sp>
+      <p:sp>
+        <p:nvSpPr>
+          <p:cNvPr id="14" name="TextBox 13"/>
+          <p:cNvSpPr txBox="1"/>
+          <p:nvPr/>
+        </p:nvSpPr>
+        <p:spPr>
+          <a:xfrm>
+            <a:off x="685800" y="5129783"/>
+            <a:ext cx="4709160" cy="310896"/>
+          </a:xfrm>
+          <a:prstGeom prst="rect">
+            <a:avLst/>
+          </a:prstGeom>
+          <a:noFill/>
+        </p:spPr>
+        <p:txBody>
+          <a:bodyPr wrap="none" lIns="9144" rIns="9144" tIns="9144" bIns="9144" anchor="t">
+            <a:spAutoFit/>
+          </a:bodyPr>
+          <a:lstStyle/>
+          <a:p>
+            <a:pPr algn="l">
+              <a:spcAft>
+                <a:spcPts val="0"/>
+              </a:spcAft>
+              <a:defRPr sz="1000" b="1">
+                <a:solidFill>
+                  <a:srgbClr val="FFFFFF"/>
+                </a:solidFill>
+                <a:latin typeface="Inter"/>
+              </a:defRPr>
+            </a:pPr>
+            <a:r>
+              <a:rPr>
+                <a:latin typeface="Inter"/>
+              </a:rPr>
+              <a:t>Investment Committee</a:t>
+            </a:r>
+          </a:p>
+        </p:txBody>
+      </p:sp>
+      <p:sp>
+        <p:nvSpPr>
+          <p:cNvPr id="15" name="TextBox 14"/>
+          <p:cNvSpPr txBox="1"/>
+          <p:nvPr/>
+        </p:nvSpPr>
+        <p:spPr>
+          <a:xfrm>
+            <a:off x="5852160" y="4937759"/>
+            <a:ext cx="4709160" cy="182880"/>
+          </a:xfrm>
+          <a:prstGeom prst="rect">
+            <a:avLst/>
+          </a:prstGeom>
+          <a:noFill/>
+        </p:spPr>
+        <p:txBody>
+          <a:bodyPr wrap="none" lIns="9144" rIns="9144" tIns="9144" bIns="9144" anchor="t">
+            <a:spAutoFit/>
+          </a:bodyPr>
+          <a:lstStyle/>
+          <a:p>
+            <a:pPr algn="l">
+              <a:spcAft>
+                <a:spcPts val="0"/>
+              </a:spcAft>
+              <a:defRPr sz="700" b="1">
+                <a:solidFill>
+                  <a:srgbClr val="8A94A1"/>
+                </a:solidFill>
+                <a:latin typeface="Inter"/>
+              </a:defRPr>
+            </a:pPr>
+            <a:r>
+              <a:rPr>
+                <a:latin typeface="Inter"/>
+              </a:rPr>
+              <a:t>DATA AS OF</a:t>
+            </a:r>
+          </a:p>
+        </p:txBody>
+      </p:sp>
+      <p:sp>
+        <p:nvSpPr>
+          <p:cNvPr id="16" name="TextBox 15"/>
+          <p:cNvSpPr txBox="1"/>
+          <p:nvPr/>
+        </p:nvSpPr>
+        <p:spPr>
+          <a:xfrm>
+            <a:off x="5852160" y="5129783"/>
+            <a:ext cx="4709160" cy="310896"/>
+          </a:xfrm>
+          <a:prstGeom prst="rect">
+            <a:avLst/>
+          </a:prstGeom>
+          <a:noFill/>
+        </p:spPr>
+        <p:txBody>
+          <a:bodyPr wrap="none" lIns="9144" rIns="9144" tIns="9144" bIns="9144" anchor="t">
+            <a:spAutoFit/>
+          </a:bodyPr>
+          <a:lstStyle/>
+          <a:p>
+            <a:pPr algn="l">
+              <a:spcAft>
+                <a:spcPts val="0"/>
+              </a:spcAft>
+              <a:defRPr sz="1000" b="1">
+                <a:solidFill>
+                  <a:srgbClr val="FFFFFF"/>
+                </a:solidFill>
+                <a:latin typeface="Inter"/>
+              </a:defRPr>
+            </a:pPr>
+            <a:r>
+              <a:rPr>
+                <a:latin typeface="Inter"/>
+              </a:rPr>
+              <a:t>2025-12-31</a:t>
+            </a:r>
+          </a:p>
+        </p:txBody>
+      </p:sp>
+      <p:sp>
+        <p:nvSpPr>
+          <p:cNvPr id="17" name="Rectangle 16"/>
           <p:cNvSpPr/>
           <p:nvPr/>
         </p:nvSpPr>
         <p:spPr>
           <a:xfrm>
-            <a:off x="685800" y="5833872"/>
-            <a:ext cx="3063240" cy="384048"/>
+            <a:off x="685800" y="5687568"/>
+            <a:ext cx="3337560" cy="530352"/>
           </a:xfrm>
           <a:prstGeom prst="rect">
             <a:avLst/>
@@ -3321,14 +3489,140 @@
       </p:sp>
       <p:sp>
         <p:nvSpPr>
-          <p:cNvPr id="14" name="TextBox 13"/>
+          <p:cNvPr id="18" name="TextBox 17"/>
           <p:cNvSpPr txBox="1"/>
           <p:nvPr/>
         </p:nvSpPr>
         <p:spPr>
           <a:xfrm>
-            <a:off x="822960" y="5934456"/>
-            <a:ext cx="2788920" cy="164592"/>
+            <a:off x="822960" y="5760720"/>
+            <a:ext cx="3063240" cy="128016"/>
+          </a:xfrm>
+          <a:prstGeom prst="rect">
+            <a:avLst/>
+          </a:prstGeom>
+          <a:noFill/>
+        </p:spPr>
+        <p:txBody>
+          <a:bodyPr wrap="none" lIns="9144" rIns="9144" tIns="9144" bIns="9144" anchor="t">
+            <a:spAutoFit/>
+          </a:bodyPr>
+          <a:lstStyle/>
+          <a:p>
+            <a:pPr algn="l">
+              <a:spcAft>
+                <a:spcPts val="0"/>
+              </a:spcAft>
+              <a:defRPr sz="620" b="1">
+                <a:solidFill>
+                  <a:srgbClr val="0D1117"/>
+                </a:solidFill>
+                <a:latin typeface="Inter"/>
+              </a:defRPr>
+            </a:pPr>
+            <a:r>
+              <a:rPr>
+                <a:latin typeface="Inter"/>
+              </a:rPr>
+              <a:t>OVERALL VIEW</a:t>
+            </a:r>
+          </a:p>
+        </p:txBody>
+      </p:sp>
+      <p:sp>
+        <p:nvSpPr>
+          <p:cNvPr id="19" name="TextBox 18"/>
+          <p:cNvSpPr txBox="1"/>
+          <p:nvPr/>
+        </p:nvSpPr>
+        <p:spPr>
+          <a:xfrm>
+            <a:off x="822960" y="5916168"/>
+            <a:ext cx="3063240" cy="182880"/>
+          </a:xfrm>
+          <a:prstGeom prst="rect">
+            <a:avLst/>
+          </a:prstGeom>
+          <a:noFill/>
+        </p:spPr>
+        <p:txBody>
+          <a:bodyPr wrap="none" lIns="9144" rIns="9144" tIns="9144" bIns="9144" anchor="t">
+            <a:spAutoFit/>
+          </a:bodyPr>
+          <a:lstStyle/>
+          <a:p>
+            <a:pPr algn="l">
+              <a:spcAft>
+                <a:spcPts val="0"/>
+              </a:spcAft>
+              <a:defRPr sz="900" b="1">
+                <a:solidFill>
+                  <a:srgbClr val="0D1117"/>
+                </a:solidFill>
+                <a:latin typeface="Inter"/>
+              </a:defRPr>
+            </a:pPr>
+            <a:r>
+              <a:rPr>
+                <a:latin typeface="Inter"/>
+              </a:rPr>
+              <a:t>Insufficient governed evidence</a:t>
+            </a:r>
+          </a:p>
+        </p:txBody>
+      </p:sp>
+      <p:sp>
+        <p:nvSpPr>
+          <p:cNvPr id="20" name="TextBox 19"/>
+          <p:cNvSpPr txBox="1"/>
+          <p:nvPr/>
+        </p:nvSpPr>
+        <p:spPr>
+          <a:xfrm>
+            <a:off x="4297680" y="5733288"/>
+            <a:ext cx="3108960" cy="164592"/>
+          </a:xfrm>
+          <a:prstGeom prst="rect">
+            <a:avLst/>
+          </a:prstGeom>
+          <a:noFill/>
+        </p:spPr>
+        <p:txBody>
+          <a:bodyPr wrap="none" lIns="9144" rIns="9144" tIns="9144" bIns="9144" anchor="t">
+            <a:spAutoFit/>
+          </a:bodyPr>
+          <a:lstStyle/>
+          <a:p>
+            <a:pPr algn="l">
+              <a:spcAft>
+                <a:spcPts val="0"/>
+              </a:spcAft>
+              <a:defRPr sz="650" b="1">
+                <a:solidFill>
+                  <a:srgbClr val="8A94A1"/>
+                </a:solidFill>
+                <a:latin typeface="Inter"/>
+              </a:defRPr>
+            </a:pPr>
+            <a:r>
+              <a:rPr>
+                <a:latin typeface="Inter"/>
+              </a:rPr>
+              <a:t>SCOPE REVIEWED</a:t>
+            </a:r>
+          </a:p>
+        </p:txBody>
+      </p:sp>
+      <p:sp>
+        <p:nvSpPr>
+          <p:cNvPr id="21" name="TextBox 20"/>
+          <p:cNvSpPr txBox="1"/>
+          <p:nvPr/>
+        </p:nvSpPr>
+        <p:spPr>
+          <a:xfrm>
+            <a:off x="4297680" y="5934456"/>
+            <a:ext cx="3108960" cy="201168"/>
           </a:xfrm>
           <a:prstGeom prst="rect">
             <a:avLst/>
@@ -3347,90 +3641,6 @@
               </a:spcAft>
               <a:defRPr sz="800" b="1">
                 <a:solidFill>
-                  <a:srgbClr val="0D1117"/>
-                </a:solidFill>
-                <a:latin typeface="Inter"/>
-              </a:defRPr>
-            </a:pPr>
-            <a:r>
-              <a:rPr>
-                <a:latin typeface="Inter"/>
-              </a:rPr>
-              <a:t>Insufficient governed evidence</a:t>
-            </a:r>
-          </a:p>
-        </p:txBody>
-      </p:sp>
-      <p:sp>
-        <p:nvSpPr>
-          <p:cNvPr id="15" name="TextBox 14"/>
-          <p:cNvSpPr txBox="1"/>
-          <p:nvPr/>
-        </p:nvSpPr>
-        <p:spPr>
-          <a:xfrm>
-            <a:off x="3977639" y="5824728"/>
-            <a:ext cx="3108960" cy="164592"/>
-          </a:xfrm>
-          <a:prstGeom prst="rect">
-            <a:avLst/>
-          </a:prstGeom>
-          <a:noFill/>
-        </p:spPr>
-        <p:txBody>
-          <a:bodyPr wrap="none" lIns="9144" rIns="9144" tIns="9144" bIns="9144" anchor="t">
-            <a:spAutoFit/>
-          </a:bodyPr>
-          <a:lstStyle/>
-          <a:p>
-            <a:pPr algn="l">
-              <a:spcAft>
-                <a:spcPts val="0"/>
-              </a:spcAft>
-              <a:defRPr sz="650" b="1">
-                <a:solidFill>
-                  <a:srgbClr val="8A94A1"/>
-                </a:solidFill>
-                <a:latin typeface="Inter"/>
-              </a:defRPr>
-            </a:pPr>
-            <a:r>
-              <a:rPr>
-                <a:latin typeface="Inter"/>
-              </a:rPr>
-              <a:t>EVIDENCE COMPLETENESS</a:t>
-            </a:r>
-          </a:p>
-        </p:txBody>
-      </p:sp>
-      <p:sp>
-        <p:nvSpPr>
-          <p:cNvPr id="16" name="TextBox 15"/>
-          <p:cNvSpPr txBox="1"/>
-          <p:nvPr/>
-        </p:nvSpPr>
-        <p:spPr>
-          <a:xfrm>
-            <a:off x="3977639" y="5998464"/>
-            <a:ext cx="3108960" cy="201168"/>
-          </a:xfrm>
-          <a:prstGeom prst="rect">
-            <a:avLst/>
-          </a:prstGeom>
-          <a:noFill/>
-        </p:spPr>
-        <p:txBody>
-          <a:bodyPr wrap="none" lIns="9144" rIns="9144" tIns="9144" bIns="9144" anchor="t">
-            <a:spAutoFit/>
-          </a:bodyPr>
-          <a:lstStyle/>
-          <a:p>
-            <a:pPr algn="l">
-              <a:spcAft>
-                <a:spcPts val="0"/>
-              </a:spcAft>
-              <a:defRPr sz="800" b="1">
-                <a:solidFill>
                   <a:srgbClr val="FFFFFF"/>
                 </a:solidFill>
                 <a:latin typeface="Inter"/>
@@ -3447,14 +3657,14 @@
       </p:sp>
       <p:sp>
         <p:nvSpPr>
-          <p:cNvPr id="17" name="TextBox 16"/>
+          <p:cNvPr id="22" name="TextBox 21"/>
           <p:cNvSpPr txBox="1"/>
           <p:nvPr/>
         </p:nvSpPr>
         <p:spPr>
           <a:xfrm>
-            <a:off x="685800" y="6473952"/>
-            <a:ext cx="8046720" cy="182880"/>
+            <a:off x="685800" y="6400800"/>
+            <a:ext cx="8046720" cy="146304"/>
           </a:xfrm>
           <a:prstGeom prst="rect">
             <a:avLst/>
@@ -3482,14 +3692,56 @@
               <a:rPr>
                 <a:latin typeface="Inter"/>
               </a:rPr>
-              <a:t>Confidential — prepared for internal investment use</a:t>
-            </a:r>
-          </a:p>
-        </p:txBody>
-      </p:sp>
-      <p:sp>
-        <p:nvSpPr>
-          <p:cNvPr id="18" name="TextBox 17"/>
+              <a:t>Confidential — manager selection review</a:t>
+            </a:r>
+          </a:p>
+        </p:txBody>
+      </p:sp>
+      <p:sp>
+        <p:nvSpPr>
+          <p:cNvPr id="23" name="TextBox 22"/>
+          <p:cNvSpPr txBox="1"/>
+          <p:nvPr/>
+        </p:nvSpPr>
+        <p:spPr>
+          <a:xfrm>
+            <a:off x="685800" y="6556248"/>
+            <a:ext cx="8046720" cy="128016"/>
+          </a:xfrm>
+          <a:prstGeom prst="rect">
+            <a:avLst/>
+          </a:prstGeom>
+          <a:noFill/>
+        </p:spPr>
+        <p:txBody>
+          <a:bodyPr wrap="none" lIns="9144" rIns="9144" tIns="9144" bIns="9144" anchor="t">
+            <a:spAutoFit/>
+          </a:bodyPr>
+          <a:lstStyle/>
+          <a:p>
+            <a:pPr algn="l">
+              <a:spcAft>
+                <a:spcPts val="0"/>
+              </a:spcAft>
+              <a:defRPr sz="650" b="0">
+                <a:solidFill>
+                  <a:srgbClr val="8A94A1"/>
+                </a:solidFill>
+                <a:latin typeface="Inter"/>
+              </a:defRPr>
+            </a:pPr>
+            <a:r>
+              <a:rPr>
+                <a:latin typeface="Inter"/>
+              </a:rPr>
+              <a:t>Illustrative sample · not client data</a:t>
+            </a:r>
+          </a:p>
+        </p:txBody>
+      </p:sp>
+      <p:sp>
+        <p:nvSpPr>
+          <p:cNvPr id="24" name="TextBox 23"/>
           <p:cNvSpPr txBox="1"/>
           <p:nvPr/>
         </p:nvSpPr>
@@ -3605,7 +3857,7 @@
         <p:spPr>
           <a:xfrm>
             <a:off x="640080" y="329184"/>
-            <a:ext cx="9875520" cy="182880"/>
+            <a:ext cx="5303520" cy="182880"/>
           </a:xfrm>
           <a:prstGeom prst="rect">
             <a:avLst/>
@@ -3646,6 +3898,48 @@
         </p:nvSpPr>
         <p:spPr>
           <a:xfrm>
+            <a:off x="5897880" y="310896"/>
+            <a:ext cx="4800600" cy="256032"/>
+          </a:xfrm>
+          <a:prstGeom prst="rect">
+            <a:avLst/>
+          </a:prstGeom>
+          <a:noFill/>
+        </p:spPr>
+        <p:txBody>
+          <a:bodyPr wrap="none" lIns="9144" rIns="9144" tIns="9144" bIns="9144" anchor="t">
+            <a:spAutoFit/>
+          </a:bodyPr>
+          <a:lstStyle/>
+          <a:p>
+            <a:pPr algn="r">
+              <a:spcAft>
+                <a:spcPts val="0"/>
+              </a:spcAft>
+              <a:defRPr sz="680" b="1">
+                <a:solidFill>
+                  <a:srgbClr val="4F6B00"/>
+                </a:solidFill>
+                <a:latin typeface="Inter"/>
+              </a:defRPr>
+            </a:pPr>
+            <a:r>
+              <a:rPr>
+                <a:latin typeface="Inter"/>
+              </a:rPr>
+              <a:t>Illustrative, Gradient Maintained — demo data, not the client's holdings or managers</a:t>
+            </a:r>
+          </a:p>
+        </p:txBody>
+      </p:sp>
+      <p:sp>
+        <p:nvSpPr>
+          <p:cNvPr id="5" name="TextBox 4"/>
+          <p:cNvSpPr txBox="1"/>
+          <p:nvPr/>
+        </p:nvSpPr>
+        <p:spPr>
+          <a:xfrm>
             <a:off x="640080" y="566928"/>
             <a:ext cx="10058400" cy="530352"/>
           </a:xfrm>
@@ -3682,7 +3976,7 @@
       </p:sp>
       <p:sp>
         <p:nvSpPr>
-          <p:cNvPr id="5" name="Rectangle 4"/>
+          <p:cNvPr id="6" name="Rectangle 5"/>
           <p:cNvSpPr/>
           <p:nvPr/>
         </p:nvSpPr>
@@ -3731,7 +4025,7 @@
       </p:sp>
       <p:sp>
         <p:nvSpPr>
-          <p:cNvPr id="6" name="Rectangle 5"/>
+          <p:cNvPr id="7" name="Rectangle 6"/>
           <p:cNvSpPr/>
           <p:nvPr/>
         </p:nvSpPr>
@@ -3780,7 +4074,7 @@
       </p:sp>
       <p:sp>
         <p:nvSpPr>
-          <p:cNvPr id="7" name="TextBox 6"/>
+          <p:cNvPr id="8" name="TextBox 7"/>
           <p:cNvSpPr txBox="1"/>
           <p:nvPr/>
         </p:nvSpPr>
@@ -3822,7 +4116,7 @@
       </p:sp>
       <p:sp>
         <p:nvSpPr>
-          <p:cNvPr id="8" name="Rectangle 7"/>
+          <p:cNvPr id="9" name="Rectangle 8"/>
           <p:cNvSpPr/>
           <p:nvPr/>
         </p:nvSpPr>
@@ -3871,7 +4165,7 @@
       </p:sp>
       <p:sp>
         <p:nvSpPr>
-          <p:cNvPr id="9" name="Rectangle 8"/>
+          <p:cNvPr id="10" name="Rectangle 9"/>
           <p:cNvSpPr/>
           <p:nvPr/>
         </p:nvSpPr>
@@ -3920,7 +4214,7 @@
       </p:sp>
       <p:sp>
         <p:nvSpPr>
-          <p:cNvPr id="10" name="TextBox 9"/>
+          <p:cNvPr id="11" name="TextBox 10"/>
           <p:cNvSpPr txBox="1"/>
           <p:nvPr/>
         </p:nvSpPr>
@@ -3962,7 +4256,7 @@
       </p:sp>
       <p:sp>
         <p:nvSpPr>
-          <p:cNvPr id="11" name="TextBox 10"/>
+          <p:cNvPr id="12" name="TextBox 11"/>
           <p:cNvSpPr txBox="1"/>
           <p:nvPr/>
         </p:nvSpPr>
@@ -4004,7 +4298,7 @@
       </p:sp>
       <p:sp>
         <p:nvSpPr>
-          <p:cNvPr id="12" name="Rectangle 11"/>
+          <p:cNvPr id="13" name="Rectangle 12"/>
           <p:cNvSpPr/>
           <p:nvPr/>
         </p:nvSpPr>
@@ -4053,7 +4347,7 @@
       </p:sp>
       <p:sp>
         <p:nvSpPr>
-          <p:cNvPr id="13" name="Rectangle 12"/>
+          <p:cNvPr id="14" name="Rectangle 13"/>
           <p:cNvSpPr/>
           <p:nvPr/>
         </p:nvSpPr>
@@ -4102,7 +4396,7 @@
       </p:sp>
       <p:sp>
         <p:nvSpPr>
-          <p:cNvPr id="14" name="TextBox 13"/>
+          <p:cNvPr id="15" name="TextBox 14"/>
           <p:cNvSpPr txBox="1"/>
           <p:nvPr/>
         </p:nvSpPr>
@@ -4144,7 +4438,7 @@
       </p:sp>
       <p:sp>
         <p:nvSpPr>
-          <p:cNvPr id="15" name="TextBox 14"/>
+          <p:cNvPr id="16" name="TextBox 15"/>
           <p:cNvSpPr txBox="1"/>
           <p:nvPr/>
         </p:nvSpPr>
@@ -4186,7 +4480,7 @@
       </p:sp>
       <p:sp>
         <p:nvSpPr>
-          <p:cNvPr id="16" name="Rectangle 15"/>
+          <p:cNvPr id="17" name="Rectangle 16"/>
           <p:cNvSpPr/>
           <p:nvPr/>
         </p:nvSpPr>
@@ -4235,7 +4529,7 @@
       </p:sp>
       <p:sp>
         <p:nvSpPr>
-          <p:cNvPr id="17" name="Rectangle 16"/>
+          <p:cNvPr id="18" name="Rectangle 17"/>
           <p:cNvSpPr/>
           <p:nvPr/>
         </p:nvSpPr>
@@ -4284,7 +4578,7 @@
       </p:sp>
       <p:sp>
         <p:nvSpPr>
-          <p:cNvPr id="18" name="TextBox 17"/>
+          <p:cNvPr id="19" name="TextBox 18"/>
           <p:cNvSpPr txBox="1"/>
           <p:nvPr/>
         </p:nvSpPr>
@@ -4326,7 +4620,7 @@
       </p:sp>
       <p:sp>
         <p:nvSpPr>
-          <p:cNvPr id="19" name="TextBox 18"/>
+          <p:cNvPr id="20" name="TextBox 19"/>
           <p:cNvSpPr txBox="1"/>
           <p:nvPr/>
         </p:nvSpPr>
@@ -4368,7 +4662,7 @@
       </p:sp>
       <p:sp>
         <p:nvSpPr>
-          <p:cNvPr id="20" name="Rectangle 19"/>
+          <p:cNvPr id="21" name="Rectangle 20"/>
           <p:cNvSpPr/>
           <p:nvPr/>
         </p:nvSpPr>
@@ -4417,7 +4711,7 @@
       </p:sp>
       <p:sp>
         <p:nvSpPr>
-          <p:cNvPr id="21" name="TextBox 20"/>
+          <p:cNvPr id="22" name="TextBox 21"/>
           <p:cNvSpPr txBox="1"/>
           <p:nvPr/>
         </p:nvSpPr>
@@ -4459,7 +4753,7 @@
       </p:sp>
       <p:sp>
         <p:nvSpPr>
-          <p:cNvPr id="22" name="TextBox 21"/>
+          <p:cNvPr id="23" name="TextBox 22"/>
           <p:cNvSpPr txBox="1"/>
           <p:nvPr/>
         </p:nvSpPr>
@@ -4494,14 +4788,14 @@
               <a:rPr>
                 <a:latin typeface="Inter"/>
               </a:rPr>
-              <a:t>Confidential — prepared for internal investment use · Data as of 2025-12-31</a:t>
-            </a:r>
-          </a:p>
-        </p:txBody>
-      </p:sp>
-      <p:sp>
-        <p:nvSpPr>
-          <p:cNvPr id="23" name="TextBox 22"/>
+              <a:t>Confidential — manager selection review · Data as of 2025-12-31</a:t>
+            </a:r>
+          </a:p>
+        </p:txBody>
+      </p:sp>
+      <p:sp>
+        <p:nvSpPr>
+          <p:cNvPr id="24" name="TextBox 23"/>
           <p:cNvSpPr txBox="1"/>
           <p:nvPr/>
         </p:nvSpPr>
@@ -4617,7 +4911,7 @@
         <p:spPr>
           <a:xfrm>
             <a:off x="640080" y="329184"/>
-            <a:ext cx="9875520" cy="182880"/>
+            <a:ext cx="5303520" cy="182880"/>
           </a:xfrm>
           <a:prstGeom prst="rect">
             <a:avLst/>
@@ -4645,7 +4939,7 @@
               <a:rPr>
                 <a:latin typeface="Inter"/>
               </a:rPr>
-              <a:t>BENCHMARK IDENTITY REMAINS ADVISORY FOR THE TEST CANDIDATES</a:t>
+              <a:t>BENCHMARK IDENTITY REMAINS ADVISORY FOR THE REVIEWED CANDIDATES</a:t>
             </a:r>
           </a:p>
         </p:txBody>
@@ -4653,6 +4947,48 @@
       <p:sp>
         <p:nvSpPr>
           <p:cNvPr id="4" name="TextBox 3"/>
+          <p:cNvSpPr txBox="1"/>
+          <p:nvPr/>
+        </p:nvSpPr>
+        <p:spPr>
+          <a:xfrm>
+            <a:off x="5897880" y="310896"/>
+            <a:ext cx="4800600" cy="256032"/>
+          </a:xfrm>
+          <a:prstGeom prst="rect">
+            <a:avLst/>
+          </a:prstGeom>
+          <a:noFill/>
+        </p:spPr>
+        <p:txBody>
+          <a:bodyPr wrap="none" lIns="9144" rIns="9144" tIns="9144" bIns="9144" anchor="t">
+            <a:spAutoFit/>
+          </a:bodyPr>
+          <a:lstStyle/>
+          <a:p>
+            <a:pPr algn="r">
+              <a:spcAft>
+                <a:spcPts val="0"/>
+              </a:spcAft>
+              <a:defRPr sz="680" b="1">
+                <a:solidFill>
+                  <a:srgbClr val="4F6B00"/>
+                </a:solidFill>
+                <a:latin typeface="Inter"/>
+              </a:defRPr>
+            </a:pPr>
+            <a:r>
+              <a:rPr>
+                <a:latin typeface="Inter"/>
+              </a:rPr>
+              <a:t>Illustrative, Gradient Maintained — demo data, not the client's holdings or managers</a:t>
+            </a:r>
+          </a:p>
+        </p:txBody>
+      </p:sp>
+      <p:sp>
+        <p:nvSpPr>
+          <p:cNvPr id="5" name="TextBox 4"/>
           <p:cNvSpPr txBox="1"/>
           <p:nvPr/>
         </p:nvSpPr>
@@ -4694,7 +5030,7 @@
       </p:sp>
       <p:sp>
         <p:nvSpPr>
-          <p:cNvPr id="5" name="Rectangle 4"/>
+          <p:cNvPr id="6" name="Rectangle 5"/>
           <p:cNvSpPr/>
           <p:nvPr/>
         </p:nvSpPr>
@@ -4743,7 +5079,7 @@
       </p:sp>
       <p:sp>
         <p:nvSpPr>
-          <p:cNvPr id="6" name="Rectangle 5"/>
+          <p:cNvPr id="7" name="Rectangle 6"/>
           <p:cNvSpPr/>
           <p:nvPr/>
         </p:nvSpPr>
@@ -4792,7 +5128,7 @@
       </p:sp>
       <p:sp>
         <p:nvSpPr>
-          <p:cNvPr id="7" name="TextBox 6"/>
+          <p:cNvPr id="8" name="TextBox 7"/>
           <p:cNvSpPr txBox="1"/>
           <p:nvPr/>
         </p:nvSpPr>
@@ -4834,7 +5170,7 @@
       </p:sp>
       <p:graphicFrame>
         <p:nvGraphicFramePr>
-          <p:cNvPr id="8" name="Table 7"/>
+          <p:cNvPr id="9" name="Table 8"/>
           <p:cNvGraphicFramePr>
             <a:graphicFrameLocks noGrp="1"/>
           </p:cNvGraphicFramePr>
@@ -5027,7 +5363,7 @@
       </p:graphicFrame>
       <p:sp>
         <p:nvSpPr>
-          <p:cNvPr id="9" name="Rectangle 8"/>
+          <p:cNvPr id="10" name="Rectangle 9"/>
           <p:cNvSpPr/>
           <p:nvPr/>
         </p:nvSpPr>
@@ -5076,7 +5412,7 @@
       </p:sp>
       <p:sp>
         <p:nvSpPr>
-          <p:cNvPr id="10" name="TextBox 9"/>
+          <p:cNvPr id="11" name="TextBox 10"/>
           <p:cNvSpPr txBox="1"/>
           <p:nvPr/>
         </p:nvSpPr>
@@ -5118,7 +5454,7 @@
       </p:sp>
       <p:sp>
         <p:nvSpPr>
-          <p:cNvPr id="11" name="TextBox 10"/>
+          <p:cNvPr id="12" name="TextBox 11"/>
           <p:cNvSpPr txBox="1"/>
           <p:nvPr/>
         </p:nvSpPr>
@@ -5153,14 +5489,14 @@
               <a:rPr>
                 <a:latin typeface="Inter"/>
               </a:rPr>
-              <a:t>Confidential — prepared for internal investment use · Data as of 2025-12-31</a:t>
-            </a:r>
-          </a:p>
-        </p:txBody>
-      </p:sp>
-      <p:sp>
-        <p:nvSpPr>
-          <p:cNvPr id="12" name="TextBox 11"/>
+              <a:t>Confidential — manager selection review · Data as of 2025-12-31</a:t>
+            </a:r>
+          </a:p>
+        </p:txBody>
+      </p:sp>
+      <p:sp>
+        <p:nvSpPr>
+          <p:cNvPr id="13" name="TextBox 12"/>
           <p:cNvSpPr txBox="1"/>
           <p:nvPr/>
         </p:nvSpPr>
@@ -5276,7 +5612,7 @@
         <p:spPr>
           <a:xfrm>
             <a:off x="640080" y="329184"/>
-            <a:ext cx="9875520" cy="182880"/>
+            <a:ext cx="5303520" cy="182880"/>
           </a:xfrm>
           <a:prstGeom prst="rect">
             <a:avLst/>
@@ -5317,6 +5653,48 @@
         </p:nvSpPr>
         <p:spPr>
           <a:xfrm>
+            <a:off x="5897880" y="310896"/>
+            <a:ext cx="4800600" cy="256032"/>
+          </a:xfrm>
+          <a:prstGeom prst="rect">
+            <a:avLst/>
+          </a:prstGeom>
+          <a:noFill/>
+        </p:spPr>
+        <p:txBody>
+          <a:bodyPr wrap="none" lIns="9144" rIns="9144" tIns="9144" bIns="9144" anchor="t">
+            <a:spAutoFit/>
+          </a:bodyPr>
+          <a:lstStyle/>
+          <a:p>
+            <a:pPr algn="r">
+              <a:spcAft>
+                <a:spcPts val="0"/>
+              </a:spcAft>
+              <a:defRPr sz="680" b="1">
+                <a:solidFill>
+                  <a:srgbClr val="4F6B00"/>
+                </a:solidFill>
+                <a:latin typeface="Inter"/>
+              </a:defRPr>
+            </a:pPr>
+            <a:r>
+              <a:rPr>
+                <a:latin typeface="Inter"/>
+              </a:rPr>
+              <a:t>Illustrative, Gradient Maintained — demo data, not the client's holdings or managers</a:t>
+            </a:r>
+          </a:p>
+        </p:txBody>
+      </p:sp>
+      <p:sp>
+        <p:nvSpPr>
+          <p:cNvPr id="5" name="TextBox 4"/>
+          <p:cNvSpPr txBox="1"/>
+          <p:nvPr/>
+        </p:nvSpPr>
+        <p:spPr>
+          <a:xfrm>
             <a:off x="640080" y="566928"/>
             <a:ext cx="10058400" cy="530352"/>
           </a:xfrm>
@@ -5353,7 +5731,7 @@
       </p:sp>
       <p:sp>
         <p:nvSpPr>
-          <p:cNvPr id="5" name="Rectangle 4"/>
+          <p:cNvPr id="6" name="Rectangle 5"/>
           <p:cNvSpPr/>
           <p:nvPr/>
         </p:nvSpPr>
@@ -5402,7 +5780,7 @@
       </p:sp>
       <p:sp>
         <p:nvSpPr>
-          <p:cNvPr id="6" name="Rectangle 5"/>
+          <p:cNvPr id="7" name="Rectangle 6"/>
           <p:cNvSpPr/>
           <p:nvPr/>
         </p:nvSpPr>
@@ -5451,7 +5829,7 @@
       </p:sp>
       <p:sp>
         <p:nvSpPr>
-          <p:cNvPr id="7" name="TextBox 6"/>
+          <p:cNvPr id="8" name="TextBox 7"/>
           <p:cNvSpPr txBox="1"/>
           <p:nvPr/>
         </p:nvSpPr>
@@ -5493,7 +5871,7 @@
       </p:sp>
       <p:sp>
         <p:nvSpPr>
-          <p:cNvPr id="8" name="Rectangle 7"/>
+          <p:cNvPr id="9" name="Rectangle 8"/>
           <p:cNvSpPr/>
           <p:nvPr/>
         </p:nvSpPr>
@@ -5542,7 +5920,7 @@
       </p:sp>
       <p:sp>
         <p:nvSpPr>
-          <p:cNvPr id="9" name="Rectangle 8"/>
+          <p:cNvPr id="10" name="Rectangle 9"/>
           <p:cNvSpPr/>
           <p:nvPr/>
         </p:nvSpPr>
@@ -5591,7 +5969,7 @@
       </p:sp>
       <p:sp>
         <p:nvSpPr>
-          <p:cNvPr id="10" name="TextBox 9"/>
+          <p:cNvPr id="11" name="TextBox 10"/>
           <p:cNvSpPr txBox="1"/>
           <p:nvPr/>
         </p:nvSpPr>
@@ -5633,7 +6011,7 @@
       </p:sp>
       <p:sp>
         <p:nvSpPr>
-          <p:cNvPr id="11" name="TextBox 10"/>
+          <p:cNvPr id="12" name="TextBox 11"/>
           <p:cNvSpPr txBox="1"/>
           <p:nvPr/>
         </p:nvSpPr>
@@ -5675,7 +6053,7 @@
       </p:sp>
       <p:sp>
         <p:nvSpPr>
-          <p:cNvPr id="12" name="Rectangle 11"/>
+          <p:cNvPr id="13" name="Rectangle 12"/>
           <p:cNvSpPr/>
           <p:nvPr/>
         </p:nvSpPr>
@@ -5724,7 +6102,7 @@
       </p:sp>
       <p:sp>
         <p:nvSpPr>
-          <p:cNvPr id="13" name="Rectangle 12"/>
+          <p:cNvPr id="14" name="Rectangle 13"/>
           <p:cNvSpPr/>
           <p:nvPr/>
         </p:nvSpPr>
@@ -5773,7 +6151,7 @@
       </p:sp>
       <p:sp>
         <p:nvSpPr>
-          <p:cNvPr id="14" name="TextBox 13"/>
+          <p:cNvPr id="15" name="TextBox 14"/>
           <p:cNvSpPr txBox="1"/>
           <p:nvPr/>
         </p:nvSpPr>
@@ -5815,7 +6193,7 @@
       </p:sp>
       <p:sp>
         <p:nvSpPr>
-          <p:cNvPr id="15" name="TextBox 14"/>
+          <p:cNvPr id="16" name="TextBox 15"/>
           <p:cNvSpPr txBox="1"/>
           <p:nvPr/>
         </p:nvSpPr>
@@ -5857,7 +6235,7 @@
       </p:sp>
       <p:sp>
         <p:nvSpPr>
-          <p:cNvPr id="16" name="Rectangle 15"/>
+          <p:cNvPr id="17" name="Rectangle 16"/>
           <p:cNvSpPr/>
           <p:nvPr/>
         </p:nvSpPr>
@@ -5906,7 +6284,7 @@
       </p:sp>
       <p:sp>
         <p:nvSpPr>
-          <p:cNvPr id="17" name="TextBox 16"/>
+          <p:cNvPr id="18" name="TextBox 17"/>
           <p:cNvSpPr txBox="1"/>
           <p:nvPr/>
         </p:nvSpPr>
@@ -5948,7 +6326,7 @@
       </p:sp>
       <p:sp>
         <p:nvSpPr>
-          <p:cNvPr id="18" name="TextBox 17"/>
+          <p:cNvPr id="19" name="TextBox 18"/>
           <p:cNvSpPr txBox="1"/>
           <p:nvPr/>
         </p:nvSpPr>
@@ -5983,14 +6361,14 @@
               <a:rPr>
                 <a:latin typeface="Inter"/>
               </a:rPr>
-              <a:t>Confidential — prepared for internal investment use · Data as of 2025-12-31</a:t>
-            </a:r>
-          </a:p>
-        </p:txBody>
-      </p:sp>
-      <p:sp>
-        <p:nvSpPr>
-          <p:cNvPr id="19" name="TextBox 18"/>
+              <a:t>Confidential — manager selection review · Data as of 2025-12-31</a:t>
+            </a:r>
+          </a:p>
+        </p:txBody>
+      </p:sp>
+      <p:sp>
+        <p:nvSpPr>
+          <p:cNvPr id="20" name="TextBox 19"/>
           <p:cNvSpPr txBox="1"/>
           <p:nvPr/>
         </p:nvSpPr>
@@ -6106,7 +6484,7 @@
         <p:spPr>
           <a:xfrm>
             <a:off x="640080" y="329184"/>
-            <a:ext cx="9875520" cy="182880"/>
+            <a:ext cx="5303520" cy="182880"/>
           </a:xfrm>
           <a:prstGeom prst="rect">
             <a:avLst/>
@@ -6147,6 +6525,48 @@
         </p:nvSpPr>
         <p:spPr>
           <a:xfrm>
+            <a:off x="5897880" y="310896"/>
+            <a:ext cx="4800600" cy="256032"/>
+          </a:xfrm>
+          <a:prstGeom prst="rect">
+            <a:avLst/>
+          </a:prstGeom>
+          <a:noFill/>
+        </p:spPr>
+        <p:txBody>
+          <a:bodyPr wrap="none" lIns="9144" rIns="9144" tIns="9144" bIns="9144" anchor="t">
+            <a:spAutoFit/>
+          </a:bodyPr>
+          <a:lstStyle/>
+          <a:p>
+            <a:pPr algn="r">
+              <a:spcAft>
+                <a:spcPts val="0"/>
+              </a:spcAft>
+              <a:defRPr sz="680" b="1">
+                <a:solidFill>
+                  <a:srgbClr val="4F6B00"/>
+                </a:solidFill>
+                <a:latin typeface="Inter"/>
+              </a:defRPr>
+            </a:pPr>
+            <a:r>
+              <a:rPr>
+                <a:latin typeface="Inter"/>
+              </a:rPr>
+              <a:t>Illustrative, Gradient Maintained — demo data, not the client's holdings or managers</a:t>
+            </a:r>
+          </a:p>
+        </p:txBody>
+      </p:sp>
+      <p:sp>
+        <p:nvSpPr>
+          <p:cNvPr id="5" name="TextBox 4"/>
+          <p:cNvSpPr txBox="1"/>
+          <p:nvPr/>
+        </p:nvSpPr>
+        <p:spPr>
+          <a:xfrm>
             <a:off x="640080" y="566928"/>
             <a:ext cx="10058400" cy="530352"/>
           </a:xfrm>
@@ -6183,7 +6603,7 @@
       </p:sp>
       <p:sp>
         <p:nvSpPr>
-          <p:cNvPr id="5" name="Rectangle 4"/>
+          <p:cNvPr id="6" name="Rectangle 5"/>
           <p:cNvSpPr/>
           <p:nvPr/>
         </p:nvSpPr>
@@ -6232,7 +6652,7 @@
       </p:sp>
       <p:sp>
         <p:nvSpPr>
-          <p:cNvPr id="6" name="Rectangle 5"/>
+          <p:cNvPr id="7" name="Rectangle 6"/>
           <p:cNvSpPr/>
           <p:nvPr/>
         </p:nvSpPr>
@@ -6281,7 +6701,7 @@
       </p:sp>
       <p:sp>
         <p:nvSpPr>
-          <p:cNvPr id="7" name="TextBox 6"/>
+          <p:cNvPr id="8" name="TextBox 7"/>
           <p:cNvSpPr txBox="1"/>
           <p:nvPr/>
         </p:nvSpPr>
@@ -6323,7 +6743,7 @@
       </p:sp>
       <p:sp>
         <p:nvSpPr>
-          <p:cNvPr id="8" name="Rectangle 7"/>
+          <p:cNvPr id="9" name="Rectangle 8"/>
           <p:cNvSpPr/>
           <p:nvPr/>
         </p:nvSpPr>
@@ -6372,7 +6792,7 @@
       </p:sp>
       <p:sp>
         <p:nvSpPr>
-          <p:cNvPr id="9" name="Rectangle 8"/>
+          <p:cNvPr id="10" name="Rectangle 9"/>
           <p:cNvSpPr/>
           <p:nvPr/>
         </p:nvSpPr>
@@ -6421,7 +6841,7 @@
       </p:sp>
       <p:sp>
         <p:nvSpPr>
-          <p:cNvPr id="10" name="TextBox 9"/>
+          <p:cNvPr id="11" name="TextBox 10"/>
           <p:cNvSpPr txBox="1"/>
           <p:nvPr/>
         </p:nvSpPr>
@@ -6463,7 +6883,7 @@
       </p:sp>
       <p:sp>
         <p:nvSpPr>
-          <p:cNvPr id="11" name="TextBox 10"/>
+          <p:cNvPr id="12" name="TextBox 11"/>
           <p:cNvSpPr txBox="1"/>
           <p:nvPr/>
         </p:nvSpPr>
@@ -6505,7 +6925,7 @@
       </p:sp>
       <p:sp>
         <p:nvSpPr>
-          <p:cNvPr id="12" name="Rectangle 11"/>
+          <p:cNvPr id="13" name="Rectangle 12"/>
           <p:cNvSpPr/>
           <p:nvPr/>
         </p:nvSpPr>
@@ -6554,7 +6974,7 @@
       </p:sp>
       <p:sp>
         <p:nvSpPr>
-          <p:cNvPr id="13" name="Rectangle 12"/>
+          <p:cNvPr id="14" name="Rectangle 13"/>
           <p:cNvSpPr/>
           <p:nvPr/>
         </p:nvSpPr>
@@ -6603,7 +7023,7 @@
       </p:sp>
       <p:sp>
         <p:nvSpPr>
-          <p:cNvPr id="14" name="TextBox 13"/>
+          <p:cNvPr id="15" name="TextBox 14"/>
           <p:cNvSpPr txBox="1"/>
           <p:nvPr/>
         </p:nvSpPr>
@@ -6645,7 +7065,7 @@
       </p:sp>
       <p:sp>
         <p:nvSpPr>
-          <p:cNvPr id="15" name="TextBox 14"/>
+          <p:cNvPr id="16" name="TextBox 15"/>
           <p:cNvSpPr txBox="1"/>
           <p:nvPr/>
         </p:nvSpPr>
@@ -6687,7 +7107,7 @@
       </p:sp>
       <p:sp>
         <p:nvSpPr>
-          <p:cNvPr id="16" name="Rectangle 15"/>
+          <p:cNvPr id="17" name="Rectangle 16"/>
           <p:cNvSpPr/>
           <p:nvPr/>
         </p:nvSpPr>
@@ -6736,7 +7156,7 @@
       </p:sp>
       <p:sp>
         <p:nvSpPr>
-          <p:cNvPr id="17" name="TextBox 16"/>
+          <p:cNvPr id="18" name="TextBox 17"/>
           <p:cNvSpPr txBox="1"/>
           <p:nvPr/>
         </p:nvSpPr>
@@ -6778,7 +7198,7 @@
       </p:sp>
       <p:sp>
         <p:nvSpPr>
-          <p:cNvPr id="18" name="TextBox 17"/>
+          <p:cNvPr id="19" name="TextBox 18"/>
           <p:cNvSpPr txBox="1"/>
           <p:nvPr/>
         </p:nvSpPr>
@@ -6813,14 +7233,14 @@
               <a:rPr>
                 <a:latin typeface="Inter"/>
               </a:rPr>
-              <a:t>Confidential — prepared for internal investment use · Data as of 2025-12-31</a:t>
-            </a:r>
-          </a:p>
-        </p:txBody>
-      </p:sp>
-      <p:sp>
-        <p:nvSpPr>
-          <p:cNvPr id="19" name="TextBox 18"/>
+              <a:t>Confidential — manager selection review · Data as of 2025-12-31</a:t>
+            </a:r>
+          </a:p>
+        </p:txBody>
+      </p:sp>
+      <p:sp>
+        <p:nvSpPr>
+          <p:cNvPr id="20" name="TextBox 19"/>
           <p:cNvSpPr txBox="1"/>
           <p:nvPr/>
         </p:nvSpPr>
@@ -6936,7 +7356,7 @@
         <p:spPr>
           <a:xfrm>
             <a:off x="640080" y="329184"/>
-            <a:ext cx="9875520" cy="182880"/>
+            <a:ext cx="5303520" cy="182880"/>
           </a:xfrm>
           <a:prstGeom prst="rect">
             <a:avLst/>
@@ -6977,6 +7397,48 @@
         </p:nvSpPr>
         <p:spPr>
           <a:xfrm>
+            <a:off x="5897880" y="310896"/>
+            <a:ext cx="4800600" cy="256032"/>
+          </a:xfrm>
+          <a:prstGeom prst="rect">
+            <a:avLst/>
+          </a:prstGeom>
+          <a:noFill/>
+        </p:spPr>
+        <p:txBody>
+          <a:bodyPr wrap="none" lIns="9144" rIns="9144" tIns="9144" bIns="9144" anchor="t">
+            <a:spAutoFit/>
+          </a:bodyPr>
+          <a:lstStyle/>
+          <a:p>
+            <a:pPr algn="r">
+              <a:spcAft>
+                <a:spcPts val="0"/>
+              </a:spcAft>
+              <a:defRPr sz="680" b="1">
+                <a:solidFill>
+                  <a:srgbClr val="4F6B00"/>
+                </a:solidFill>
+                <a:latin typeface="Inter"/>
+              </a:defRPr>
+            </a:pPr>
+            <a:r>
+              <a:rPr>
+                <a:latin typeface="Inter"/>
+              </a:rPr>
+              <a:t>Illustrative, Gradient Maintained — demo data, not the client's holdings or managers</a:t>
+            </a:r>
+          </a:p>
+        </p:txBody>
+      </p:sp>
+      <p:sp>
+        <p:nvSpPr>
+          <p:cNvPr id="5" name="TextBox 4"/>
+          <p:cNvSpPr txBox="1"/>
+          <p:nvPr/>
+        </p:nvSpPr>
+        <p:spPr>
+          <a:xfrm>
             <a:off x="640080" y="566928"/>
             <a:ext cx="10058400" cy="530352"/>
           </a:xfrm>
@@ -7013,7 +7475,7 @@
       </p:sp>
       <p:sp>
         <p:nvSpPr>
-          <p:cNvPr id="5" name="Rectangle 4"/>
+          <p:cNvPr id="6" name="Rectangle 5"/>
           <p:cNvSpPr/>
           <p:nvPr/>
         </p:nvSpPr>
@@ -7062,7 +7524,7 @@
       </p:sp>
       <p:sp>
         <p:nvSpPr>
-          <p:cNvPr id="6" name="Rectangle 5"/>
+          <p:cNvPr id="7" name="Rectangle 6"/>
           <p:cNvSpPr/>
           <p:nvPr/>
         </p:nvSpPr>
@@ -7111,7 +7573,7 @@
       </p:sp>
       <p:sp>
         <p:nvSpPr>
-          <p:cNvPr id="7" name="TextBox 6"/>
+          <p:cNvPr id="8" name="TextBox 7"/>
           <p:cNvSpPr txBox="1"/>
           <p:nvPr/>
         </p:nvSpPr>
@@ -7153,7 +7615,7 @@
       </p:sp>
       <p:sp>
         <p:nvSpPr>
-          <p:cNvPr id="8" name="Rectangle 7"/>
+          <p:cNvPr id="9" name="Rectangle 8"/>
           <p:cNvSpPr/>
           <p:nvPr/>
         </p:nvSpPr>
@@ -7202,7 +7664,7 @@
       </p:sp>
       <p:sp>
         <p:nvSpPr>
-          <p:cNvPr id="9" name="Rectangle 8"/>
+          <p:cNvPr id="10" name="Rectangle 9"/>
           <p:cNvSpPr/>
           <p:nvPr/>
         </p:nvSpPr>
@@ -7251,7 +7713,7 @@
       </p:sp>
       <p:sp>
         <p:nvSpPr>
-          <p:cNvPr id="10" name="TextBox 9"/>
+          <p:cNvPr id="11" name="TextBox 10"/>
           <p:cNvSpPr txBox="1"/>
           <p:nvPr/>
         </p:nvSpPr>
@@ -7293,7 +7755,7 @@
       </p:sp>
       <p:sp>
         <p:nvSpPr>
-          <p:cNvPr id="11" name="TextBox 10"/>
+          <p:cNvPr id="12" name="TextBox 11"/>
           <p:cNvSpPr txBox="1"/>
           <p:nvPr/>
         </p:nvSpPr>
@@ -7335,7 +7797,7 @@
       </p:sp>
       <p:sp>
         <p:nvSpPr>
-          <p:cNvPr id="12" name="Rectangle 11"/>
+          <p:cNvPr id="13" name="Rectangle 12"/>
           <p:cNvSpPr/>
           <p:nvPr/>
         </p:nvSpPr>
@@ -7384,7 +7846,7 @@
       </p:sp>
       <p:sp>
         <p:nvSpPr>
-          <p:cNvPr id="13" name="Rectangle 12"/>
+          <p:cNvPr id="14" name="Rectangle 13"/>
           <p:cNvSpPr/>
           <p:nvPr/>
         </p:nvSpPr>
@@ -7433,7 +7895,7 @@
       </p:sp>
       <p:sp>
         <p:nvSpPr>
-          <p:cNvPr id="14" name="TextBox 13"/>
+          <p:cNvPr id="15" name="TextBox 14"/>
           <p:cNvSpPr txBox="1"/>
           <p:nvPr/>
         </p:nvSpPr>
@@ -7475,7 +7937,7 @@
       </p:sp>
       <p:sp>
         <p:nvSpPr>
-          <p:cNvPr id="15" name="TextBox 14"/>
+          <p:cNvPr id="16" name="TextBox 15"/>
           <p:cNvSpPr txBox="1"/>
           <p:nvPr/>
         </p:nvSpPr>
@@ -7517,7 +7979,7 @@
       </p:sp>
       <p:sp>
         <p:nvSpPr>
-          <p:cNvPr id="16" name="Rectangle 15"/>
+          <p:cNvPr id="17" name="Rectangle 16"/>
           <p:cNvSpPr/>
           <p:nvPr/>
         </p:nvSpPr>
@@ -7566,7 +8028,7 @@
       </p:sp>
       <p:sp>
         <p:nvSpPr>
-          <p:cNvPr id="17" name="TextBox 16"/>
+          <p:cNvPr id="18" name="TextBox 17"/>
           <p:cNvSpPr txBox="1"/>
           <p:nvPr/>
         </p:nvSpPr>
@@ -7608,7 +8070,7 @@
       </p:sp>
       <p:sp>
         <p:nvSpPr>
-          <p:cNvPr id="18" name="TextBox 17"/>
+          <p:cNvPr id="19" name="TextBox 18"/>
           <p:cNvSpPr txBox="1"/>
           <p:nvPr/>
         </p:nvSpPr>
@@ -7643,14 +8105,14 @@
               <a:rPr>
                 <a:latin typeface="Inter"/>
               </a:rPr>
-              <a:t>Confidential — prepared for internal investment use · Data as of 2025-12-31</a:t>
-            </a:r>
-          </a:p>
-        </p:txBody>
-      </p:sp>
-      <p:sp>
-        <p:nvSpPr>
-          <p:cNvPr id="19" name="TextBox 18"/>
+              <a:t>Confidential — manager selection review · Data as of 2025-12-31</a:t>
+            </a:r>
+          </a:p>
+        </p:txBody>
+      </p:sp>
+      <p:sp>
+        <p:nvSpPr>
+          <p:cNvPr id="20" name="TextBox 19"/>
           <p:cNvSpPr txBox="1"/>
           <p:nvPr/>
         </p:nvSpPr>
@@ -7766,7 +8228,7 @@
         <p:spPr>
           <a:xfrm>
             <a:off x="640080" y="329184"/>
-            <a:ext cx="9875520" cy="182880"/>
+            <a:ext cx="5303520" cy="182880"/>
           </a:xfrm>
           <a:prstGeom prst="rect">
             <a:avLst/>
@@ -7807,6 +8269,48 @@
         </p:nvSpPr>
         <p:spPr>
           <a:xfrm>
+            <a:off x="5897880" y="310896"/>
+            <a:ext cx="4800600" cy="256032"/>
+          </a:xfrm>
+          <a:prstGeom prst="rect">
+            <a:avLst/>
+          </a:prstGeom>
+          <a:noFill/>
+        </p:spPr>
+        <p:txBody>
+          <a:bodyPr wrap="none" lIns="9144" rIns="9144" tIns="9144" bIns="9144" anchor="t">
+            <a:spAutoFit/>
+          </a:bodyPr>
+          <a:lstStyle/>
+          <a:p>
+            <a:pPr algn="r">
+              <a:spcAft>
+                <a:spcPts val="0"/>
+              </a:spcAft>
+              <a:defRPr sz="680" b="1">
+                <a:solidFill>
+                  <a:srgbClr val="4F6B00"/>
+                </a:solidFill>
+                <a:latin typeface="Inter"/>
+              </a:defRPr>
+            </a:pPr>
+            <a:r>
+              <a:rPr>
+                <a:latin typeface="Inter"/>
+              </a:rPr>
+              <a:t>Illustrative, Gradient Maintained — demo data, not the client's holdings or managers</a:t>
+            </a:r>
+          </a:p>
+        </p:txBody>
+      </p:sp>
+      <p:sp>
+        <p:nvSpPr>
+          <p:cNvPr id="5" name="TextBox 4"/>
+          <p:cNvSpPr txBox="1"/>
+          <p:nvPr/>
+        </p:nvSpPr>
+        <p:spPr>
+          <a:xfrm>
             <a:off x="640080" y="566928"/>
             <a:ext cx="10058400" cy="530352"/>
           </a:xfrm>
@@ -7843,7 +8347,7 @@
       </p:sp>
       <p:sp>
         <p:nvSpPr>
-          <p:cNvPr id="5" name="Rectangle 4"/>
+          <p:cNvPr id="6" name="Rectangle 5"/>
           <p:cNvSpPr/>
           <p:nvPr/>
         </p:nvSpPr>
@@ -7892,7 +8396,7 @@
       </p:sp>
       <p:sp>
         <p:nvSpPr>
-          <p:cNvPr id="6" name="Rectangle 5"/>
+          <p:cNvPr id="7" name="Rectangle 6"/>
           <p:cNvSpPr/>
           <p:nvPr/>
         </p:nvSpPr>
@@ -7941,7 +8445,7 @@
       </p:sp>
       <p:sp>
         <p:nvSpPr>
-          <p:cNvPr id="7" name="TextBox 6"/>
+          <p:cNvPr id="8" name="TextBox 7"/>
           <p:cNvSpPr txBox="1"/>
           <p:nvPr/>
         </p:nvSpPr>
@@ -7983,7 +8487,7 @@
       </p:sp>
       <p:sp>
         <p:nvSpPr>
-          <p:cNvPr id="8" name="TextBox 7"/>
+          <p:cNvPr id="9" name="TextBox 8"/>
           <p:cNvSpPr txBox="1"/>
           <p:nvPr/>
         </p:nvSpPr>
@@ -8032,7 +8536,7 @@
       </p:sp>
       <p:sp>
         <p:nvSpPr>
-          <p:cNvPr id="9" name="Rectangle 8"/>
+          <p:cNvPr id="10" name="Rectangle 9"/>
           <p:cNvSpPr/>
           <p:nvPr/>
         </p:nvSpPr>
@@ -8081,7 +8585,7 @@
       </p:sp>
       <p:sp>
         <p:nvSpPr>
-          <p:cNvPr id="10" name="TextBox 9"/>
+          <p:cNvPr id="11" name="TextBox 10"/>
           <p:cNvSpPr txBox="1"/>
           <p:nvPr/>
         </p:nvSpPr>
@@ -8123,7 +8627,7 @@
       </p:sp>
       <p:sp>
         <p:nvSpPr>
-          <p:cNvPr id="11" name="TextBox 10"/>
+          <p:cNvPr id="12" name="TextBox 11"/>
           <p:cNvSpPr txBox="1"/>
           <p:nvPr/>
         </p:nvSpPr>
@@ -8158,14 +8662,14 @@
               <a:rPr>
                 <a:latin typeface="Inter"/>
               </a:rPr>
-              <a:t>Confidential — prepared for internal investment use · Data as of 2025-12-31</a:t>
-            </a:r>
-          </a:p>
-        </p:txBody>
-      </p:sp>
-      <p:sp>
-        <p:nvSpPr>
-          <p:cNvPr id="12" name="TextBox 11"/>
+              <a:t>Confidential — manager selection review · Data as of 2025-12-31</a:t>
+            </a:r>
+          </a:p>
+        </p:txBody>
+      </p:sp>
+      <p:sp>
+        <p:nvSpPr>
+          <p:cNvPr id="13" name="TextBox 12"/>
           <p:cNvSpPr txBox="1"/>
           <p:nvPr/>
         </p:nvSpPr>
@@ -8281,7 +8785,7 @@
         <p:spPr>
           <a:xfrm>
             <a:off x="640080" y="329184"/>
-            <a:ext cx="9875520" cy="182880"/>
+            <a:ext cx="5303520" cy="182880"/>
           </a:xfrm>
           <a:prstGeom prst="rect">
             <a:avLst/>
@@ -8309,7 +8813,7 @@
               <a:rPr>
                 <a:latin typeface="Inter"/>
               </a:rPr>
-              <a:t>SAVED FICTIONAL TEST EVIDENCE</a:t>
+              <a:t>SAVED ILLUSTRATIVE SAMPLE EVIDENCE</a:t>
             </a:r>
           </a:p>
         </p:txBody>
@@ -8317,6 +8821,48 @@
       <p:sp>
         <p:nvSpPr>
           <p:cNvPr id="4" name="TextBox 3"/>
+          <p:cNvSpPr txBox="1"/>
+          <p:nvPr/>
+        </p:nvSpPr>
+        <p:spPr>
+          <a:xfrm>
+            <a:off x="5897880" y="310896"/>
+            <a:ext cx="4800600" cy="256032"/>
+          </a:xfrm>
+          <a:prstGeom prst="rect">
+            <a:avLst/>
+          </a:prstGeom>
+          <a:noFill/>
+        </p:spPr>
+        <p:txBody>
+          <a:bodyPr wrap="none" lIns="9144" rIns="9144" tIns="9144" bIns="9144" anchor="t">
+            <a:spAutoFit/>
+          </a:bodyPr>
+          <a:lstStyle/>
+          <a:p>
+            <a:pPr algn="r">
+              <a:spcAft>
+                <a:spcPts val="0"/>
+              </a:spcAft>
+              <a:defRPr sz="680" b="1">
+                <a:solidFill>
+                  <a:srgbClr val="4F6B00"/>
+                </a:solidFill>
+                <a:latin typeface="Inter"/>
+              </a:defRPr>
+            </a:pPr>
+            <a:r>
+              <a:rPr>
+                <a:latin typeface="Inter"/>
+              </a:rPr>
+              <a:t>Illustrative, Gradient Maintained — demo data, not the client's holdings or managers</a:t>
+            </a:r>
+          </a:p>
+        </p:txBody>
+      </p:sp>
+      <p:sp>
+        <p:nvSpPr>
+          <p:cNvPr id="5" name="TextBox 4"/>
           <p:cNvSpPr txBox="1"/>
           <p:nvPr/>
         </p:nvSpPr>
@@ -8358,7 +8904,7 @@
       </p:sp>
       <p:sp>
         <p:nvSpPr>
-          <p:cNvPr id="5" name="Rectangle 4"/>
+          <p:cNvPr id="6" name="Rectangle 5"/>
           <p:cNvSpPr/>
           <p:nvPr/>
         </p:nvSpPr>
@@ -8407,7 +8953,7 @@
       </p:sp>
       <p:sp>
         <p:nvSpPr>
-          <p:cNvPr id="6" name="Rectangle 5"/>
+          <p:cNvPr id="7" name="Rectangle 6"/>
           <p:cNvSpPr/>
           <p:nvPr/>
         </p:nvSpPr>
@@ -8456,7 +9002,7 @@
       </p:sp>
       <p:sp>
         <p:nvSpPr>
-          <p:cNvPr id="7" name="TextBox 6"/>
+          <p:cNvPr id="8" name="TextBox 7"/>
           <p:cNvSpPr txBox="1"/>
           <p:nvPr/>
         </p:nvSpPr>
@@ -8498,7 +9044,7 @@
       </p:sp>
       <p:graphicFrame>
         <p:nvGraphicFramePr>
-          <p:cNvPr id="8" name="Table 7"/>
+          <p:cNvPr id="9" name="Table 8"/>
           <p:cNvGraphicFramePr>
             <a:graphicFrameLocks noGrp="1"/>
           </p:cNvGraphicFramePr>
@@ -8506,7 +9052,7 @@
         </p:nvGraphicFramePr>
         <p:xfrm>
           <a:off x="640080" y="1325880"/>
-          <a:ext cx="10908792" cy="1169662"/>
+          <a:ext cx="10908792" cy="968494"/>
         </p:xfrm>
         <a:graphic>
           <a:graphicData uri="http://schemas.openxmlformats.org/drawingml/2006/table">
@@ -8525,7 +9071,7 @@
                 <a:gridCol w="1112139"/>
                 <a:gridCol w="1112139"/>
               </a:tblGrid>
-              <a:tr h="584831">
+              <a:tr h="484247">
                 <a:tc>
                   <a:txBody>
                     <a:bodyPr/>
@@ -8770,7 +9316,7 @@
                   </a:tcPr>
                 </a:tc>
               </a:tr>
-              <a:tr h="584831">
+              <a:tr h="484247">
                 <a:tc>
                   <a:txBody>
                     <a:bodyPr/>
@@ -8896,7 +9442,7 @@
                         <a:rPr>
                           <a:latin typeface="Inter"/>
                         </a:rPr>
-                        <a:t>fixture=true</a:t>
+                        <a:t>illustrative sample</a:t>
                       </a:r>
                     </a:p>
                   </a:txBody>
@@ -8950,7 +9496,7 @@
                         <a:rPr>
                           <a:latin typeface="Inter"/>
                         </a:rPr>
-                        <a:t>Gradient-governed TEST evidence</a:t>
+                        <a:t>Gradient-governed review evidence</a:t>
                       </a:r>
                     </a:p>
                   </a:txBody>
@@ -9021,7 +9567,49 @@
       </p:graphicFrame>
       <p:sp>
         <p:nvSpPr>
-          <p:cNvPr id="9" name="Rectangle 8"/>
+          <p:cNvPr id="10" name="TextBox 9"/>
+          <p:cNvSpPr txBox="1"/>
+          <p:nvPr/>
+        </p:nvSpPr>
+        <p:spPr>
+          <a:xfrm>
+            <a:off x="640080" y="2312662"/>
+            <a:ext cx="10908792" cy="164592"/>
+          </a:xfrm>
+          <a:prstGeom prst="rect">
+            <a:avLst/>
+          </a:prstGeom>
+          <a:noFill/>
+        </p:spPr>
+        <p:txBody>
+          <a:bodyPr wrap="none" lIns="9144" rIns="9144" tIns="9144" bIns="9144" anchor="t">
+            <a:spAutoFit/>
+          </a:bodyPr>
+          <a:lstStyle/>
+          <a:p>
+            <a:pPr algn="l">
+              <a:spcAft>
+                <a:spcPts val="0"/>
+              </a:spcAft>
+              <a:defRPr sz="680" b="0">
+                <a:solidFill>
+                  <a:srgbClr val="8A94A1"/>
+                </a:solidFill>
+                <a:latin typeface="Inter"/>
+              </a:defRPr>
+            </a:pPr>
+            <a:r>
+              <a:rPr>
+                <a:latin typeface="Inter"/>
+              </a:rPr>
+              <a:t>Illustrative, Gradient Maintained — demo data, not the client's holdings or managers. All organizations, portfolios, managers and results in this public example are illustrative.</a:t>
+            </a:r>
+          </a:p>
+        </p:txBody>
+      </p:sp>
+      <p:sp>
+        <p:nvSpPr>
+          <p:cNvPr id="11" name="Rectangle 10"/>
           <p:cNvSpPr/>
           <p:nvPr/>
         </p:nvSpPr>
@@ -9070,7 +9658,7 @@
       </p:sp>
       <p:sp>
         <p:nvSpPr>
-          <p:cNvPr id="10" name="Rectangle 9"/>
+          <p:cNvPr id="12" name="Rectangle 11"/>
           <p:cNvSpPr/>
           <p:nvPr/>
         </p:nvSpPr>
@@ -9119,7 +9707,7 @@
       </p:sp>
       <p:sp>
         <p:nvSpPr>
-          <p:cNvPr id="11" name="TextBox 10"/>
+          <p:cNvPr id="13" name="TextBox 12"/>
           <p:cNvSpPr txBox="1"/>
           <p:nvPr/>
         </p:nvSpPr>
@@ -9161,7 +9749,7 @@
       </p:sp>
       <p:sp>
         <p:nvSpPr>
-          <p:cNvPr id="12" name="TextBox 11"/>
+          <p:cNvPr id="14" name="TextBox 13"/>
           <p:cNvSpPr txBox="1"/>
           <p:nvPr/>
         </p:nvSpPr>
@@ -9203,7 +9791,7 @@
       </p:sp>
       <p:sp>
         <p:nvSpPr>
-          <p:cNvPr id="13" name="Rectangle 12"/>
+          <p:cNvPr id="15" name="Rectangle 14"/>
           <p:cNvSpPr/>
           <p:nvPr/>
         </p:nvSpPr>
@@ -9252,7 +9840,7 @@
       </p:sp>
       <p:sp>
         <p:nvSpPr>
-          <p:cNvPr id="14" name="Rectangle 13"/>
+          <p:cNvPr id="16" name="Rectangle 15"/>
           <p:cNvSpPr/>
           <p:nvPr/>
         </p:nvSpPr>
@@ -9301,7 +9889,7 @@
       </p:sp>
       <p:sp>
         <p:nvSpPr>
-          <p:cNvPr id="15" name="TextBox 14"/>
+          <p:cNvPr id="17" name="TextBox 16"/>
           <p:cNvSpPr txBox="1"/>
           <p:nvPr/>
         </p:nvSpPr>
@@ -9343,7 +9931,7 @@
       </p:sp>
       <p:sp>
         <p:nvSpPr>
-          <p:cNvPr id="16" name="TextBox 15"/>
+          <p:cNvPr id="18" name="TextBox 17"/>
           <p:cNvSpPr txBox="1"/>
           <p:nvPr/>
         </p:nvSpPr>
@@ -9385,7 +9973,7 @@
       </p:sp>
       <p:sp>
         <p:nvSpPr>
-          <p:cNvPr id="17" name="Rectangle 16"/>
+          <p:cNvPr id="19" name="Rectangle 18"/>
           <p:cNvSpPr/>
           <p:nvPr/>
         </p:nvSpPr>
@@ -9434,7 +10022,7 @@
       </p:sp>
       <p:sp>
         <p:nvSpPr>
-          <p:cNvPr id="18" name="TextBox 17"/>
+          <p:cNvPr id="20" name="TextBox 19"/>
           <p:cNvSpPr txBox="1"/>
           <p:nvPr/>
         </p:nvSpPr>
@@ -9476,7 +10064,7 @@
       </p:sp>
       <p:sp>
         <p:nvSpPr>
-          <p:cNvPr id="19" name="TextBox 18"/>
+          <p:cNvPr id="21" name="TextBox 20"/>
           <p:cNvSpPr txBox="1"/>
           <p:nvPr/>
         </p:nvSpPr>
@@ -9511,14 +10099,14 @@
               <a:rPr>
                 <a:latin typeface="Inter"/>
               </a:rPr>
-              <a:t>Confidential — prepared for internal investment use · Data as of 2025-12-31</a:t>
-            </a:r>
-          </a:p>
-        </p:txBody>
-      </p:sp>
-      <p:sp>
-        <p:nvSpPr>
-          <p:cNvPr id="20" name="TextBox 19"/>
+              <a:t>Confidential — manager selection review · Data as of 2025-12-31</a:t>
+            </a:r>
+          </a:p>
+        </p:txBody>
+      </p:sp>
+      <p:sp>
+        <p:nvSpPr>
+          <p:cNvPr id="22" name="TextBox 21"/>
           <p:cNvSpPr txBox="1"/>
           <p:nvPr/>
         </p:nvSpPr>
@@ -9634,7 +10222,7 @@
         <p:spPr>
           <a:xfrm>
             <a:off x="640080" y="329184"/>
-            <a:ext cx="9875520" cy="182880"/>
+            <a:ext cx="5303520" cy="182880"/>
           </a:xfrm>
           <a:prstGeom prst="rect">
             <a:avLst/>
@@ -9662,7 +10250,7 @@
               <a:rPr>
                 <a:latin typeface="Inter"/>
               </a:rPr>
-              <a:t>SAVED FICTIONAL TEST EVIDENCE</a:t>
+              <a:t>SAVED ILLUSTRATIVE SAMPLE EVIDENCE</a:t>
             </a:r>
           </a:p>
         </p:txBody>
@@ -9670,6 +10258,48 @@
       <p:sp>
         <p:nvSpPr>
           <p:cNvPr id="4" name="TextBox 3"/>
+          <p:cNvSpPr txBox="1"/>
+          <p:nvPr/>
+        </p:nvSpPr>
+        <p:spPr>
+          <a:xfrm>
+            <a:off x="5897880" y="310896"/>
+            <a:ext cx="4800600" cy="256032"/>
+          </a:xfrm>
+          <a:prstGeom prst="rect">
+            <a:avLst/>
+          </a:prstGeom>
+          <a:noFill/>
+        </p:spPr>
+        <p:txBody>
+          <a:bodyPr wrap="none" lIns="9144" rIns="9144" tIns="9144" bIns="9144" anchor="t">
+            <a:spAutoFit/>
+          </a:bodyPr>
+          <a:lstStyle/>
+          <a:p>
+            <a:pPr algn="r">
+              <a:spcAft>
+                <a:spcPts val="0"/>
+              </a:spcAft>
+              <a:defRPr sz="680" b="1">
+                <a:solidFill>
+                  <a:srgbClr val="4F6B00"/>
+                </a:solidFill>
+                <a:latin typeface="Inter"/>
+              </a:defRPr>
+            </a:pPr>
+            <a:r>
+              <a:rPr>
+                <a:latin typeface="Inter"/>
+              </a:rPr>
+              <a:t>Illustrative, Gradient Maintained — demo data, not the client's holdings or managers</a:t>
+            </a:r>
+          </a:p>
+        </p:txBody>
+      </p:sp>
+      <p:sp>
+        <p:nvSpPr>
+          <p:cNvPr id="5" name="TextBox 4"/>
           <p:cNvSpPr txBox="1"/>
           <p:nvPr/>
         </p:nvSpPr>
@@ -9711,7 +10341,7 @@
       </p:sp>
       <p:sp>
         <p:nvSpPr>
-          <p:cNvPr id="5" name="Rectangle 4"/>
+          <p:cNvPr id="6" name="Rectangle 5"/>
           <p:cNvSpPr/>
           <p:nvPr/>
         </p:nvSpPr>
@@ -9760,7 +10390,7 @@
       </p:sp>
       <p:sp>
         <p:nvSpPr>
-          <p:cNvPr id="6" name="Rectangle 5"/>
+          <p:cNvPr id="7" name="Rectangle 6"/>
           <p:cNvSpPr/>
           <p:nvPr/>
         </p:nvSpPr>
@@ -9809,7 +10439,7 @@
       </p:sp>
       <p:sp>
         <p:nvSpPr>
-          <p:cNvPr id="7" name="TextBox 6"/>
+          <p:cNvPr id="8" name="TextBox 7"/>
           <p:cNvSpPr txBox="1"/>
           <p:nvPr/>
         </p:nvSpPr>
@@ -9851,7 +10481,7 @@
       </p:sp>
       <p:sp>
         <p:nvSpPr>
-          <p:cNvPr id="8" name="Rectangle 7"/>
+          <p:cNvPr id="9" name="Rectangle 8"/>
           <p:cNvSpPr/>
           <p:nvPr/>
         </p:nvSpPr>
@@ -9900,7 +10530,7 @@
       </p:sp>
       <p:sp>
         <p:nvSpPr>
-          <p:cNvPr id="9" name="Rectangle 8"/>
+          <p:cNvPr id="10" name="Rectangle 9"/>
           <p:cNvSpPr/>
           <p:nvPr/>
         </p:nvSpPr>
@@ -9949,7 +10579,7 @@
       </p:sp>
       <p:sp>
         <p:nvSpPr>
-          <p:cNvPr id="10" name="TextBox 9"/>
+          <p:cNvPr id="11" name="TextBox 10"/>
           <p:cNvSpPr txBox="1"/>
           <p:nvPr/>
         </p:nvSpPr>
@@ -9991,7 +10621,7 @@
       </p:sp>
       <p:sp>
         <p:nvSpPr>
-          <p:cNvPr id="11" name="TextBox 10"/>
+          <p:cNvPr id="12" name="TextBox 11"/>
           <p:cNvSpPr txBox="1"/>
           <p:nvPr/>
         </p:nvSpPr>
@@ -10033,7 +10663,7 @@
       </p:sp>
       <p:sp>
         <p:nvSpPr>
-          <p:cNvPr id="12" name="Rectangle 11"/>
+          <p:cNvPr id="13" name="Rectangle 12"/>
           <p:cNvSpPr/>
           <p:nvPr/>
         </p:nvSpPr>
@@ -10082,7 +10712,7 @@
       </p:sp>
       <p:sp>
         <p:nvSpPr>
-          <p:cNvPr id="13" name="TextBox 12"/>
+          <p:cNvPr id="14" name="TextBox 13"/>
           <p:cNvSpPr txBox="1"/>
           <p:nvPr/>
         </p:nvSpPr>
@@ -10124,7 +10754,7 @@
       </p:sp>
       <p:sp>
         <p:nvSpPr>
-          <p:cNvPr id="14" name="TextBox 13"/>
+          <p:cNvPr id="15" name="TextBox 14"/>
           <p:cNvSpPr txBox="1"/>
           <p:nvPr/>
         </p:nvSpPr>
@@ -10159,14 +10789,14 @@
               <a:rPr>
                 <a:latin typeface="Inter"/>
               </a:rPr>
-              <a:t>Confidential — prepared for internal investment use · Data as of 2025-12-31</a:t>
-            </a:r>
-          </a:p>
-        </p:txBody>
-      </p:sp>
-      <p:sp>
-        <p:nvSpPr>
-          <p:cNvPr id="15" name="TextBox 14"/>
+              <a:t>Confidential — manager selection review · Data as of 2025-12-31</a:t>
+            </a:r>
+          </a:p>
+        </p:txBody>
+      </p:sp>
+      <p:sp>
+        <p:nvSpPr>
+          <p:cNvPr id="16" name="TextBox 15"/>
           <p:cNvSpPr txBox="1"/>
           <p:nvPr/>
         </p:nvSpPr>

</xml_diff>

<commit_message>
feat: release GradientCIO plugin 5.7.0 (#41)
Co-authored-by: shbryx <sbryant@gradientao.com>
Co-authored-by: Cursor <cursoragent@cursor.com>
</commit_message>
<xml_diff>
--- a/plugins/gradient-cio/assets/examples/gradient-idd-manager-performance-compare.pptx
+++ b/plugins/gradient-cio/assets/examples/gradient-idd-manager-performance-compare.pptx
@@ -2935,7 +2935,7 @@
         </p:nvSpPr>
         <p:spPr>
           <a:xfrm>
-            <a:off x="685800" y="1828800"/>
+            <a:off x="685800" y="1664208"/>
             <a:ext cx="9966960" cy="274320"/>
           </a:xfrm>
           <a:prstGeom prst="rect">
@@ -2953,7 +2953,7 @@
               <a:spcAft>
                 <a:spcPts val="0"/>
               </a:spcAft>
-              <a:defRPr sz="900" b="1">
+              <a:defRPr sz="850" b="1">
                 <a:solidFill>
                   <a:srgbClr val="C6F432"/>
                 </a:solidFill>
@@ -2977,7 +2977,7 @@
         </p:nvSpPr>
         <p:spPr>
           <a:xfrm>
-            <a:off x="685800" y="2176272"/>
+            <a:off x="685800" y="2011680"/>
             <a:ext cx="9966960" cy="1234440"/>
           </a:xfrm>
           <a:prstGeom prst="rect">
@@ -2995,7 +2995,7 @@
               <a:spcAft>
                 <a:spcPts val="0"/>
               </a:spcAft>
-              <a:defRPr sz="3400" b="1">
+              <a:defRPr sz="3300" b="1">
                 <a:solidFill>
                   <a:srgbClr val="FFFFFF"/>
                 </a:solidFill>
@@ -3006,7 +3006,7 @@
               <a:rPr>
                 <a:latin typeface="Inter"/>
               </a:rPr>
-              <a:t>Northstar Manager Comparison (TEST)</a:t>
+              <a:t>Northstar Manager Comparison</a:t>
             </a:r>
           </a:p>
         </p:txBody>
@@ -3019,8 +3019,8 @@
         </p:nvSpPr>
         <p:spPr>
           <a:xfrm>
-            <a:off x="685800" y="3456432"/>
-            <a:ext cx="9692640" cy="640080"/>
+            <a:off x="685800" y="3273552"/>
+            <a:ext cx="9692640" cy="594360"/>
           </a:xfrm>
           <a:prstGeom prst="rect">
             <a:avLst/>
@@ -3037,7 +3037,7 @@
               <a:spcAft>
                 <a:spcPts val="0"/>
               </a:spcAft>
-              <a:defRPr sz="1500" b="0">
+              <a:defRPr sz="1400" b="0">
                 <a:solidFill>
                   <a:srgbClr val="9AA5B1"/>
                 </a:solidFill>
@@ -3048,7 +3048,7 @@
               <a:rPr>
                 <a:latin typeface="Inter"/>
               </a:rPr>
-              <a:t>Governed return evidence</a:t>
+              <a:t>Comparative performance and benchmark assessment</a:t>
             </a:r>
           </a:p>
         </p:txBody>
@@ -3061,8 +3061,8 @@
         </p:nvSpPr>
         <p:spPr>
           <a:xfrm>
-            <a:off x="685800" y="4251960"/>
-            <a:ext cx="1005840" cy="54864"/>
+            <a:off x="685800" y="4005072"/>
+            <a:ext cx="822960" cy="45720"/>
           </a:xfrm>
           <a:prstGeom prst="rect">
             <a:avLst/>
@@ -3110,8 +3110,8 @@
         </p:nvSpPr>
         <p:spPr>
           <a:xfrm>
-            <a:off x="685800" y="4572000"/>
-            <a:ext cx="3063240" cy="182880"/>
+            <a:off x="685800" y="4315968"/>
+            <a:ext cx="4709160" cy="182880"/>
           </a:xfrm>
           <a:prstGeom prst="rect">
             <a:avLst/>
@@ -3139,7 +3139,7 @@
               <a:rPr>
                 <a:latin typeface="Inter"/>
               </a:rPr>
-              <a:t>MODE</a:t>
+              <a:t>REVIEW</a:t>
             </a:r>
           </a:p>
         </p:txBody>
@@ -3152,8 +3152,8 @@
         </p:nvSpPr>
         <p:spPr>
           <a:xfrm>
-            <a:off x="685800" y="4773168"/>
-            <a:ext cx="3063240" cy="320040"/>
+            <a:off x="685800" y="4507992"/>
+            <a:ext cx="4709160" cy="310896"/>
           </a:xfrm>
           <a:prstGeom prst="rect">
             <a:avLst/>
@@ -3181,7 +3181,7 @@
               <a:rPr>
                 <a:latin typeface="Inter"/>
               </a:rPr>
-              <a:t>Compare</a:t>
+              <a:t>Manager comparison</a:t>
             </a:r>
           </a:p>
         </p:txBody>
@@ -3194,8 +3194,8 @@
         </p:nvSpPr>
         <p:spPr>
           <a:xfrm>
-            <a:off x="4160520" y="4572000"/>
-            <a:ext cx="3063240" cy="182880"/>
+            <a:off x="5852160" y="4315968"/>
+            <a:ext cx="4709160" cy="182880"/>
           </a:xfrm>
           <a:prstGeom prst="rect">
             <a:avLst/>
@@ -3223,7 +3223,7 @@
               <a:rPr>
                 <a:latin typeface="Inter"/>
               </a:rPr>
-              <a:t>SCOPE</a:t>
+              <a:t>EVIDENCE</a:t>
             </a:r>
           </a:p>
         </p:txBody>
@@ -3236,8 +3236,8 @@
         </p:nvSpPr>
         <p:spPr>
           <a:xfrm>
-            <a:off x="4160520" y="4773168"/>
-            <a:ext cx="3063240" cy="320040"/>
+            <a:off x="5852160" y="4507992"/>
+            <a:ext cx="4709160" cy="310896"/>
           </a:xfrm>
           <a:prstGeom prst="rect">
             <a:avLst/>
@@ -3265,21 +3265,189 @@
               <a:rPr>
                 <a:latin typeface="Inter"/>
               </a:rPr>
-              <a:t>Fictional TEST managers</a:t>
-            </a:r>
-          </a:p>
-        </p:txBody>
-      </p:sp>
-      <p:sp>
-        <p:nvSpPr>
-          <p:cNvPr id="13" name="Rectangle 12"/>
+              <a:t>Governed return series</a:t>
+            </a:r>
+          </a:p>
+        </p:txBody>
+      </p:sp>
+      <p:sp>
+        <p:nvSpPr>
+          <p:cNvPr id="13" name="TextBox 12"/>
+          <p:cNvSpPr txBox="1"/>
+          <p:nvPr/>
+        </p:nvSpPr>
+        <p:spPr>
+          <a:xfrm>
+            <a:off x="685800" y="4937759"/>
+            <a:ext cx="4709160" cy="182880"/>
+          </a:xfrm>
+          <a:prstGeom prst="rect">
+            <a:avLst/>
+          </a:prstGeom>
+          <a:noFill/>
+        </p:spPr>
+        <p:txBody>
+          <a:bodyPr wrap="none" lIns="9144" rIns="9144" tIns="9144" bIns="9144" anchor="t">
+            <a:spAutoFit/>
+          </a:bodyPr>
+          <a:lstStyle/>
+          <a:p>
+            <a:pPr algn="l">
+              <a:spcAft>
+                <a:spcPts val="0"/>
+              </a:spcAft>
+              <a:defRPr sz="700" b="1">
+                <a:solidFill>
+                  <a:srgbClr val="8A94A1"/>
+                </a:solidFill>
+                <a:latin typeface="Inter"/>
+              </a:defRPr>
+            </a:pPr>
+            <a:r>
+              <a:rPr>
+                <a:latin typeface="Inter"/>
+              </a:rPr>
+              <a:t>AUDIENCE</a:t>
+            </a:r>
+          </a:p>
+        </p:txBody>
+      </p:sp>
+      <p:sp>
+        <p:nvSpPr>
+          <p:cNvPr id="14" name="TextBox 13"/>
+          <p:cNvSpPr txBox="1"/>
+          <p:nvPr/>
+        </p:nvSpPr>
+        <p:spPr>
+          <a:xfrm>
+            <a:off x="685800" y="5129783"/>
+            <a:ext cx="4709160" cy="310896"/>
+          </a:xfrm>
+          <a:prstGeom prst="rect">
+            <a:avLst/>
+          </a:prstGeom>
+          <a:noFill/>
+        </p:spPr>
+        <p:txBody>
+          <a:bodyPr wrap="none" lIns="9144" rIns="9144" tIns="9144" bIns="9144" anchor="t">
+            <a:spAutoFit/>
+          </a:bodyPr>
+          <a:lstStyle/>
+          <a:p>
+            <a:pPr algn="l">
+              <a:spcAft>
+                <a:spcPts val="0"/>
+              </a:spcAft>
+              <a:defRPr sz="1000" b="1">
+                <a:solidFill>
+                  <a:srgbClr val="FFFFFF"/>
+                </a:solidFill>
+                <a:latin typeface="Inter"/>
+              </a:defRPr>
+            </a:pPr>
+            <a:r>
+              <a:rPr>
+                <a:latin typeface="Inter"/>
+              </a:rPr>
+              <a:t>Investment Committee</a:t>
+            </a:r>
+          </a:p>
+        </p:txBody>
+      </p:sp>
+      <p:sp>
+        <p:nvSpPr>
+          <p:cNvPr id="15" name="TextBox 14"/>
+          <p:cNvSpPr txBox="1"/>
+          <p:nvPr/>
+        </p:nvSpPr>
+        <p:spPr>
+          <a:xfrm>
+            <a:off x="5852160" y="4937759"/>
+            <a:ext cx="4709160" cy="182880"/>
+          </a:xfrm>
+          <a:prstGeom prst="rect">
+            <a:avLst/>
+          </a:prstGeom>
+          <a:noFill/>
+        </p:spPr>
+        <p:txBody>
+          <a:bodyPr wrap="none" lIns="9144" rIns="9144" tIns="9144" bIns="9144" anchor="t">
+            <a:spAutoFit/>
+          </a:bodyPr>
+          <a:lstStyle/>
+          <a:p>
+            <a:pPr algn="l">
+              <a:spcAft>
+                <a:spcPts val="0"/>
+              </a:spcAft>
+              <a:defRPr sz="700" b="1">
+                <a:solidFill>
+                  <a:srgbClr val="8A94A1"/>
+                </a:solidFill>
+                <a:latin typeface="Inter"/>
+              </a:defRPr>
+            </a:pPr>
+            <a:r>
+              <a:rPr>
+                <a:latin typeface="Inter"/>
+              </a:rPr>
+              <a:t>DATA AS OF</a:t>
+            </a:r>
+          </a:p>
+        </p:txBody>
+      </p:sp>
+      <p:sp>
+        <p:nvSpPr>
+          <p:cNvPr id="16" name="TextBox 15"/>
+          <p:cNvSpPr txBox="1"/>
+          <p:nvPr/>
+        </p:nvSpPr>
+        <p:spPr>
+          <a:xfrm>
+            <a:off x="5852160" y="5129783"/>
+            <a:ext cx="4709160" cy="310896"/>
+          </a:xfrm>
+          <a:prstGeom prst="rect">
+            <a:avLst/>
+          </a:prstGeom>
+          <a:noFill/>
+        </p:spPr>
+        <p:txBody>
+          <a:bodyPr wrap="none" lIns="9144" rIns="9144" tIns="9144" bIns="9144" anchor="t">
+            <a:spAutoFit/>
+          </a:bodyPr>
+          <a:lstStyle/>
+          <a:p>
+            <a:pPr algn="l">
+              <a:spcAft>
+                <a:spcPts val="0"/>
+              </a:spcAft>
+              <a:defRPr sz="1000" b="1">
+                <a:solidFill>
+                  <a:srgbClr val="FFFFFF"/>
+                </a:solidFill>
+                <a:latin typeface="Inter"/>
+              </a:defRPr>
+            </a:pPr>
+            <a:r>
+              <a:rPr>
+                <a:latin typeface="Inter"/>
+              </a:rPr>
+              <a:t>2025-12-31</a:t>
+            </a:r>
+          </a:p>
+        </p:txBody>
+      </p:sp>
+      <p:sp>
+        <p:nvSpPr>
+          <p:cNvPr id="17" name="Rectangle 16"/>
           <p:cNvSpPr/>
           <p:nvPr/>
         </p:nvSpPr>
         <p:spPr>
           <a:xfrm>
-            <a:off x="685800" y="5833872"/>
-            <a:ext cx="3063240" cy="384048"/>
+            <a:off x="685800" y="5687568"/>
+            <a:ext cx="3337560" cy="530352"/>
           </a:xfrm>
           <a:prstGeom prst="rect">
             <a:avLst/>
@@ -3321,14 +3489,140 @@
       </p:sp>
       <p:sp>
         <p:nvSpPr>
-          <p:cNvPr id="14" name="TextBox 13"/>
+          <p:cNvPr id="18" name="TextBox 17"/>
           <p:cNvSpPr txBox="1"/>
           <p:nvPr/>
         </p:nvSpPr>
         <p:spPr>
           <a:xfrm>
-            <a:off x="822960" y="5934456"/>
-            <a:ext cx="2788920" cy="164592"/>
+            <a:off x="822960" y="5760720"/>
+            <a:ext cx="3063240" cy="128016"/>
+          </a:xfrm>
+          <a:prstGeom prst="rect">
+            <a:avLst/>
+          </a:prstGeom>
+          <a:noFill/>
+        </p:spPr>
+        <p:txBody>
+          <a:bodyPr wrap="none" lIns="9144" rIns="9144" tIns="9144" bIns="9144" anchor="t">
+            <a:spAutoFit/>
+          </a:bodyPr>
+          <a:lstStyle/>
+          <a:p>
+            <a:pPr algn="l">
+              <a:spcAft>
+                <a:spcPts val="0"/>
+              </a:spcAft>
+              <a:defRPr sz="620" b="1">
+                <a:solidFill>
+                  <a:srgbClr val="0D1117"/>
+                </a:solidFill>
+                <a:latin typeface="Inter"/>
+              </a:defRPr>
+            </a:pPr>
+            <a:r>
+              <a:rPr>
+                <a:latin typeface="Inter"/>
+              </a:rPr>
+              <a:t>OVERALL VIEW</a:t>
+            </a:r>
+          </a:p>
+        </p:txBody>
+      </p:sp>
+      <p:sp>
+        <p:nvSpPr>
+          <p:cNvPr id="19" name="TextBox 18"/>
+          <p:cNvSpPr txBox="1"/>
+          <p:nvPr/>
+        </p:nvSpPr>
+        <p:spPr>
+          <a:xfrm>
+            <a:off x="822960" y="5916168"/>
+            <a:ext cx="3063240" cy="182880"/>
+          </a:xfrm>
+          <a:prstGeom prst="rect">
+            <a:avLst/>
+          </a:prstGeom>
+          <a:noFill/>
+        </p:spPr>
+        <p:txBody>
+          <a:bodyPr wrap="none" lIns="9144" rIns="9144" tIns="9144" bIns="9144" anchor="t">
+            <a:spAutoFit/>
+          </a:bodyPr>
+          <a:lstStyle/>
+          <a:p>
+            <a:pPr algn="l">
+              <a:spcAft>
+                <a:spcPts val="0"/>
+              </a:spcAft>
+              <a:defRPr sz="900" b="1">
+                <a:solidFill>
+                  <a:srgbClr val="0D1117"/>
+                </a:solidFill>
+                <a:latin typeface="Inter"/>
+              </a:defRPr>
+            </a:pPr>
+            <a:r>
+              <a:rPr>
+                <a:latin typeface="Inter"/>
+              </a:rPr>
+              <a:t>Insufficient governed evidence</a:t>
+            </a:r>
+          </a:p>
+        </p:txBody>
+      </p:sp>
+      <p:sp>
+        <p:nvSpPr>
+          <p:cNvPr id="20" name="TextBox 19"/>
+          <p:cNvSpPr txBox="1"/>
+          <p:nvPr/>
+        </p:nvSpPr>
+        <p:spPr>
+          <a:xfrm>
+            <a:off x="4297680" y="5733288"/>
+            <a:ext cx="3108960" cy="164592"/>
+          </a:xfrm>
+          <a:prstGeom prst="rect">
+            <a:avLst/>
+          </a:prstGeom>
+          <a:noFill/>
+        </p:spPr>
+        <p:txBody>
+          <a:bodyPr wrap="none" lIns="9144" rIns="9144" tIns="9144" bIns="9144" anchor="t">
+            <a:spAutoFit/>
+          </a:bodyPr>
+          <a:lstStyle/>
+          <a:p>
+            <a:pPr algn="l">
+              <a:spcAft>
+                <a:spcPts val="0"/>
+              </a:spcAft>
+              <a:defRPr sz="650" b="1">
+                <a:solidFill>
+                  <a:srgbClr val="8A94A1"/>
+                </a:solidFill>
+                <a:latin typeface="Inter"/>
+              </a:defRPr>
+            </a:pPr>
+            <a:r>
+              <a:rPr>
+                <a:latin typeface="Inter"/>
+              </a:rPr>
+              <a:t>SCOPE REVIEWED</a:t>
+            </a:r>
+          </a:p>
+        </p:txBody>
+      </p:sp>
+      <p:sp>
+        <p:nvSpPr>
+          <p:cNvPr id="21" name="TextBox 20"/>
+          <p:cNvSpPr txBox="1"/>
+          <p:nvPr/>
+        </p:nvSpPr>
+        <p:spPr>
+          <a:xfrm>
+            <a:off x="4297680" y="5934456"/>
+            <a:ext cx="3108960" cy="201168"/>
           </a:xfrm>
           <a:prstGeom prst="rect">
             <a:avLst/>
@@ -3347,90 +3641,6 @@
               </a:spcAft>
               <a:defRPr sz="800" b="1">
                 <a:solidFill>
-                  <a:srgbClr val="0D1117"/>
-                </a:solidFill>
-                <a:latin typeface="Inter"/>
-              </a:defRPr>
-            </a:pPr>
-            <a:r>
-              <a:rPr>
-                <a:latin typeface="Inter"/>
-              </a:rPr>
-              <a:t>Insufficient governed evidence</a:t>
-            </a:r>
-          </a:p>
-        </p:txBody>
-      </p:sp>
-      <p:sp>
-        <p:nvSpPr>
-          <p:cNvPr id="15" name="TextBox 14"/>
-          <p:cNvSpPr txBox="1"/>
-          <p:nvPr/>
-        </p:nvSpPr>
-        <p:spPr>
-          <a:xfrm>
-            <a:off x="3977639" y="5824728"/>
-            <a:ext cx="3108960" cy="164592"/>
-          </a:xfrm>
-          <a:prstGeom prst="rect">
-            <a:avLst/>
-          </a:prstGeom>
-          <a:noFill/>
-        </p:spPr>
-        <p:txBody>
-          <a:bodyPr wrap="none" lIns="9144" rIns="9144" tIns="9144" bIns="9144" anchor="t">
-            <a:spAutoFit/>
-          </a:bodyPr>
-          <a:lstStyle/>
-          <a:p>
-            <a:pPr algn="l">
-              <a:spcAft>
-                <a:spcPts val="0"/>
-              </a:spcAft>
-              <a:defRPr sz="650" b="1">
-                <a:solidFill>
-                  <a:srgbClr val="8A94A1"/>
-                </a:solidFill>
-                <a:latin typeface="Inter"/>
-              </a:defRPr>
-            </a:pPr>
-            <a:r>
-              <a:rPr>
-                <a:latin typeface="Inter"/>
-              </a:rPr>
-              <a:t>EVIDENCE COMPLETENESS</a:t>
-            </a:r>
-          </a:p>
-        </p:txBody>
-      </p:sp>
-      <p:sp>
-        <p:nvSpPr>
-          <p:cNvPr id="16" name="TextBox 15"/>
-          <p:cNvSpPr txBox="1"/>
-          <p:nvPr/>
-        </p:nvSpPr>
-        <p:spPr>
-          <a:xfrm>
-            <a:off x="3977639" y="5998464"/>
-            <a:ext cx="3108960" cy="201168"/>
-          </a:xfrm>
-          <a:prstGeom prst="rect">
-            <a:avLst/>
-          </a:prstGeom>
-          <a:noFill/>
-        </p:spPr>
-        <p:txBody>
-          <a:bodyPr wrap="none" lIns="9144" rIns="9144" tIns="9144" bIns="9144" anchor="t">
-            <a:spAutoFit/>
-          </a:bodyPr>
-          <a:lstStyle/>
-          <a:p>
-            <a:pPr algn="l">
-              <a:spcAft>
-                <a:spcPts val="0"/>
-              </a:spcAft>
-              <a:defRPr sz="800" b="1">
-                <a:solidFill>
                   <a:srgbClr val="FFFFFF"/>
                 </a:solidFill>
                 <a:latin typeface="Inter"/>
@@ -3447,14 +3657,14 @@
       </p:sp>
       <p:sp>
         <p:nvSpPr>
-          <p:cNvPr id="17" name="TextBox 16"/>
+          <p:cNvPr id="22" name="TextBox 21"/>
           <p:cNvSpPr txBox="1"/>
           <p:nvPr/>
         </p:nvSpPr>
         <p:spPr>
           <a:xfrm>
-            <a:off x="685800" y="6473952"/>
-            <a:ext cx="8046720" cy="182880"/>
+            <a:off x="685800" y="6400800"/>
+            <a:ext cx="8046720" cy="146304"/>
           </a:xfrm>
           <a:prstGeom prst="rect">
             <a:avLst/>
@@ -3482,14 +3692,56 @@
               <a:rPr>
                 <a:latin typeface="Inter"/>
               </a:rPr>
-              <a:t>Confidential — prepared for internal investment use</a:t>
-            </a:r>
-          </a:p>
-        </p:txBody>
-      </p:sp>
-      <p:sp>
-        <p:nvSpPr>
-          <p:cNvPr id="18" name="TextBox 17"/>
+              <a:t>Confidential — manager selection review</a:t>
+            </a:r>
+          </a:p>
+        </p:txBody>
+      </p:sp>
+      <p:sp>
+        <p:nvSpPr>
+          <p:cNvPr id="23" name="TextBox 22"/>
+          <p:cNvSpPr txBox="1"/>
+          <p:nvPr/>
+        </p:nvSpPr>
+        <p:spPr>
+          <a:xfrm>
+            <a:off x="685800" y="6556248"/>
+            <a:ext cx="8046720" cy="128016"/>
+          </a:xfrm>
+          <a:prstGeom prst="rect">
+            <a:avLst/>
+          </a:prstGeom>
+          <a:noFill/>
+        </p:spPr>
+        <p:txBody>
+          <a:bodyPr wrap="none" lIns="9144" rIns="9144" tIns="9144" bIns="9144" anchor="t">
+            <a:spAutoFit/>
+          </a:bodyPr>
+          <a:lstStyle/>
+          <a:p>
+            <a:pPr algn="l">
+              <a:spcAft>
+                <a:spcPts val="0"/>
+              </a:spcAft>
+              <a:defRPr sz="650" b="0">
+                <a:solidFill>
+                  <a:srgbClr val="8A94A1"/>
+                </a:solidFill>
+                <a:latin typeface="Inter"/>
+              </a:defRPr>
+            </a:pPr>
+            <a:r>
+              <a:rPr>
+                <a:latin typeface="Inter"/>
+              </a:rPr>
+              <a:t>Illustrative sample · not client data</a:t>
+            </a:r>
+          </a:p>
+        </p:txBody>
+      </p:sp>
+      <p:sp>
+        <p:nvSpPr>
+          <p:cNvPr id="24" name="TextBox 23"/>
           <p:cNvSpPr txBox="1"/>
           <p:nvPr/>
         </p:nvSpPr>
@@ -3605,7 +3857,7 @@
         <p:spPr>
           <a:xfrm>
             <a:off x="640080" y="329184"/>
-            <a:ext cx="9875520" cy="182880"/>
+            <a:ext cx="5303520" cy="182880"/>
           </a:xfrm>
           <a:prstGeom prst="rect">
             <a:avLst/>
@@ -3646,6 +3898,48 @@
         </p:nvSpPr>
         <p:spPr>
           <a:xfrm>
+            <a:off x="5897880" y="310896"/>
+            <a:ext cx="4800600" cy="256032"/>
+          </a:xfrm>
+          <a:prstGeom prst="rect">
+            <a:avLst/>
+          </a:prstGeom>
+          <a:noFill/>
+        </p:spPr>
+        <p:txBody>
+          <a:bodyPr wrap="none" lIns="9144" rIns="9144" tIns="9144" bIns="9144" anchor="t">
+            <a:spAutoFit/>
+          </a:bodyPr>
+          <a:lstStyle/>
+          <a:p>
+            <a:pPr algn="r">
+              <a:spcAft>
+                <a:spcPts val="0"/>
+              </a:spcAft>
+              <a:defRPr sz="680" b="1">
+                <a:solidFill>
+                  <a:srgbClr val="4F6B00"/>
+                </a:solidFill>
+                <a:latin typeface="Inter"/>
+              </a:defRPr>
+            </a:pPr>
+            <a:r>
+              <a:rPr>
+                <a:latin typeface="Inter"/>
+              </a:rPr>
+              <a:t>Illustrative, Gradient Maintained — demo data, not the client's holdings or managers</a:t>
+            </a:r>
+          </a:p>
+        </p:txBody>
+      </p:sp>
+      <p:sp>
+        <p:nvSpPr>
+          <p:cNvPr id="5" name="TextBox 4"/>
+          <p:cNvSpPr txBox="1"/>
+          <p:nvPr/>
+        </p:nvSpPr>
+        <p:spPr>
+          <a:xfrm>
             <a:off x="640080" y="566928"/>
             <a:ext cx="10058400" cy="530352"/>
           </a:xfrm>
@@ -3682,7 +3976,7 @@
       </p:sp>
       <p:sp>
         <p:nvSpPr>
-          <p:cNvPr id="5" name="Rectangle 4"/>
+          <p:cNvPr id="6" name="Rectangle 5"/>
           <p:cNvSpPr/>
           <p:nvPr/>
         </p:nvSpPr>
@@ -3731,7 +4025,7 @@
       </p:sp>
       <p:sp>
         <p:nvSpPr>
-          <p:cNvPr id="6" name="Rectangle 5"/>
+          <p:cNvPr id="7" name="Rectangle 6"/>
           <p:cNvSpPr/>
           <p:nvPr/>
         </p:nvSpPr>
@@ -3780,7 +4074,7 @@
       </p:sp>
       <p:sp>
         <p:nvSpPr>
-          <p:cNvPr id="7" name="TextBox 6"/>
+          <p:cNvPr id="8" name="TextBox 7"/>
           <p:cNvSpPr txBox="1"/>
           <p:nvPr/>
         </p:nvSpPr>
@@ -3822,7 +4116,7 @@
       </p:sp>
       <p:sp>
         <p:nvSpPr>
-          <p:cNvPr id="8" name="Rectangle 7"/>
+          <p:cNvPr id="9" name="Rectangle 8"/>
           <p:cNvSpPr/>
           <p:nvPr/>
         </p:nvSpPr>
@@ -3871,7 +4165,7 @@
       </p:sp>
       <p:sp>
         <p:nvSpPr>
-          <p:cNvPr id="9" name="Rectangle 8"/>
+          <p:cNvPr id="10" name="Rectangle 9"/>
           <p:cNvSpPr/>
           <p:nvPr/>
         </p:nvSpPr>
@@ -3920,7 +4214,7 @@
       </p:sp>
       <p:sp>
         <p:nvSpPr>
-          <p:cNvPr id="10" name="TextBox 9"/>
+          <p:cNvPr id="11" name="TextBox 10"/>
           <p:cNvSpPr txBox="1"/>
           <p:nvPr/>
         </p:nvSpPr>
@@ -3962,7 +4256,7 @@
       </p:sp>
       <p:sp>
         <p:nvSpPr>
-          <p:cNvPr id="11" name="TextBox 10"/>
+          <p:cNvPr id="12" name="TextBox 11"/>
           <p:cNvSpPr txBox="1"/>
           <p:nvPr/>
         </p:nvSpPr>
@@ -4004,7 +4298,7 @@
       </p:sp>
       <p:sp>
         <p:nvSpPr>
-          <p:cNvPr id="12" name="Rectangle 11"/>
+          <p:cNvPr id="13" name="Rectangle 12"/>
           <p:cNvSpPr/>
           <p:nvPr/>
         </p:nvSpPr>
@@ -4053,7 +4347,7 @@
       </p:sp>
       <p:sp>
         <p:nvSpPr>
-          <p:cNvPr id="13" name="Rectangle 12"/>
+          <p:cNvPr id="14" name="Rectangle 13"/>
           <p:cNvSpPr/>
           <p:nvPr/>
         </p:nvSpPr>
@@ -4102,7 +4396,7 @@
       </p:sp>
       <p:sp>
         <p:nvSpPr>
-          <p:cNvPr id="14" name="TextBox 13"/>
+          <p:cNvPr id="15" name="TextBox 14"/>
           <p:cNvSpPr txBox="1"/>
           <p:nvPr/>
         </p:nvSpPr>
@@ -4144,7 +4438,7 @@
       </p:sp>
       <p:sp>
         <p:nvSpPr>
-          <p:cNvPr id="15" name="TextBox 14"/>
+          <p:cNvPr id="16" name="TextBox 15"/>
           <p:cNvSpPr txBox="1"/>
           <p:nvPr/>
         </p:nvSpPr>
@@ -4186,7 +4480,7 @@
       </p:sp>
       <p:sp>
         <p:nvSpPr>
-          <p:cNvPr id="16" name="Rectangle 15"/>
+          <p:cNvPr id="17" name="Rectangle 16"/>
           <p:cNvSpPr/>
           <p:nvPr/>
         </p:nvSpPr>
@@ -4235,7 +4529,7 @@
       </p:sp>
       <p:sp>
         <p:nvSpPr>
-          <p:cNvPr id="17" name="Rectangle 16"/>
+          <p:cNvPr id="18" name="Rectangle 17"/>
           <p:cNvSpPr/>
           <p:nvPr/>
         </p:nvSpPr>
@@ -4284,7 +4578,7 @@
       </p:sp>
       <p:sp>
         <p:nvSpPr>
-          <p:cNvPr id="18" name="TextBox 17"/>
+          <p:cNvPr id="19" name="TextBox 18"/>
           <p:cNvSpPr txBox="1"/>
           <p:nvPr/>
         </p:nvSpPr>
@@ -4326,7 +4620,7 @@
       </p:sp>
       <p:sp>
         <p:nvSpPr>
-          <p:cNvPr id="19" name="TextBox 18"/>
+          <p:cNvPr id="20" name="TextBox 19"/>
           <p:cNvSpPr txBox="1"/>
           <p:nvPr/>
         </p:nvSpPr>
@@ -4368,7 +4662,7 @@
       </p:sp>
       <p:sp>
         <p:nvSpPr>
-          <p:cNvPr id="20" name="Rectangle 19"/>
+          <p:cNvPr id="21" name="Rectangle 20"/>
           <p:cNvSpPr/>
           <p:nvPr/>
         </p:nvSpPr>
@@ -4417,7 +4711,7 @@
       </p:sp>
       <p:sp>
         <p:nvSpPr>
-          <p:cNvPr id="21" name="TextBox 20"/>
+          <p:cNvPr id="22" name="TextBox 21"/>
           <p:cNvSpPr txBox="1"/>
           <p:nvPr/>
         </p:nvSpPr>
@@ -4459,7 +4753,7 @@
       </p:sp>
       <p:sp>
         <p:nvSpPr>
-          <p:cNvPr id="22" name="TextBox 21"/>
+          <p:cNvPr id="23" name="TextBox 22"/>
           <p:cNvSpPr txBox="1"/>
           <p:nvPr/>
         </p:nvSpPr>
@@ -4494,14 +4788,14 @@
               <a:rPr>
                 <a:latin typeface="Inter"/>
               </a:rPr>
-              <a:t>Confidential — prepared for internal investment use · Data as of 2025-12-31</a:t>
-            </a:r>
-          </a:p>
-        </p:txBody>
-      </p:sp>
-      <p:sp>
-        <p:nvSpPr>
-          <p:cNvPr id="23" name="TextBox 22"/>
+              <a:t>Confidential — manager selection review · Data as of 2025-12-31</a:t>
+            </a:r>
+          </a:p>
+        </p:txBody>
+      </p:sp>
+      <p:sp>
+        <p:nvSpPr>
+          <p:cNvPr id="24" name="TextBox 23"/>
           <p:cNvSpPr txBox="1"/>
           <p:nvPr/>
         </p:nvSpPr>
@@ -4617,7 +4911,7 @@
         <p:spPr>
           <a:xfrm>
             <a:off x="640080" y="329184"/>
-            <a:ext cx="9875520" cy="182880"/>
+            <a:ext cx="5303520" cy="182880"/>
           </a:xfrm>
           <a:prstGeom prst="rect">
             <a:avLst/>
@@ -4645,7 +4939,7 @@
               <a:rPr>
                 <a:latin typeface="Inter"/>
               </a:rPr>
-              <a:t>BENCHMARK IDENTITY REMAINS ADVISORY FOR THE TEST CANDIDATES</a:t>
+              <a:t>BENCHMARK IDENTITY REMAINS ADVISORY FOR THE REVIEWED CANDIDATES</a:t>
             </a:r>
           </a:p>
         </p:txBody>
@@ -4653,6 +4947,48 @@
       <p:sp>
         <p:nvSpPr>
           <p:cNvPr id="4" name="TextBox 3"/>
+          <p:cNvSpPr txBox="1"/>
+          <p:nvPr/>
+        </p:nvSpPr>
+        <p:spPr>
+          <a:xfrm>
+            <a:off x="5897880" y="310896"/>
+            <a:ext cx="4800600" cy="256032"/>
+          </a:xfrm>
+          <a:prstGeom prst="rect">
+            <a:avLst/>
+          </a:prstGeom>
+          <a:noFill/>
+        </p:spPr>
+        <p:txBody>
+          <a:bodyPr wrap="none" lIns="9144" rIns="9144" tIns="9144" bIns="9144" anchor="t">
+            <a:spAutoFit/>
+          </a:bodyPr>
+          <a:lstStyle/>
+          <a:p>
+            <a:pPr algn="r">
+              <a:spcAft>
+                <a:spcPts val="0"/>
+              </a:spcAft>
+              <a:defRPr sz="680" b="1">
+                <a:solidFill>
+                  <a:srgbClr val="4F6B00"/>
+                </a:solidFill>
+                <a:latin typeface="Inter"/>
+              </a:defRPr>
+            </a:pPr>
+            <a:r>
+              <a:rPr>
+                <a:latin typeface="Inter"/>
+              </a:rPr>
+              <a:t>Illustrative, Gradient Maintained — demo data, not the client's holdings or managers</a:t>
+            </a:r>
+          </a:p>
+        </p:txBody>
+      </p:sp>
+      <p:sp>
+        <p:nvSpPr>
+          <p:cNvPr id="5" name="TextBox 4"/>
           <p:cNvSpPr txBox="1"/>
           <p:nvPr/>
         </p:nvSpPr>
@@ -4694,7 +5030,7 @@
       </p:sp>
       <p:sp>
         <p:nvSpPr>
-          <p:cNvPr id="5" name="Rectangle 4"/>
+          <p:cNvPr id="6" name="Rectangle 5"/>
           <p:cNvSpPr/>
           <p:nvPr/>
         </p:nvSpPr>
@@ -4743,7 +5079,7 @@
       </p:sp>
       <p:sp>
         <p:nvSpPr>
-          <p:cNvPr id="6" name="Rectangle 5"/>
+          <p:cNvPr id="7" name="Rectangle 6"/>
           <p:cNvSpPr/>
           <p:nvPr/>
         </p:nvSpPr>
@@ -4792,7 +5128,7 @@
       </p:sp>
       <p:sp>
         <p:nvSpPr>
-          <p:cNvPr id="7" name="TextBox 6"/>
+          <p:cNvPr id="8" name="TextBox 7"/>
           <p:cNvSpPr txBox="1"/>
           <p:nvPr/>
         </p:nvSpPr>
@@ -4834,7 +5170,7 @@
       </p:sp>
       <p:graphicFrame>
         <p:nvGraphicFramePr>
-          <p:cNvPr id="8" name="Table 7"/>
+          <p:cNvPr id="9" name="Table 8"/>
           <p:cNvGraphicFramePr>
             <a:graphicFrameLocks noGrp="1"/>
           </p:cNvGraphicFramePr>
@@ -5027,7 +5363,7 @@
       </p:graphicFrame>
       <p:sp>
         <p:nvSpPr>
-          <p:cNvPr id="9" name="Rectangle 8"/>
+          <p:cNvPr id="10" name="Rectangle 9"/>
           <p:cNvSpPr/>
           <p:nvPr/>
         </p:nvSpPr>
@@ -5076,7 +5412,7 @@
       </p:sp>
       <p:sp>
         <p:nvSpPr>
-          <p:cNvPr id="10" name="TextBox 9"/>
+          <p:cNvPr id="11" name="TextBox 10"/>
           <p:cNvSpPr txBox="1"/>
           <p:nvPr/>
         </p:nvSpPr>
@@ -5118,7 +5454,7 @@
       </p:sp>
       <p:sp>
         <p:nvSpPr>
-          <p:cNvPr id="11" name="TextBox 10"/>
+          <p:cNvPr id="12" name="TextBox 11"/>
           <p:cNvSpPr txBox="1"/>
           <p:nvPr/>
         </p:nvSpPr>
@@ -5153,14 +5489,14 @@
               <a:rPr>
                 <a:latin typeface="Inter"/>
               </a:rPr>
-              <a:t>Confidential — prepared for internal investment use · Data as of 2025-12-31</a:t>
-            </a:r>
-          </a:p>
-        </p:txBody>
-      </p:sp>
-      <p:sp>
-        <p:nvSpPr>
-          <p:cNvPr id="12" name="TextBox 11"/>
+              <a:t>Confidential — manager selection review · Data as of 2025-12-31</a:t>
+            </a:r>
+          </a:p>
+        </p:txBody>
+      </p:sp>
+      <p:sp>
+        <p:nvSpPr>
+          <p:cNvPr id="13" name="TextBox 12"/>
           <p:cNvSpPr txBox="1"/>
           <p:nvPr/>
         </p:nvSpPr>
@@ -5276,7 +5612,7 @@
         <p:spPr>
           <a:xfrm>
             <a:off x="640080" y="329184"/>
-            <a:ext cx="9875520" cy="182880"/>
+            <a:ext cx="5303520" cy="182880"/>
           </a:xfrm>
           <a:prstGeom prst="rect">
             <a:avLst/>
@@ -5317,6 +5653,48 @@
         </p:nvSpPr>
         <p:spPr>
           <a:xfrm>
+            <a:off x="5897880" y="310896"/>
+            <a:ext cx="4800600" cy="256032"/>
+          </a:xfrm>
+          <a:prstGeom prst="rect">
+            <a:avLst/>
+          </a:prstGeom>
+          <a:noFill/>
+        </p:spPr>
+        <p:txBody>
+          <a:bodyPr wrap="none" lIns="9144" rIns="9144" tIns="9144" bIns="9144" anchor="t">
+            <a:spAutoFit/>
+          </a:bodyPr>
+          <a:lstStyle/>
+          <a:p>
+            <a:pPr algn="r">
+              <a:spcAft>
+                <a:spcPts val="0"/>
+              </a:spcAft>
+              <a:defRPr sz="680" b="1">
+                <a:solidFill>
+                  <a:srgbClr val="4F6B00"/>
+                </a:solidFill>
+                <a:latin typeface="Inter"/>
+              </a:defRPr>
+            </a:pPr>
+            <a:r>
+              <a:rPr>
+                <a:latin typeface="Inter"/>
+              </a:rPr>
+              <a:t>Illustrative, Gradient Maintained — demo data, not the client's holdings or managers</a:t>
+            </a:r>
+          </a:p>
+        </p:txBody>
+      </p:sp>
+      <p:sp>
+        <p:nvSpPr>
+          <p:cNvPr id="5" name="TextBox 4"/>
+          <p:cNvSpPr txBox="1"/>
+          <p:nvPr/>
+        </p:nvSpPr>
+        <p:spPr>
+          <a:xfrm>
             <a:off x="640080" y="566928"/>
             <a:ext cx="10058400" cy="530352"/>
           </a:xfrm>
@@ -5353,7 +5731,7 @@
       </p:sp>
       <p:sp>
         <p:nvSpPr>
-          <p:cNvPr id="5" name="Rectangle 4"/>
+          <p:cNvPr id="6" name="Rectangle 5"/>
           <p:cNvSpPr/>
           <p:nvPr/>
         </p:nvSpPr>
@@ -5402,7 +5780,7 @@
       </p:sp>
       <p:sp>
         <p:nvSpPr>
-          <p:cNvPr id="6" name="Rectangle 5"/>
+          <p:cNvPr id="7" name="Rectangle 6"/>
           <p:cNvSpPr/>
           <p:nvPr/>
         </p:nvSpPr>
@@ -5451,7 +5829,7 @@
       </p:sp>
       <p:sp>
         <p:nvSpPr>
-          <p:cNvPr id="7" name="TextBox 6"/>
+          <p:cNvPr id="8" name="TextBox 7"/>
           <p:cNvSpPr txBox="1"/>
           <p:nvPr/>
         </p:nvSpPr>
@@ -5493,7 +5871,7 @@
       </p:sp>
       <p:sp>
         <p:nvSpPr>
-          <p:cNvPr id="8" name="Rectangle 7"/>
+          <p:cNvPr id="9" name="Rectangle 8"/>
           <p:cNvSpPr/>
           <p:nvPr/>
         </p:nvSpPr>
@@ -5542,7 +5920,7 @@
       </p:sp>
       <p:sp>
         <p:nvSpPr>
-          <p:cNvPr id="9" name="Rectangle 8"/>
+          <p:cNvPr id="10" name="Rectangle 9"/>
           <p:cNvSpPr/>
           <p:nvPr/>
         </p:nvSpPr>
@@ -5591,7 +5969,7 @@
       </p:sp>
       <p:sp>
         <p:nvSpPr>
-          <p:cNvPr id="10" name="TextBox 9"/>
+          <p:cNvPr id="11" name="TextBox 10"/>
           <p:cNvSpPr txBox="1"/>
           <p:nvPr/>
         </p:nvSpPr>
@@ -5633,7 +6011,7 @@
       </p:sp>
       <p:sp>
         <p:nvSpPr>
-          <p:cNvPr id="11" name="TextBox 10"/>
+          <p:cNvPr id="12" name="TextBox 11"/>
           <p:cNvSpPr txBox="1"/>
           <p:nvPr/>
         </p:nvSpPr>
@@ -5675,7 +6053,7 @@
       </p:sp>
       <p:sp>
         <p:nvSpPr>
-          <p:cNvPr id="12" name="Rectangle 11"/>
+          <p:cNvPr id="13" name="Rectangle 12"/>
           <p:cNvSpPr/>
           <p:nvPr/>
         </p:nvSpPr>
@@ -5724,7 +6102,7 @@
       </p:sp>
       <p:sp>
         <p:nvSpPr>
-          <p:cNvPr id="13" name="Rectangle 12"/>
+          <p:cNvPr id="14" name="Rectangle 13"/>
           <p:cNvSpPr/>
           <p:nvPr/>
         </p:nvSpPr>
@@ -5773,7 +6151,7 @@
       </p:sp>
       <p:sp>
         <p:nvSpPr>
-          <p:cNvPr id="14" name="TextBox 13"/>
+          <p:cNvPr id="15" name="TextBox 14"/>
           <p:cNvSpPr txBox="1"/>
           <p:nvPr/>
         </p:nvSpPr>
@@ -5815,7 +6193,7 @@
       </p:sp>
       <p:sp>
         <p:nvSpPr>
-          <p:cNvPr id="15" name="TextBox 14"/>
+          <p:cNvPr id="16" name="TextBox 15"/>
           <p:cNvSpPr txBox="1"/>
           <p:nvPr/>
         </p:nvSpPr>
@@ -5857,7 +6235,7 @@
       </p:sp>
       <p:sp>
         <p:nvSpPr>
-          <p:cNvPr id="16" name="Rectangle 15"/>
+          <p:cNvPr id="17" name="Rectangle 16"/>
           <p:cNvSpPr/>
           <p:nvPr/>
         </p:nvSpPr>
@@ -5906,7 +6284,7 @@
       </p:sp>
       <p:sp>
         <p:nvSpPr>
-          <p:cNvPr id="17" name="TextBox 16"/>
+          <p:cNvPr id="18" name="TextBox 17"/>
           <p:cNvSpPr txBox="1"/>
           <p:nvPr/>
         </p:nvSpPr>
@@ -5948,7 +6326,7 @@
       </p:sp>
       <p:sp>
         <p:nvSpPr>
-          <p:cNvPr id="18" name="TextBox 17"/>
+          <p:cNvPr id="19" name="TextBox 18"/>
           <p:cNvSpPr txBox="1"/>
           <p:nvPr/>
         </p:nvSpPr>
@@ -5983,14 +6361,14 @@
               <a:rPr>
                 <a:latin typeface="Inter"/>
               </a:rPr>
-              <a:t>Confidential — prepared for internal investment use · Data as of 2025-12-31</a:t>
-            </a:r>
-          </a:p>
-        </p:txBody>
-      </p:sp>
-      <p:sp>
-        <p:nvSpPr>
-          <p:cNvPr id="19" name="TextBox 18"/>
+              <a:t>Confidential — manager selection review · Data as of 2025-12-31</a:t>
+            </a:r>
+          </a:p>
+        </p:txBody>
+      </p:sp>
+      <p:sp>
+        <p:nvSpPr>
+          <p:cNvPr id="20" name="TextBox 19"/>
           <p:cNvSpPr txBox="1"/>
           <p:nvPr/>
         </p:nvSpPr>
@@ -6106,7 +6484,7 @@
         <p:spPr>
           <a:xfrm>
             <a:off x="640080" y="329184"/>
-            <a:ext cx="9875520" cy="182880"/>
+            <a:ext cx="5303520" cy="182880"/>
           </a:xfrm>
           <a:prstGeom prst="rect">
             <a:avLst/>
@@ -6147,6 +6525,48 @@
         </p:nvSpPr>
         <p:spPr>
           <a:xfrm>
+            <a:off x="5897880" y="310896"/>
+            <a:ext cx="4800600" cy="256032"/>
+          </a:xfrm>
+          <a:prstGeom prst="rect">
+            <a:avLst/>
+          </a:prstGeom>
+          <a:noFill/>
+        </p:spPr>
+        <p:txBody>
+          <a:bodyPr wrap="none" lIns="9144" rIns="9144" tIns="9144" bIns="9144" anchor="t">
+            <a:spAutoFit/>
+          </a:bodyPr>
+          <a:lstStyle/>
+          <a:p>
+            <a:pPr algn="r">
+              <a:spcAft>
+                <a:spcPts val="0"/>
+              </a:spcAft>
+              <a:defRPr sz="680" b="1">
+                <a:solidFill>
+                  <a:srgbClr val="4F6B00"/>
+                </a:solidFill>
+                <a:latin typeface="Inter"/>
+              </a:defRPr>
+            </a:pPr>
+            <a:r>
+              <a:rPr>
+                <a:latin typeface="Inter"/>
+              </a:rPr>
+              <a:t>Illustrative, Gradient Maintained — demo data, not the client's holdings or managers</a:t>
+            </a:r>
+          </a:p>
+        </p:txBody>
+      </p:sp>
+      <p:sp>
+        <p:nvSpPr>
+          <p:cNvPr id="5" name="TextBox 4"/>
+          <p:cNvSpPr txBox="1"/>
+          <p:nvPr/>
+        </p:nvSpPr>
+        <p:spPr>
+          <a:xfrm>
             <a:off x="640080" y="566928"/>
             <a:ext cx="10058400" cy="530352"/>
           </a:xfrm>
@@ -6183,7 +6603,7 @@
       </p:sp>
       <p:sp>
         <p:nvSpPr>
-          <p:cNvPr id="5" name="Rectangle 4"/>
+          <p:cNvPr id="6" name="Rectangle 5"/>
           <p:cNvSpPr/>
           <p:nvPr/>
         </p:nvSpPr>
@@ -6232,7 +6652,7 @@
       </p:sp>
       <p:sp>
         <p:nvSpPr>
-          <p:cNvPr id="6" name="Rectangle 5"/>
+          <p:cNvPr id="7" name="Rectangle 6"/>
           <p:cNvSpPr/>
           <p:nvPr/>
         </p:nvSpPr>
@@ -6281,7 +6701,7 @@
       </p:sp>
       <p:sp>
         <p:nvSpPr>
-          <p:cNvPr id="7" name="TextBox 6"/>
+          <p:cNvPr id="8" name="TextBox 7"/>
           <p:cNvSpPr txBox="1"/>
           <p:nvPr/>
         </p:nvSpPr>
@@ -6323,7 +6743,7 @@
       </p:sp>
       <p:sp>
         <p:nvSpPr>
-          <p:cNvPr id="8" name="Rectangle 7"/>
+          <p:cNvPr id="9" name="Rectangle 8"/>
           <p:cNvSpPr/>
           <p:nvPr/>
         </p:nvSpPr>
@@ -6372,7 +6792,7 @@
       </p:sp>
       <p:sp>
         <p:nvSpPr>
-          <p:cNvPr id="9" name="Rectangle 8"/>
+          <p:cNvPr id="10" name="Rectangle 9"/>
           <p:cNvSpPr/>
           <p:nvPr/>
         </p:nvSpPr>
@@ -6421,7 +6841,7 @@
       </p:sp>
       <p:sp>
         <p:nvSpPr>
-          <p:cNvPr id="10" name="TextBox 9"/>
+          <p:cNvPr id="11" name="TextBox 10"/>
           <p:cNvSpPr txBox="1"/>
           <p:nvPr/>
         </p:nvSpPr>
@@ -6463,7 +6883,7 @@
       </p:sp>
       <p:sp>
         <p:nvSpPr>
-          <p:cNvPr id="11" name="TextBox 10"/>
+          <p:cNvPr id="12" name="TextBox 11"/>
           <p:cNvSpPr txBox="1"/>
           <p:nvPr/>
         </p:nvSpPr>
@@ -6505,7 +6925,7 @@
       </p:sp>
       <p:sp>
         <p:nvSpPr>
-          <p:cNvPr id="12" name="Rectangle 11"/>
+          <p:cNvPr id="13" name="Rectangle 12"/>
           <p:cNvSpPr/>
           <p:nvPr/>
         </p:nvSpPr>
@@ -6554,7 +6974,7 @@
       </p:sp>
       <p:sp>
         <p:nvSpPr>
-          <p:cNvPr id="13" name="Rectangle 12"/>
+          <p:cNvPr id="14" name="Rectangle 13"/>
           <p:cNvSpPr/>
           <p:nvPr/>
         </p:nvSpPr>
@@ -6603,7 +7023,7 @@
       </p:sp>
       <p:sp>
         <p:nvSpPr>
-          <p:cNvPr id="14" name="TextBox 13"/>
+          <p:cNvPr id="15" name="TextBox 14"/>
           <p:cNvSpPr txBox="1"/>
           <p:nvPr/>
         </p:nvSpPr>
@@ -6645,7 +7065,7 @@
       </p:sp>
       <p:sp>
         <p:nvSpPr>
-          <p:cNvPr id="15" name="TextBox 14"/>
+          <p:cNvPr id="16" name="TextBox 15"/>
           <p:cNvSpPr txBox="1"/>
           <p:nvPr/>
         </p:nvSpPr>
@@ -6687,7 +7107,7 @@
       </p:sp>
       <p:sp>
         <p:nvSpPr>
-          <p:cNvPr id="16" name="Rectangle 15"/>
+          <p:cNvPr id="17" name="Rectangle 16"/>
           <p:cNvSpPr/>
           <p:nvPr/>
         </p:nvSpPr>
@@ -6736,7 +7156,7 @@
       </p:sp>
       <p:sp>
         <p:nvSpPr>
-          <p:cNvPr id="17" name="TextBox 16"/>
+          <p:cNvPr id="18" name="TextBox 17"/>
           <p:cNvSpPr txBox="1"/>
           <p:nvPr/>
         </p:nvSpPr>
@@ -6778,7 +7198,7 @@
       </p:sp>
       <p:sp>
         <p:nvSpPr>
-          <p:cNvPr id="18" name="TextBox 17"/>
+          <p:cNvPr id="19" name="TextBox 18"/>
           <p:cNvSpPr txBox="1"/>
           <p:nvPr/>
         </p:nvSpPr>
@@ -6813,14 +7233,14 @@
               <a:rPr>
                 <a:latin typeface="Inter"/>
               </a:rPr>
-              <a:t>Confidential — prepared for internal investment use · Data as of 2025-12-31</a:t>
-            </a:r>
-          </a:p>
-        </p:txBody>
-      </p:sp>
-      <p:sp>
-        <p:nvSpPr>
-          <p:cNvPr id="19" name="TextBox 18"/>
+              <a:t>Confidential — manager selection review · Data as of 2025-12-31</a:t>
+            </a:r>
+          </a:p>
+        </p:txBody>
+      </p:sp>
+      <p:sp>
+        <p:nvSpPr>
+          <p:cNvPr id="20" name="TextBox 19"/>
           <p:cNvSpPr txBox="1"/>
           <p:nvPr/>
         </p:nvSpPr>
@@ -6936,7 +7356,7 @@
         <p:spPr>
           <a:xfrm>
             <a:off x="640080" y="329184"/>
-            <a:ext cx="9875520" cy="182880"/>
+            <a:ext cx="5303520" cy="182880"/>
           </a:xfrm>
           <a:prstGeom prst="rect">
             <a:avLst/>
@@ -6977,6 +7397,48 @@
         </p:nvSpPr>
         <p:spPr>
           <a:xfrm>
+            <a:off x="5897880" y="310896"/>
+            <a:ext cx="4800600" cy="256032"/>
+          </a:xfrm>
+          <a:prstGeom prst="rect">
+            <a:avLst/>
+          </a:prstGeom>
+          <a:noFill/>
+        </p:spPr>
+        <p:txBody>
+          <a:bodyPr wrap="none" lIns="9144" rIns="9144" tIns="9144" bIns="9144" anchor="t">
+            <a:spAutoFit/>
+          </a:bodyPr>
+          <a:lstStyle/>
+          <a:p>
+            <a:pPr algn="r">
+              <a:spcAft>
+                <a:spcPts val="0"/>
+              </a:spcAft>
+              <a:defRPr sz="680" b="1">
+                <a:solidFill>
+                  <a:srgbClr val="4F6B00"/>
+                </a:solidFill>
+                <a:latin typeface="Inter"/>
+              </a:defRPr>
+            </a:pPr>
+            <a:r>
+              <a:rPr>
+                <a:latin typeface="Inter"/>
+              </a:rPr>
+              <a:t>Illustrative, Gradient Maintained — demo data, not the client's holdings or managers</a:t>
+            </a:r>
+          </a:p>
+        </p:txBody>
+      </p:sp>
+      <p:sp>
+        <p:nvSpPr>
+          <p:cNvPr id="5" name="TextBox 4"/>
+          <p:cNvSpPr txBox="1"/>
+          <p:nvPr/>
+        </p:nvSpPr>
+        <p:spPr>
+          <a:xfrm>
             <a:off x="640080" y="566928"/>
             <a:ext cx="10058400" cy="530352"/>
           </a:xfrm>
@@ -7013,7 +7475,7 @@
       </p:sp>
       <p:sp>
         <p:nvSpPr>
-          <p:cNvPr id="5" name="Rectangle 4"/>
+          <p:cNvPr id="6" name="Rectangle 5"/>
           <p:cNvSpPr/>
           <p:nvPr/>
         </p:nvSpPr>
@@ -7062,7 +7524,7 @@
       </p:sp>
       <p:sp>
         <p:nvSpPr>
-          <p:cNvPr id="6" name="Rectangle 5"/>
+          <p:cNvPr id="7" name="Rectangle 6"/>
           <p:cNvSpPr/>
           <p:nvPr/>
         </p:nvSpPr>
@@ -7111,7 +7573,7 @@
       </p:sp>
       <p:sp>
         <p:nvSpPr>
-          <p:cNvPr id="7" name="TextBox 6"/>
+          <p:cNvPr id="8" name="TextBox 7"/>
           <p:cNvSpPr txBox="1"/>
           <p:nvPr/>
         </p:nvSpPr>
@@ -7153,7 +7615,7 @@
       </p:sp>
       <p:sp>
         <p:nvSpPr>
-          <p:cNvPr id="8" name="Rectangle 7"/>
+          <p:cNvPr id="9" name="Rectangle 8"/>
           <p:cNvSpPr/>
           <p:nvPr/>
         </p:nvSpPr>
@@ -7202,7 +7664,7 @@
       </p:sp>
       <p:sp>
         <p:nvSpPr>
-          <p:cNvPr id="9" name="Rectangle 8"/>
+          <p:cNvPr id="10" name="Rectangle 9"/>
           <p:cNvSpPr/>
           <p:nvPr/>
         </p:nvSpPr>
@@ -7251,7 +7713,7 @@
       </p:sp>
       <p:sp>
         <p:nvSpPr>
-          <p:cNvPr id="10" name="TextBox 9"/>
+          <p:cNvPr id="11" name="TextBox 10"/>
           <p:cNvSpPr txBox="1"/>
           <p:nvPr/>
         </p:nvSpPr>
@@ -7293,7 +7755,7 @@
       </p:sp>
       <p:sp>
         <p:nvSpPr>
-          <p:cNvPr id="11" name="TextBox 10"/>
+          <p:cNvPr id="12" name="TextBox 11"/>
           <p:cNvSpPr txBox="1"/>
           <p:nvPr/>
         </p:nvSpPr>
@@ -7335,7 +7797,7 @@
       </p:sp>
       <p:sp>
         <p:nvSpPr>
-          <p:cNvPr id="12" name="Rectangle 11"/>
+          <p:cNvPr id="13" name="Rectangle 12"/>
           <p:cNvSpPr/>
           <p:nvPr/>
         </p:nvSpPr>
@@ -7384,7 +7846,7 @@
       </p:sp>
       <p:sp>
         <p:nvSpPr>
-          <p:cNvPr id="13" name="Rectangle 12"/>
+          <p:cNvPr id="14" name="Rectangle 13"/>
           <p:cNvSpPr/>
           <p:nvPr/>
         </p:nvSpPr>
@@ -7433,7 +7895,7 @@
       </p:sp>
       <p:sp>
         <p:nvSpPr>
-          <p:cNvPr id="14" name="TextBox 13"/>
+          <p:cNvPr id="15" name="TextBox 14"/>
           <p:cNvSpPr txBox="1"/>
           <p:nvPr/>
         </p:nvSpPr>
@@ -7475,7 +7937,7 @@
       </p:sp>
       <p:sp>
         <p:nvSpPr>
-          <p:cNvPr id="15" name="TextBox 14"/>
+          <p:cNvPr id="16" name="TextBox 15"/>
           <p:cNvSpPr txBox="1"/>
           <p:nvPr/>
         </p:nvSpPr>
@@ -7517,7 +7979,7 @@
       </p:sp>
       <p:sp>
         <p:nvSpPr>
-          <p:cNvPr id="16" name="Rectangle 15"/>
+          <p:cNvPr id="17" name="Rectangle 16"/>
           <p:cNvSpPr/>
           <p:nvPr/>
         </p:nvSpPr>
@@ -7566,7 +8028,7 @@
       </p:sp>
       <p:sp>
         <p:nvSpPr>
-          <p:cNvPr id="17" name="TextBox 16"/>
+          <p:cNvPr id="18" name="TextBox 17"/>
           <p:cNvSpPr txBox="1"/>
           <p:nvPr/>
         </p:nvSpPr>
@@ -7608,7 +8070,7 @@
       </p:sp>
       <p:sp>
         <p:nvSpPr>
-          <p:cNvPr id="18" name="TextBox 17"/>
+          <p:cNvPr id="19" name="TextBox 18"/>
           <p:cNvSpPr txBox="1"/>
           <p:nvPr/>
         </p:nvSpPr>
@@ -7643,14 +8105,14 @@
               <a:rPr>
                 <a:latin typeface="Inter"/>
               </a:rPr>
-              <a:t>Confidential — prepared for internal investment use · Data as of 2025-12-31</a:t>
-            </a:r>
-          </a:p>
-        </p:txBody>
-      </p:sp>
-      <p:sp>
-        <p:nvSpPr>
-          <p:cNvPr id="19" name="TextBox 18"/>
+              <a:t>Confidential — manager selection review · Data as of 2025-12-31</a:t>
+            </a:r>
+          </a:p>
+        </p:txBody>
+      </p:sp>
+      <p:sp>
+        <p:nvSpPr>
+          <p:cNvPr id="20" name="TextBox 19"/>
           <p:cNvSpPr txBox="1"/>
           <p:nvPr/>
         </p:nvSpPr>
@@ -7766,7 +8228,7 @@
         <p:spPr>
           <a:xfrm>
             <a:off x="640080" y="329184"/>
-            <a:ext cx="9875520" cy="182880"/>
+            <a:ext cx="5303520" cy="182880"/>
           </a:xfrm>
           <a:prstGeom prst="rect">
             <a:avLst/>
@@ -7807,6 +8269,48 @@
         </p:nvSpPr>
         <p:spPr>
           <a:xfrm>
+            <a:off x="5897880" y="310896"/>
+            <a:ext cx="4800600" cy="256032"/>
+          </a:xfrm>
+          <a:prstGeom prst="rect">
+            <a:avLst/>
+          </a:prstGeom>
+          <a:noFill/>
+        </p:spPr>
+        <p:txBody>
+          <a:bodyPr wrap="none" lIns="9144" rIns="9144" tIns="9144" bIns="9144" anchor="t">
+            <a:spAutoFit/>
+          </a:bodyPr>
+          <a:lstStyle/>
+          <a:p>
+            <a:pPr algn="r">
+              <a:spcAft>
+                <a:spcPts val="0"/>
+              </a:spcAft>
+              <a:defRPr sz="680" b="1">
+                <a:solidFill>
+                  <a:srgbClr val="4F6B00"/>
+                </a:solidFill>
+                <a:latin typeface="Inter"/>
+              </a:defRPr>
+            </a:pPr>
+            <a:r>
+              <a:rPr>
+                <a:latin typeface="Inter"/>
+              </a:rPr>
+              <a:t>Illustrative, Gradient Maintained — demo data, not the client's holdings or managers</a:t>
+            </a:r>
+          </a:p>
+        </p:txBody>
+      </p:sp>
+      <p:sp>
+        <p:nvSpPr>
+          <p:cNvPr id="5" name="TextBox 4"/>
+          <p:cNvSpPr txBox="1"/>
+          <p:nvPr/>
+        </p:nvSpPr>
+        <p:spPr>
+          <a:xfrm>
             <a:off x="640080" y="566928"/>
             <a:ext cx="10058400" cy="530352"/>
           </a:xfrm>
@@ -7843,7 +8347,7 @@
       </p:sp>
       <p:sp>
         <p:nvSpPr>
-          <p:cNvPr id="5" name="Rectangle 4"/>
+          <p:cNvPr id="6" name="Rectangle 5"/>
           <p:cNvSpPr/>
           <p:nvPr/>
         </p:nvSpPr>
@@ -7892,7 +8396,7 @@
       </p:sp>
       <p:sp>
         <p:nvSpPr>
-          <p:cNvPr id="6" name="Rectangle 5"/>
+          <p:cNvPr id="7" name="Rectangle 6"/>
           <p:cNvSpPr/>
           <p:nvPr/>
         </p:nvSpPr>
@@ -7941,7 +8445,7 @@
       </p:sp>
       <p:sp>
         <p:nvSpPr>
-          <p:cNvPr id="7" name="TextBox 6"/>
+          <p:cNvPr id="8" name="TextBox 7"/>
           <p:cNvSpPr txBox="1"/>
           <p:nvPr/>
         </p:nvSpPr>
@@ -7983,7 +8487,7 @@
       </p:sp>
       <p:sp>
         <p:nvSpPr>
-          <p:cNvPr id="8" name="TextBox 7"/>
+          <p:cNvPr id="9" name="TextBox 8"/>
           <p:cNvSpPr txBox="1"/>
           <p:nvPr/>
         </p:nvSpPr>
@@ -8032,7 +8536,7 @@
       </p:sp>
       <p:sp>
         <p:nvSpPr>
-          <p:cNvPr id="9" name="Rectangle 8"/>
+          <p:cNvPr id="10" name="Rectangle 9"/>
           <p:cNvSpPr/>
           <p:nvPr/>
         </p:nvSpPr>
@@ -8081,7 +8585,7 @@
       </p:sp>
       <p:sp>
         <p:nvSpPr>
-          <p:cNvPr id="10" name="TextBox 9"/>
+          <p:cNvPr id="11" name="TextBox 10"/>
           <p:cNvSpPr txBox="1"/>
           <p:nvPr/>
         </p:nvSpPr>
@@ -8123,7 +8627,7 @@
       </p:sp>
       <p:sp>
         <p:nvSpPr>
-          <p:cNvPr id="11" name="TextBox 10"/>
+          <p:cNvPr id="12" name="TextBox 11"/>
           <p:cNvSpPr txBox="1"/>
           <p:nvPr/>
         </p:nvSpPr>
@@ -8158,14 +8662,14 @@
               <a:rPr>
                 <a:latin typeface="Inter"/>
               </a:rPr>
-              <a:t>Confidential — prepared for internal investment use · Data as of 2025-12-31</a:t>
-            </a:r>
-          </a:p>
-        </p:txBody>
-      </p:sp>
-      <p:sp>
-        <p:nvSpPr>
-          <p:cNvPr id="12" name="TextBox 11"/>
+              <a:t>Confidential — manager selection review · Data as of 2025-12-31</a:t>
+            </a:r>
+          </a:p>
+        </p:txBody>
+      </p:sp>
+      <p:sp>
+        <p:nvSpPr>
+          <p:cNvPr id="13" name="TextBox 12"/>
           <p:cNvSpPr txBox="1"/>
           <p:nvPr/>
         </p:nvSpPr>
@@ -8281,7 +8785,7 @@
         <p:spPr>
           <a:xfrm>
             <a:off x="640080" y="329184"/>
-            <a:ext cx="9875520" cy="182880"/>
+            <a:ext cx="5303520" cy="182880"/>
           </a:xfrm>
           <a:prstGeom prst="rect">
             <a:avLst/>
@@ -8309,7 +8813,7 @@
               <a:rPr>
                 <a:latin typeface="Inter"/>
               </a:rPr>
-              <a:t>SAVED FICTIONAL TEST EVIDENCE</a:t>
+              <a:t>SAVED ILLUSTRATIVE SAMPLE EVIDENCE</a:t>
             </a:r>
           </a:p>
         </p:txBody>
@@ -8317,6 +8821,48 @@
       <p:sp>
         <p:nvSpPr>
           <p:cNvPr id="4" name="TextBox 3"/>
+          <p:cNvSpPr txBox="1"/>
+          <p:nvPr/>
+        </p:nvSpPr>
+        <p:spPr>
+          <a:xfrm>
+            <a:off x="5897880" y="310896"/>
+            <a:ext cx="4800600" cy="256032"/>
+          </a:xfrm>
+          <a:prstGeom prst="rect">
+            <a:avLst/>
+          </a:prstGeom>
+          <a:noFill/>
+        </p:spPr>
+        <p:txBody>
+          <a:bodyPr wrap="none" lIns="9144" rIns="9144" tIns="9144" bIns="9144" anchor="t">
+            <a:spAutoFit/>
+          </a:bodyPr>
+          <a:lstStyle/>
+          <a:p>
+            <a:pPr algn="r">
+              <a:spcAft>
+                <a:spcPts val="0"/>
+              </a:spcAft>
+              <a:defRPr sz="680" b="1">
+                <a:solidFill>
+                  <a:srgbClr val="4F6B00"/>
+                </a:solidFill>
+                <a:latin typeface="Inter"/>
+              </a:defRPr>
+            </a:pPr>
+            <a:r>
+              <a:rPr>
+                <a:latin typeface="Inter"/>
+              </a:rPr>
+              <a:t>Illustrative, Gradient Maintained — demo data, not the client's holdings or managers</a:t>
+            </a:r>
+          </a:p>
+        </p:txBody>
+      </p:sp>
+      <p:sp>
+        <p:nvSpPr>
+          <p:cNvPr id="5" name="TextBox 4"/>
           <p:cNvSpPr txBox="1"/>
           <p:nvPr/>
         </p:nvSpPr>
@@ -8358,7 +8904,7 @@
       </p:sp>
       <p:sp>
         <p:nvSpPr>
-          <p:cNvPr id="5" name="Rectangle 4"/>
+          <p:cNvPr id="6" name="Rectangle 5"/>
           <p:cNvSpPr/>
           <p:nvPr/>
         </p:nvSpPr>
@@ -8407,7 +8953,7 @@
       </p:sp>
       <p:sp>
         <p:nvSpPr>
-          <p:cNvPr id="6" name="Rectangle 5"/>
+          <p:cNvPr id="7" name="Rectangle 6"/>
           <p:cNvSpPr/>
           <p:nvPr/>
         </p:nvSpPr>
@@ -8456,7 +9002,7 @@
       </p:sp>
       <p:sp>
         <p:nvSpPr>
-          <p:cNvPr id="7" name="TextBox 6"/>
+          <p:cNvPr id="8" name="TextBox 7"/>
           <p:cNvSpPr txBox="1"/>
           <p:nvPr/>
         </p:nvSpPr>
@@ -8498,7 +9044,7 @@
       </p:sp>
       <p:graphicFrame>
         <p:nvGraphicFramePr>
-          <p:cNvPr id="8" name="Table 7"/>
+          <p:cNvPr id="9" name="Table 8"/>
           <p:cNvGraphicFramePr>
             <a:graphicFrameLocks noGrp="1"/>
           </p:cNvGraphicFramePr>
@@ -8506,7 +9052,7 @@
         </p:nvGraphicFramePr>
         <p:xfrm>
           <a:off x="640080" y="1325880"/>
-          <a:ext cx="10908792" cy="1169662"/>
+          <a:ext cx="10908792" cy="968494"/>
         </p:xfrm>
         <a:graphic>
           <a:graphicData uri="http://schemas.openxmlformats.org/drawingml/2006/table">
@@ -8525,7 +9071,7 @@
                 <a:gridCol w="1112139"/>
                 <a:gridCol w="1112139"/>
               </a:tblGrid>
-              <a:tr h="584831">
+              <a:tr h="484247">
                 <a:tc>
                   <a:txBody>
                     <a:bodyPr/>
@@ -8770,7 +9316,7 @@
                   </a:tcPr>
                 </a:tc>
               </a:tr>
-              <a:tr h="584831">
+              <a:tr h="484247">
                 <a:tc>
                   <a:txBody>
                     <a:bodyPr/>
@@ -8896,7 +9442,7 @@
                         <a:rPr>
                           <a:latin typeface="Inter"/>
                         </a:rPr>
-                        <a:t>fixture=true</a:t>
+                        <a:t>illustrative sample</a:t>
                       </a:r>
                     </a:p>
                   </a:txBody>
@@ -8950,7 +9496,7 @@
                         <a:rPr>
                           <a:latin typeface="Inter"/>
                         </a:rPr>
-                        <a:t>Gradient-governed TEST evidence</a:t>
+                        <a:t>Gradient-governed review evidence</a:t>
                       </a:r>
                     </a:p>
                   </a:txBody>
@@ -9021,7 +9567,49 @@
       </p:graphicFrame>
       <p:sp>
         <p:nvSpPr>
-          <p:cNvPr id="9" name="Rectangle 8"/>
+          <p:cNvPr id="10" name="TextBox 9"/>
+          <p:cNvSpPr txBox="1"/>
+          <p:nvPr/>
+        </p:nvSpPr>
+        <p:spPr>
+          <a:xfrm>
+            <a:off x="640080" y="2312662"/>
+            <a:ext cx="10908792" cy="164592"/>
+          </a:xfrm>
+          <a:prstGeom prst="rect">
+            <a:avLst/>
+          </a:prstGeom>
+          <a:noFill/>
+        </p:spPr>
+        <p:txBody>
+          <a:bodyPr wrap="none" lIns="9144" rIns="9144" tIns="9144" bIns="9144" anchor="t">
+            <a:spAutoFit/>
+          </a:bodyPr>
+          <a:lstStyle/>
+          <a:p>
+            <a:pPr algn="l">
+              <a:spcAft>
+                <a:spcPts val="0"/>
+              </a:spcAft>
+              <a:defRPr sz="680" b="0">
+                <a:solidFill>
+                  <a:srgbClr val="8A94A1"/>
+                </a:solidFill>
+                <a:latin typeface="Inter"/>
+              </a:defRPr>
+            </a:pPr>
+            <a:r>
+              <a:rPr>
+                <a:latin typeface="Inter"/>
+              </a:rPr>
+              <a:t>Illustrative, Gradient Maintained — demo data, not the client's holdings or managers. All organizations, portfolios, managers and results in this public example are illustrative.</a:t>
+            </a:r>
+          </a:p>
+        </p:txBody>
+      </p:sp>
+      <p:sp>
+        <p:nvSpPr>
+          <p:cNvPr id="11" name="Rectangle 10"/>
           <p:cNvSpPr/>
           <p:nvPr/>
         </p:nvSpPr>
@@ -9070,7 +9658,7 @@
       </p:sp>
       <p:sp>
         <p:nvSpPr>
-          <p:cNvPr id="10" name="Rectangle 9"/>
+          <p:cNvPr id="12" name="Rectangle 11"/>
           <p:cNvSpPr/>
           <p:nvPr/>
         </p:nvSpPr>
@@ -9119,7 +9707,7 @@
       </p:sp>
       <p:sp>
         <p:nvSpPr>
-          <p:cNvPr id="11" name="TextBox 10"/>
+          <p:cNvPr id="13" name="TextBox 12"/>
           <p:cNvSpPr txBox="1"/>
           <p:nvPr/>
         </p:nvSpPr>
@@ -9161,7 +9749,7 @@
       </p:sp>
       <p:sp>
         <p:nvSpPr>
-          <p:cNvPr id="12" name="TextBox 11"/>
+          <p:cNvPr id="14" name="TextBox 13"/>
           <p:cNvSpPr txBox="1"/>
           <p:nvPr/>
         </p:nvSpPr>
@@ -9203,7 +9791,7 @@
       </p:sp>
       <p:sp>
         <p:nvSpPr>
-          <p:cNvPr id="13" name="Rectangle 12"/>
+          <p:cNvPr id="15" name="Rectangle 14"/>
           <p:cNvSpPr/>
           <p:nvPr/>
         </p:nvSpPr>
@@ -9252,7 +9840,7 @@
       </p:sp>
       <p:sp>
         <p:nvSpPr>
-          <p:cNvPr id="14" name="Rectangle 13"/>
+          <p:cNvPr id="16" name="Rectangle 15"/>
           <p:cNvSpPr/>
           <p:nvPr/>
         </p:nvSpPr>
@@ -9301,7 +9889,7 @@
       </p:sp>
       <p:sp>
         <p:nvSpPr>
-          <p:cNvPr id="15" name="TextBox 14"/>
+          <p:cNvPr id="17" name="TextBox 16"/>
           <p:cNvSpPr txBox="1"/>
           <p:nvPr/>
         </p:nvSpPr>
@@ -9343,7 +9931,7 @@
       </p:sp>
       <p:sp>
         <p:nvSpPr>
-          <p:cNvPr id="16" name="TextBox 15"/>
+          <p:cNvPr id="18" name="TextBox 17"/>
           <p:cNvSpPr txBox="1"/>
           <p:nvPr/>
         </p:nvSpPr>
@@ -9385,7 +9973,7 @@
       </p:sp>
       <p:sp>
         <p:nvSpPr>
-          <p:cNvPr id="17" name="Rectangle 16"/>
+          <p:cNvPr id="19" name="Rectangle 18"/>
           <p:cNvSpPr/>
           <p:nvPr/>
         </p:nvSpPr>
@@ -9434,7 +10022,7 @@
       </p:sp>
       <p:sp>
         <p:nvSpPr>
-          <p:cNvPr id="18" name="TextBox 17"/>
+          <p:cNvPr id="20" name="TextBox 19"/>
           <p:cNvSpPr txBox="1"/>
           <p:nvPr/>
         </p:nvSpPr>
@@ -9476,7 +10064,7 @@
       </p:sp>
       <p:sp>
         <p:nvSpPr>
-          <p:cNvPr id="19" name="TextBox 18"/>
+          <p:cNvPr id="21" name="TextBox 20"/>
           <p:cNvSpPr txBox="1"/>
           <p:nvPr/>
         </p:nvSpPr>
@@ -9511,14 +10099,14 @@
               <a:rPr>
                 <a:latin typeface="Inter"/>
               </a:rPr>
-              <a:t>Confidential — prepared for internal investment use · Data as of 2025-12-31</a:t>
-            </a:r>
-          </a:p>
-        </p:txBody>
-      </p:sp>
-      <p:sp>
-        <p:nvSpPr>
-          <p:cNvPr id="20" name="TextBox 19"/>
+              <a:t>Confidential — manager selection review · Data as of 2025-12-31</a:t>
+            </a:r>
+          </a:p>
+        </p:txBody>
+      </p:sp>
+      <p:sp>
+        <p:nvSpPr>
+          <p:cNvPr id="22" name="TextBox 21"/>
           <p:cNvSpPr txBox="1"/>
           <p:nvPr/>
         </p:nvSpPr>
@@ -9634,7 +10222,7 @@
         <p:spPr>
           <a:xfrm>
             <a:off x="640080" y="329184"/>
-            <a:ext cx="9875520" cy="182880"/>
+            <a:ext cx="5303520" cy="182880"/>
           </a:xfrm>
           <a:prstGeom prst="rect">
             <a:avLst/>
@@ -9662,7 +10250,7 @@
               <a:rPr>
                 <a:latin typeface="Inter"/>
               </a:rPr>
-              <a:t>SAVED FICTIONAL TEST EVIDENCE</a:t>
+              <a:t>SAVED ILLUSTRATIVE SAMPLE EVIDENCE</a:t>
             </a:r>
           </a:p>
         </p:txBody>
@@ -9670,6 +10258,48 @@
       <p:sp>
         <p:nvSpPr>
           <p:cNvPr id="4" name="TextBox 3"/>
+          <p:cNvSpPr txBox="1"/>
+          <p:nvPr/>
+        </p:nvSpPr>
+        <p:spPr>
+          <a:xfrm>
+            <a:off x="5897880" y="310896"/>
+            <a:ext cx="4800600" cy="256032"/>
+          </a:xfrm>
+          <a:prstGeom prst="rect">
+            <a:avLst/>
+          </a:prstGeom>
+          <a:noFill/>
+        </p:spPr>
+        <p:txBody>
+          <a:bodyPr wrap="none" lIns="9144" rIns="9144" tIns="9144" bIns="9144" anchor="t">
+            <a:spAutoFit/>
+          </a:bodyPr>
+          <a:lstStyle/>
+          <a:p>
+            <a:pPr algn="r">
+              <a:spcAft>
+                <a:spcPts val="0"/>
+              </a:spcAft>
+              <a:defRPr sz="680" b="1">
+                <a:solidFill>
+                  <a:srgbClr val="4F6B00"/>
+                </a:solidFill>
+                <a:latin typeface="Inter"/>
+              </a:defRPr>
+            </a:pPr>
+            <a:r>
+              <a:rPr>
+                <a:latin typeface="Inter"/>
+              </a:rPr>
+              <a:t>Illustrative, Gradient Maintained — demo data, not the client's holdings or managers</a:t>
+            </a:r>
+          </a:p>
+        </p:txBody>
+      </p:sp>
+      <p:sp>
+        <p:nvSpPr>
+          <p:cNvPr id="5" name="TextBox 4"/>
           <p:cNvSpPr txBox="1"/>
           <p:nvPr/>
         </p:nvSpPr>
@@ -9711,7 +10341,7 @@
       </p:sp>
       <p:sp>
         <p:nvSpPr>
-          <p:cNvPr id="5" name="Rectangle 4"/>
+          <p:cNvPr id="6" name="Rectangle 5"/>
           <p:cNvSpPr/>
           <p:nvPr/>
         </p:nvSpPr>
@@ -9760,7 +10390,7 @@
       </p:sp>
       <p:sp>
         <p:nvSpPr>
-          <p:cNvPr id="6" name="Rectangle 5"/>
+          <p:cNvPr id="7" name="Rectangle 6"/>
           <p:cNvSpPr/>
           <p:nvPr/>
         </p:nvSpPr>
@@ -9809,7 +10439,7 @@
       </p:sp>
       <p:sp>
         <p:nvSpPr>
-          <p:cNvPr id="7" name="TextBox 6"/>
+          <p:cNvPr id="8" name="TextBox 7"/>
           <p:cNvSpPr txBox="1"/>
           <p:nvPr/>
         </p:nvSpPr>
@@ -9851,7 +10481,7 @@
       </p:sp>
       <p:sp>
         <p:nvSpPr>
-          <p:cNvPr id="8" name="Rectangle 7"/>
+          <p:cNvPr id="9" name="Rectangle 8"/>
           <p:cNvSpPr/>
           <p:nvPr/>
         </p:nvSpPr>
@@ -9900,7 +10530,7 @@
       </p:sp>
       <p:sp>
         <p:nvSpPr>
-          <p:cNvPr id="9" name="Rectangle 8"/>
+          <p:cNvPr id="10" name="Rectangle 9"/>
           <p:cNvSpPr/>
           <p:nvPr/>
         </p:nvSpPr>
@@ -9949,7 +10579,7 @@
       </p:sp>
       <p:sp>
         <p:nvSpPr>
-          <p:cNvPr id="10" name="TextBox 9"/>
+          <p:cNvPr id="11" name="TextBox 10"/>
           <p:cNvSpPr txBox="1"/>
           <p:nvPr/>
         </p:nvSpPr>
@@ -9991,7 +10621,7 @@
       </p:sp>
       <p:sp>
         <p:nvSpPr>
-          <p:cNvPr id="11" name="TextBox 10"/>
+          <p:cNvPr id="12" name="TextBox 11"/>
           <p:cNvSpPr txBox="1"/>
           <p:nvPr/>
         </p:nvSpPr>
@@ -10033,7 +10663,7 @@
       </p:sp>
       <p:sp>
         <p:nvSpPr>
-          <p:cNvPr id="12" name="Rectangle 11"/>
+          <p:cNvPr id="13" name="Rectangle 12"/>
           <p:cNvSpPr/>
           <p:nvPr/>
         </p:nvSpPr>
@@ -10082,7 +10712,7 @@
       </p:sp>
       <p:sp>
         <p:nvSpPr>
-          <p:cNvPr id="13" name="TextBox 12"/>
+          <p:cNvPr id="14" name="TextBox 13"/>
           <p:cNvSpPr txBox="1"/>
           <p:nvPr/>
         </p:nvSpPr>
@@ -10124,7 +10754,7 @@
       </p:sp>
       <p:sp>
         <p:nvSpPr>
-          <p:cNvPr id="14" name="TextBox 13"/>
+          <p:cNvPr id="15" name="TextBox 14"/>
           <p:cNvSpPr txBox="1"/>
           <p:nvPr/>
         </p:nvSpPr>
@@ -10159,14 +10789,14 @@
               <a:rPr>
                 <a:latin typeface="Inter"/>
               </a:rPr>
-              <a:t>Confidential — prepared for internal investment use · Data as of 2025-12-31</a:t>
-            </a:r>
-          </a:p>
-        </p:txBody>
-      </p:sp>
-      <p:sp>
-        <p:nvSpPr>
-          <p:cNvPr id="15" name="TextBox 14"/>
+              <a:t>Confidential — manager selection review · Data as of 2025-12-31</a:t>
+            </a:r>
+          </a:p>
+        </p:txBody>
+      </p:sp>
+      <p:sp>
+        <p:nvSpPr>
+          <p:cNvPr id="16" name="TextBox 15"/>
           <p:cNvSpPr txBox="1"/>
           <p:nvPr/>
         </p:nvSpPr>

</xml_diff>

<commit_message>
feat: polish report covers, wording and layout (6.2.0)
Clean title-page covers, plain-language status labels with connector display_label, rebuilt sources appendix, true-scale printing with a width-overflow QA gate and updated page budgets, chart fixes, and layout QA refinements. See CHANGELOG 6.2.0.

Co-authored-by: Cursor <cursoragent@cursor.com>
</commit_message>
<xml_diff>
--- a/plugins/gradient-cio/assets/examples/gradient-idd-manager-performance-compare.pptx
+++ b/plugins/gradient-cio/assets/examples/gradient-idd-manager-performance-compare.pptx
@@ -3223,7 +3223,7 @@
               <a:rPr>
                 <a:latin typeface="Inter"/>
               </a:rPr>
-              <a:t>EVIDENCE</a:t>
+              <a:t>PREPARED FOR</a:t>
             </a:r>
           </a:p>
         </p:txBody>
@@ -3265,7 +3265,7 @@
               <a:rPr>
                 <a:latin typeface="Inter"/>
               </a:rPr>
-              <a:t>Governed return series</a:t>
+              <a:t>Investment Committee</a:t>
             </a:r>
           </a:p>
         </p:txBody>
@@ -3307,7 +3307,7 @@
               <a:rPr>
                 <a:latin typeface="Inter"/>
               </a:rPr>
-              <a:t>AUDIENCE</a:t>
+              <a:t>DATA AS OF</a:t>
             </a:r>
           </a:p>
         </p:txBody>
@@ -3349,7 +3349,7 @@
               <a:rPr>
                 <a:latin typeface="Inter"/>
               </a:rPr>
-              <a:t>Investment Committee</a:t>
+              <a:t>2025-12-31</a:t>
             </a:r>
           </a:p>
         </p:txBody>
@@ -3357,307 +3357,6 @@
       <p:sp>
         <p:nvSpPr>
           <p:cNvPr id="15" name="TextBox 14"/>
-          <p:cNvSpPr txBox="1"/>
-          <p:nvPr/>
-        </p:nvSpPr>
-        <p:spPr>
-          <a:xfrm>
-            <a:off x="5852160" y="4937759"/>
-            <a:ext cx="4709160" cy="182880"/>
-          </a:xfrm>
-          <a:prstGeom prst="rect">
-            <a:avLst/>
-          </a:prstGeom>
-          <a:noFill/>
-        </p:spPr>
-        <p:txBody>
-          <a:bodyPr wrap="none" lIns="9144" rIns="9144" tIns="9144" bIns="9144" anchor="t">
-            <a:spAutoFit/>
-          </a:bodyPr>
-          <a:lstStyle/>
-          <a:p>
-            <a:pPr algn="l">
-              <a:spcAft>
-                <a:spcPts val="0"/>
-              </a:spcAft>
-              <a:defRPr sz="700" b="1">
-                <a:solidFill>
-                  <a:srgbClr val="8A94A1"/>
-                </a:solidFill>
-                <a:latin typeface="Inter"/>
-              </a:defRPr>
-            </a:pPr>
-            <a:r>
-              <a:rPr>
-                <a:latin typeface="Inter"/>
-              </a:rPr>
-              <a:t>DATA AS OF</a:t>
-            </a:r>
-          </a:p>
-        </p:txBody>
-      </p:sp>
-      <p:sp>
-        <p:nvSpPr>
-          <p:cNvPr id="16" name="TextBox 15"/>
-          <p:cNvSpPr txBox="1"/>
-          <p:nvPr/>
-        </p:nvSpPr>
-        <p:spPr>
-          <a:xfrm>
-            <a:off x="5852160" y="5129783"/>
-            <a:ext cx="4709160" cy="310896"/>
-          </a:xfrm>
-          <a:prstGeom prst="rect">
-            <a:avLst/>
-          </a:prstGeom>
-          <a:noFill/>
-        </p:spPr>
-        <p:txBody>
-          <a:bodyPr wrap="none" lIns="9144" rIns="9144" tIns="9144" bIns="9144" anchor="t">
-            <a:spAutoFit/>
-          </a:bodyPr>
-          <a:lstStyle/>
-          <a:p>
-            <a:pPr algn="l">
-              <a:spcAft>
-                <a:spcPts val="0"/>
-              </a:spcAft>
-              <a:defRPr sz="1000" b="1">
-                <a:solidFill>
-                  <a:srgbClr val="FFFFFF"/>
-                </a:solidFill>
-                <a:latin typeface="Inter"/>
-              </a:defRPr>
-            </a:pPr>
-            <a:r>
-              <a:rPr>
-                <a:latin typeface="Inter"/>
-              </a:rPr>
-              <a:t>2025-12-31</a:t>
-            </a:r>
-          </a:p>
-        </p:txBody>
-      </p:sp>
-      <p:sp>
-        <p:nvSpPr>
-          <p:cNvPr id="17" name="Rectangle 16"/>
-          <p:cNvSpPr/>
-          <p:nvPr/>
-        </p:nvSpPr>
-        <p:spPr>
-          <a:xfrm>
-            <a:off x="685800" y="5687568"/>
-            <a:ext cx="3337560" cy="530352"/>
-          </a:xfrm>
-          <a:prstGeom prst="rect">
-            <a:avLst/>
-          </a:prstGeom>
-          <a:solidFill>
-            <a:srgbClr val="9AA5B1"/>
-          </a:solidFill>
-          <a:ln>
-            <a:solidFill>
-              <a:srgbClr val="9AA5B1"/>
-            </a:solidFill>
-          </a:ln>
-        </p:spPr>
-        <p:style>
-          <a:lnRef idx="1">
-            <a:schemeClr val="accent1"/>
-          </a:lnRef>
-          <a:fillRef idx="3">
-            <a:schemeClr val="accent1"/>
-          </a:fillRef>
-          <a:effectRef idx="2">
-            <a:schemeClr val="accent1"/>
-          </a:effectRef>
-          <a:fontRef idx="minor">
-            <a:schemeClr val="lt1"/>
-          </a:fontRef>
-        </p:style>
-        <p:txBody>
-          <a:bodyPr rtlCol="0" anchor="ctr"/>
-          <a:lstStyle/>
-          <a:p>
-            <a:pPr algn="ctr">
-              <a:defRPr>
-                <a:latin typeface="Inter"/>
-              </a:defRPr>
-            </a:pPr>
-          </a:p>
-        </p:txBody>
-      </p:sp>
-      <p:sp>
-        <p:nvSpPr>
-          <p:cNvPr id="18" name="TextBox 17"/>
-          <p:cNvSpPr txBox="1"/>
-          <p:nvPr/>
-        </p:nvSpPr>
-        <p:spPr>
-          <a:xfrm>
-            <a:off x="822960" y="5760720"/>
-            <a:ext cx="3063240" cy="128016"/>
-          </a:xfrm>
-          <a:prstGeom prst="rect">
-            <a:avLst/>
-          </a:prstGeom>
-          <a:noFill/>
-        </p:spPr>
-        <p:txBody>
-          <a:bodyPr wrap="none" lIns="9144" rIns="9144" tIns="9144" bIns="9144" anchor="t">
-            <a:spAutoFit/>
-          </a:bodyPr>
-          <a:lstStyle/>
-          <a:p>
-            <a:pPr algn="l">
-              <a:spcAft>
-                <a:spcPts val="0"/>
-              </a:spcAft>
-              <a:defRPr sz="620" b="1">
-                <a:solidFill>
-                  <a:srgbClr val="0D1117"/>
-                </a:solidFill>
-                <a:latin typeface="Inter"/>
-              </a:defRPr>
-            </a:pPr>
-            <a:r>
-              <a:rPr>
-                <a:latin typeface="Inter"/>
-              </a:rPr>
-              <a:t>OVERALL VIEW</a:t>
-            </a:r>
-          </a:p>
-        </p:txBody>
-      </p:sp>
-      <p:sp>
-        <p:nvSpPr>
-          <p:cNvPr id="19" name="TextBox 18"/>
-          <p:cNvSpPr txBox="1"/>
-          <p:nvPr/>
-        </p:nvSpPr>
-        <p:spPr>
-          <a:xfrm>
-            <a:off x="822960" y="5916168"/>
-            <a:ext cx="3063240" cy="182880"/>
-          </a:xfrm>
-          <a:prstGeom prst="rect">
-            <a:avLst/>
-          </a:prstGeom>
-          <a:noFill/>
-        </p:spPr>
-        <p:txBody>
-          <a:bodyPr wrap="none" lIns="9144" rIns="9144" tIns="9144" bIns="9144" anchor="t">
-            <a:spAutoFit/>
-          </a:bodyPr>
-          <a:lstStyle/>
-          <a:p>
-            <a:pPr algn="l">
-              <a:spcAft>
-                <a:spcPts val="0"/>
-              </a:spcAft>
-              <a:defRPr sz="900" b="1">
-                <a:solidFill>
-                  <a:srgbClr val="0D1117"/>
-                </a:solidFill>
-                <a:latin typeface="Inter"/>
-              </a:defRPr>
-            </a:pPr>
-            <a:r>
-              <a:rPr>
-                <a:latin typeface="Inter"/>
-              </a:rPr>
-              <a:t>Insufficient governed evidence</a:t>
-            </a:r>
-          </a:p>
-        </p:txBody>
-      </p:sp>
-      <p:sp>
-        <p:nvSpPr>
-          <p:cNvPr id="20" name="TextBox 19"/>
-          <p:cNvSpPr txBox="1"/>
-          <p:nvPr/>
-        </p:nvSpPr>
-        <p:spPr>
-          <a:xfrm>
-            <a:off x="4297680" y="5733288"/>
-            <a:ext cx="3108960" cy="164592"/>
-          </a:xfrm>
-          <a:prstGeom prst="rect">
-            <a:avLst/>
-          </a:prstGeom>
-          <a:noFill/>
-        </p:spPr>
-        <p:txBody>
-          <a:bodyPr wrap="none" lIns="9144" rIns="9144" tIns="9144" bIns="9144" anchor="t">
-            <a:spAutoFit/>
-          </a:bodyPr>
-          <a:lstStyle/>
-          <a:p>
-            <a:pPr algn="l">
-              <a:spcAft>
-                <a:spcPts val="0"/>
-              </a:spcAft>
-              <a:defRPr sz="650" b="1">
-                <a:solidFill>
-                  <a:srgbClr val="8A94A1"/>
-                </a:solidFill>
-                <a:latin typeface="Inter"/>
-              </a:defRPr>
-            </a:pPr>
-            <a:r>
-              <a:rPr>
-                <a:latin typeface="Inter"/>
-              </a:rPr>
-              <a:t>SCOPE REVIEWED</a:t>
-            </a:r>
-          </a:p>
-        </p:txBody>
-      </p:sp>
-      <p:sp>
-        <p:nvSpPr>
-          <p:cNvPr id="21" name="TextBox 20"/>
-          <p:cNvSpPr txBox="1"/>
-          <p:nvPr/>
-        </p:nvSpPr>
-        <p:spPr>
-          <a:xfrm>
-            <a:off x="4297680" y="5934456"/>
-            <a:ext cx="3108960" cy="201168"/>
-          </a:xfrm>
-          <a:prstGeom prst="rect">
-            <a:avLst/>
-          </a:prstGeom>
-          <a:noFill/>
-        </p:spPr>
-        <p:txBody>
-          <a:bodyPr wrap="none" lIns="9144" rIns="9144" tIns="9144" bIns="9144" anchor="t">
-            <a:spAutoFit/>
-          </a:bodyPr>
-          <a:lstStyle/>
-          <a:p>
-            <a:pPr algn="l">
-              <a:spcAft>
-                <a:spcPts val="0"/>
-              </a:spcAft>
-              <a:defRPr sz="800" b="1">
-                <a:solidFill>
-                  <a:srgbClr val="FFFFFF"/>
-                </a:solidFill>
-                <a:latin typeface="Inter"/>
-              </a:defRPr>
-            </a:pPr>
-            <a:r>
-              <a:rPr>
-                <a:latin typeface="Inter"/>
-              </a:rPr>
-              <a:t>1 of 4 · Partial</a:t>
-            </a:r>
-          </a:p>
-        </p:txBody>
-      </p:sp>
-      <p:sp>
-        <p:nvSpPr>
-          <p:cNvPr id="22" name="TextBox 21"/>
           <p:cNvSpPr txBox="1"/>
           <p:nvPr/>
         </p:nvSpPr>
@@ -3699,7 +3398,7 @@
       </p:sp>
       <p:sp>
         <p:nvSpPr>
-          <p:cNvPr id="23" name="TextBox 22"/>
+          <p:cNvPr id="16" name="TextBox 15"/>
           <p:cNvSpPr txBox="1"/>
           <p:nvPr/>
         </p:nvSpPr>
@@ -3741,7 +3440,7 @@
       </p:sp>
       <p:sp>
         <p:nvSpPr>
-          <p:cNvPr id="24" name="TextBox 23"/>
+          <p:cNvPr id="17" name="TextBox 16"/>
           <p:cNvSpPr txBox="1"/>
           <p:nvPr/>
         </p:nvSpPr>
@@ -3857,7 +3556,7 @@
         <p:spPr>
           <a:xfrm>
             <a:off x="640080" y="329184"/>
-            <a:ext cx="5303520" cy="182880"/>
+            <a:ext cx="9875520" cy="182880"/>
           </a:xfrm>
           <a:prstGeom prst="rect">
             <a:avLst/>
@@ -3898,48 +3597,6 @@
         </p:nvSpPr>
         <p:spPr>
           <a:xfrm>
-            <a:off x="5897880" y="310896"/>
-            <a:ext cx="4800600" cy="256032"/>
-          </a:xfrm>
-          <a:prstGeom prst="rect">
-            <a:avLst/>
-          </a:prstGeom>
-          <a:noFill/>
-        </p:spPr>
-        <p:txBody>
-          <a:bodyPr wrap="none" lIns="9144" rIns="9144" tIns="9144" bIns="9144" anchor="t">
-            <a:spAutoFit/>
-          </a:bodyPr>
-          <a:lstStyle/>
-          <a:p>
-            <a:pPr algn="r">
-              <a:spcAft>
-                <a:spcPts val="0"/>
-              </a:spcAft>
-              <a:defRPr sz="680" b="1">
-                <a:solidFill>
-                  <a:srgbClr val="4F6B00"/>
-                </a:solidFill>
-                <a:latin typeface="Inter"/>
-              </a:defRPr>
-            </a:pPr>
-            <a:r>
-              <a:rPr>
-                <a:latin typeface="Inter"/>
-              </a:rPr>
-              <a:t>Illustrative, Gradient Maintained — demo data, not the client's holdings or managers</a:t>
-            </a:r>
-          </a:p>
-        </p:txBody>
-      </p:sp>
-      <p:sp>
-        <p:nvSpPr>
-          <p:cNvPr id="5" name="TextBox 4"/>
-          <p:cNvSpPr txBox="1"/>
-          <p:nvPr/>
-        </p:nvSpPr>
-        <p:spPr>
-          <a:xfrm>
             <a:off x="640080" y="566928"/>
             <a:ext cx="10058400" cy="530352"/>
           </a:xfrm>
@@ -3976,7 +3633,7 @@
       </p:sp>
       <p:sp>
         <p:nvSpPr>
-          <p:cNvPr id="6" name="Rectangle 5"/>
+          <p:cNvPr id="5" name="Rectangle 4"/>
           <p:cNvSpPr/>
           <p:nvPr/>
         </p:nvSpPr>
@@ -4025,7 +3682,7 @@
       </p:sp>
       <p:sp>
         <p:nvSpPr>
-          <p:cNvPr id="7" name="Rectangle 6"/>
+          <p:cNvPr id="6" name="Rectangle 5"/>
           <p:cNvSpPr/>
           <p:nvPr/>
         </p:nvSpPr>
@@ -4074,7 +3731,7 @@
       </p:sp>
       <p:sp>
         <p:nvSpPr>
-          <p:cNvPr id="8" name="TextBox 7"/>
+          <p:cNvPr id="7" name="TextBox 6"/>
           <p:cNvSpPr txBox="1"/>
           <p:nvPr/>
         </p:nvSpPr>
@@ -4116,14 +3773,14 @@
       </p:sp>
       <p:sp>
         <p:nvSpPr>
-          <p:cNvPr id="9" name="Rectangle 8"/>
+          <p:cNvPr id="8" name="Rectangle 7"/>
           <p:cNvSpPr/>
           <p:nvPr/>
         </p:nvSpPr>
         <p:spPr>
           <a:xfrm>
             <a:off x="640080" y="1325880"/>
-            <a:ext cx="10908792" cy="1557527"/>
+            <a:ext cx="10908792" cy="1615379"/>
           </a:xfrm>
           <a:prstGeom prst="rect">
             <a:avLst/>
@@ -4165,14 +3822,14 @@
       </p:sp>
       <p:sp>
         <p:nvSpPr>
-          <p:cNvPr id="10" name="Rectangle 9"/>
+          <p:cNvPr id="9" name="Rectangle 8"/>
           <p:cNvSpPr/>
           <p:nvPr/>
         </p:nvSpPr>
         <p:spPr>
           <a:xfrm>
             <a:off x="640080" y="1325880"/>
-            <a:ext cx="54864" cy="1557527"/>
+            <a:ext cx="54864" cy="1615379"/>
           </a:xfrm>
           <a:prstGeom prst="rect">
             <a:avLst/>
@@ -4214,7 +3871,7 @@
       </p:sp>
       <p:sp>
         <p:nvSpPr>
-          <p:cNvPr id="11" name="TextBox 10"/>
+          <p:cNvPr id="10" name="TextBox 9"/>
           <p:cNvSpPr txBox="1"/>
           <p:nvPr/>
         </p:nvSpPr>
@@ -4256,14 +3913,14 @@
       </p:sp>
       <p:sp>
         <p:nvSpPr>
-          <p:cNvPr id="12" name="TextBox 11"/>
+          <p:cNvPr id="11" name="TextBox 10"/>
           <p:cNvSpPr txBox="1"/>
           <p:nvPr/>
         </p:nvSpPr>
         <p:spPr>
           <a:xfrm>
             <a:off x="804671" y="1719072"/>
-            <a:ext cx="10616184" cy="1072895"/>
+            <a:ext cx="10616184" cy="1130747"/>
           </a:xfrm>
           <a:prstGeom prst="rect">
             <a:avLst/>
@@ -4291,21 +3948,21 @@
               <a:rPr>
                 <a:latin typeface="Inter"/>
               </a:rPr>
-              <a:t>Observation: Coverage is incomplete [S1]. Why it matters: Comparison is constrained. Uncertainty: Missing reads may change results. What would change the view: Governed comparison evidence.</a:t>
-            </a:r>
-          </a:p>
-        </p:txBody>
-      </p:sp>
-      <p:sp>
-        <p:nvSpPr>
-          <p:cNvPr id="13" name="Rectangle 12"/>
+              <a:t>Observation: Only one of four comparison inputs is available [S1]. Why it matters: Managers cannot be ranked on one input. Uncertainty: Missing return series may change the order. What would change the view: Return series for every candidate.</a:t>
+            </a:r>
+          </a:p>
+        </p:txBody>
+      </p:sp>
+      <p:sp>
+        <p:nvSpPr>
+          <p:cNvPr id="12" name="Rectangle 11"/>
           <p:cNvSpPr/>
           <p:nvPr/>
         </p:nvSpPr>
         <p:spPr>
           <a:xfrm>
-            <a:off x="640080" y="2993136"/>
-            <a:ext cx="10908792" cy="1557527"/>
+            <a:off x="640080" y="3050987"/>
+            <a:ext cx="10908792" cy="1521927"/>
           </a:xfrm>
           <a:prstGeom prst="rect">
             <a:avLst/>
@@ -4347,14 +4004,14 @@
       </p:sp>
       <p:sp>
         <p:nvSpPr>
-          <p:cNvPr id="14" name="Rectangle 13"/>
+          <p:cNvPr id="13" name="Rectangle 12"/>
           <p:cNvSpPr/>
           <p:nvPr/>
         </p:nvSpPr>
         <p:spPr>
           <a:xfrm>
-            <a:off x="640080" y="2993136"/>
-            <a:ext cx="54864" cy="1557527"/>
+            <a:off x="640080" y="3050987"/>
+            <a:ext cx="54864" cy="1521927"/>
           </a:xfrm>
           <a:prstGeom prst="rect">
             <a:avLst/>
@@ -4396,13 +4053,13 @@
       </p:sp>
       <p:sp>
         <p:nvSpPr>
-          <p:cNvPr id="15" name="TextBox 14"/>
+          <p:cNvPr id="14" name="TextBox 13"/>
           <p:cNvSpPr txBox="1"/>
           <p:nvPr/>
         </p:nvSpPr>
         <p:spPr>
           <a:xfrm>
-            <a:off x="804671" y="3102864"/>
+            <a:off x="804671" y="3160715"/>
             <a:ext cx="10616184" cy="228600"/>
           </a:xfrm>
           <a:prstGeom prst="rect">
@@ -4438,14 +4095,14 @@
       </p:sp>
       <p:sp>
         <p:nvSpPr>
-          <p:cNvPr id="16" name="TextBox 15"/>
+          <p:cNvPr id="15" name="TextBox 14"/>
           <p:cNvSpPr txBox="1"/>
           <p:nvPr/>
         </p:nvSpPr>
         <p:spPr>
           <a:xfrm>
-            <a:off x="804671" y="3386328"/>
-            <a:ext cx="10616184" cy="1072895"/>
+            <a:off x="804671" y="3444179"/>
+            <a:ext cx="10616184" cy="1037295"/>
           </a:xfrm>
           <a:prstGeom prst="rect">
             <a:avLst/>
@@ -4473,21 +4130,21 @@
               <a:rPr>
                 <a:latin typeface="Inter"/>
               </a:rPr>
-              <a:t>Observation: Benchmark matching is advisory [S1]. Why it matters: Relative evidence is bounded. Uncertainty: Mandate fit is unconfirmed. What would change the view: Canonical matches.</a:t>
-            </a:r>
-          </a:p>
-        </p:txBody>
-      </p:sp>
-      <p:sp>
-        <p:nvSpPr>
-          <p:cNvPr id="17" name="Rectangle 16"/>
+              <a:t>Observation: Benchmark matches are suggested, not confirmed [S1]. Why it matters: Relative results depend on the right benchmark. Uncertainty: Mandate fit is unconfirmed. What would change the view: Confirmed benchmark mappings.</a:t>
+            </a:r>
+          </a:p>
+        </p:txBody>
+      </p:sp>
+      <p:sp>
+        <p:nvSpPr>
+          <p:cNvPr id="16" name="Rectangle 15"/>
           <p:cNvSpPr/>
           <p:nvPr/>
         </p:nvSpPr>
         <p:spPr>
           <a:xfrm>
-            <a:off x="640080" y="4660392"/>
-            <a:ext cx="10908792" cy="1557527"/>
+            <a:off x="640080" y="4682642"/>
+            <a:ext cx="10908792" cy="1535277"/>
           </a:xfrm>
           <a:prstGeom prst="rect">
             <a:avLst/>
@@ -4529,14 +4186,14 @@
       </p:sp>
       <p:sp>
         <p:nvSpPr>
-          <p:cNvPr id="18" name="Rectangle 17"/>
+          <p:cNvPr id="17" name="Rectangle 16"/>
           <p:cNvSpPr/>
           <p:nvPr/>
         </p:nvSpPr>
         <p:spPr>
           <a:xfrm>
-            <a:off x="640080" y="4660392"/>
-            <a:ext cx="54864" cy="1557527"/>
+            <a:off x="640080" y="4682642"/>
+            <a:ext cx="54864" cy="1535277"/>
           </a:xfrm>
           <a:prstGeom prst="rect">
             <a:avLst/>
@@ -4578,13 +4235,13 @@
       </p:sp>
       <p:sp>
         <p:nvSpPr>
-          <p:cNvPr id="19" name="TextBox 18"/>
+          <p:cNvPr id="18" name="TextBox 17"/>
           <p:cNvSpPr txBox="1"/>
           <p:nvPr/>
         </p:nvSpPr>
         <p:spPr>
           <a:xfrm>
-            <a:off x="804671" y="4770120"/>
+            <a:off x="804671" y="4792370"/>
             <a:ext cx="10616184" cy="228600"/>
           </a:xfrm>
           <a:prstGeom prst="rect">
@@ -4620,14 +4277,14 @@
       </p:sp>
       <p:sp>
         <p:nvSpPr>
-          <p:cNvPr id="20" name="TextBox 19"/>
+          <p:cNvPr id="19" name="TextBox 18"/>
           <p:cNvSpPr txBox="1"/>
           <p:nvPr/>
         </p:nvSpPr>
         <p:spPr>
           <a:xfrm>
-            <a:off x="804671" y="5053584"/>
-            <a:ext cx="10616184" cy="1072896"/>
+            <a:off x="804671" y="5075834"/>
+            <a:ext cx="10616184" cy="1050645"/>
           </a:xfrm>
           <a:prstGeom prst="rect">
             <a:avLst/>
@@ -4655,14 +4312,14 @@
               <a:rPr>
                 <a:latin typeface="Inter"/>
               </a:rPr>
-              <a:t>Observation: Robustness is unavailable [S1]. Why it matters: Persistence is unknown. Uncertainty: Window sensitivity is untested. What would change the view: Governed robustness results.</a:t>
-            </a:r>
-          </a:p>
-        </p:txBody>
-      </p:sp>
-      <p:sp>
-        <p:nvSpPr>
-          <p:cNvPr id="21" name="Rectangle 20"/>
+              <a:t>Observation: Robustness across date windows was not tested [S1]. Why it matters: A single window can flatter one manager. Uncertainty: Results may depend on the start date. What would change the view: A date-window robustness run.</a:t>
+            </a:r>
+          </a:p>
+        </p:txBody>
+      </p:sp>
+      <p:sp>
+        <p:nvSpPr>
+          <p:cNvPr id="20" name="Rectangle 19"/>
           <p:cNvSpPr/>
           <p:nvPr/>
         </p:nvSpPr>
@@ -4711,7 +4368,7 @@
       </p:sp>
       <p:sp>
         <p:nvSpPr>
-          <p:cNvPr id="22" name="TextBox 21"/>
+          <p:cNvPr id="21" name="TextBox 20"/>
           <p:cNvSpPr txBox="1"/>
           <p:nvPr/>
         </p:nvSpPr>
@@ -4753,7 +4410,7 @@
       </p:sp>
       <p:sp>
         <p:nvSpPr>
-          <p:cNvPr id="23" name="TextBox 22"/>
+          <p:cNvPr id="22" name="TextBox 21"/>
           <p:cNvSpPr txBox="1"/>
           <p:nvPr/>
         </p:nvSpPr>
@@ -4795,7 +4452,7 @@
       </p:sp>
       <p:sp>
         <p:nvSpPr>
-          <p:cNvPr id="24" name="TextBox 23"/>
+          <p:cNvPr id="23" name="TextBox 22"/>
           <p:cNvSpPr txBox="1"/>
           <p:nvPr/>
         </p:nvSpPr>
@@ -4911,7 +4568,7 @@
         <p:spPr>
           <a:xfrm>
             <a:off x="640080" y="329184"/>
-            <a:ext cx="5303520" cy="182880"/>
+            <a:ext cx="9875520" cy="182880"/>
           </a:xfrm>
           <a:prstGeom prst="rect">
             <a:avLst/>
@@ -4952,48 +4609,6 @@
         </p:nvSpPr>
         <p:spPr>
           <a:xfrm>
-            <a:off x="5897880" y="310896"/>
-            <a:ext cx="4800600" cy="256032"/>
-          </a:xfrm>
-          <a:prstGeom prst="rect">
-            <a:avLst/>
-          </a:prstGeom>
-          <a:noFill/>
-        </p:spPr>
-        <p:txBody>
-          <a:bodyPr wrap="none" lIns="9144" rIns="9144" tIns="9144" bIns="9144" anchor="t">
-            <a:spAutoFit/>
-          </a:bodyPr>
-          <a:lstStyle/>
-          <a:p>
-            <a:pPr algn="r">
-              <a:spcAft>
-                <a:spcPts val="0"/>
-              </a:spcAft>
-              <a:defRPr sz="680" b="1">
-                <a:solidFill>
-                  <a:srgbClr val="4F6B00"/>
-                </a:solidFill>
-                <a:latin typeface="Inter"/>
-              </a:defRPr>
-            </a:pPr>
-            <a:r>
-              <a:rPr>
-                <a:latin typeface="Inter"/>
-              </a:rPr>
-              <a:t>Illustrative, Gradient Maintained — demo data, not the client's holdings or managers</a:t>
-            </a:r>
-          </a:p>
-        </p:txBody>
-      </p:sp>
-      <p:sp>
-        <p:nvSpPr>
-          <p:cNvPr id="5" name="TextBox 4"/>
-          <p:cNvSpPr txBox="1"/>
-          <p:nvPr/>
-        </p:nvSpPr>
-        <p:spPr>
-          <a:xfrm>
             <a:off x="640080" y="566928"/>
             <a:ext cx="10058400" cy="530352"/>
           </a:xfrm>
@@ -5030,7 +4645,7 @@
       </p:sp>
       <p:sp>
         <p:nvSpPr>
-          <p:cNvPr id="6" name="Rectangle 5"/>
+          <p:cNvPr id="5" name="Rectangle 4"/>
           <p:cNvSpPr/>
           <p:nvPr/>
         </p:nvSpPr>
@@ -5079,7 +4694,7 @@
       </p:sp>
       <p:sp>
         <p:nvSpPr>
-          <p:cNvPr id="7" name="Rectangle 6"/>
+          <p:cNvPr id="6" name="Rectangle 5"/>
           <p:cNvSpPr/>
           <p:nvPr/>
         </p:nvSpPr>
@@ -5128,7 +4743,7 @@
       </p:sp>
       <p:sp>
         <p:nvSpPr>
-          <p:cNvPr id="8" name="TextBox 7"/>
+          <p:cNvPr id="7" name="TextBox 6"/>
           <p:cNvSpPr txBox="1"/>
           <p:nvPr/>
         </p:nvSpPr>
@@ -5170,7 +4785,7 @@
       </p:sp>
       <p:graphicFrame>
         <p:nvGraphicFramePr>
-          <p:cNvPr id="9" name="Table 8"/>
+          <p:cNvPr id="8" name="Table 7"/>
           <p:cNvGraphicFramePr>
             <a:graphicFrameLocks noGrp="1"/>
           </p:cNvGraphicFramePr>
@@ -5319,7 +4934,7 @@
                         <a:rPr>
                           <a:latin typeface="Inter"/>
                         </a:rPr>
-                        <a:t>● unavailable</a:t>
+                        <a:t>● Not available</a:t>
                       </a:r>
                     </a:p>
                   </a:txBody>
@@ -5363,7 +4978,7 @@
       </p:graphicFrame>
       <p:sp>
         <p:nvSpPr>
-          <p:cNvPr id="10" name="Rectangle 9"/>
+          <p:cNvPr id="9" name="Rectangle 8"/>
           <p:cNvSpPr/>
           <p:nvPr/>
         </p:nvSpPr>
@@ -5412,7 +5027,7 @@
       </p:sp>
       <p:sp>
         <p:nvSpPr>
-          <p:cNvPr id="11" name="TextBox 10"/>
+          <p:cNvPr id="10" name="TextBox 9"/>
           <p:cNvSpPr txBox="1"/>
           <p:nvPr/>
         </p:nvSpPr>
@@ -5454,7 +5069,7 @@
       </p:sp>
       <p:sp>
         <p:nvSpPr>
-          <p:cNvPr id="12" name="TextBox 11"/>
+          <p:cNvPr id="11" name="TextBox 10"/>
           <p:cNvSpPr txBox="1"/>
           <p:nvPr/>
         </p:nvSpPr>
@@ -5496,7 +5111,7 @@
       </p:sp>
       <p:sp>
         <p:nvSpPr>
-          <p:cNvPr id="13" name="TextBox 12"/>
+          <p:cNvPr id="12" name="TextBox 11"/>
           <p:cNvSpPr txBox="1"/>
           <p:nvPr/>
         </p:nvSpPr>
@@ -5612,7 +5227,7 @@
         <p:spPr>
           <a:xfrm>
             <a:off x="640080" y="329184"/>
-            <a:ext cx="5303520" cy="182880"/>
+            <a:ext cx="9875520" cy="182880"/>
           </a:xfrm>
           <a:prstGeom prst="rect">
             <a:avLst/>
@@ -5653,48 +5268,6 @@
         </p:nvSpPr>
         <p:spPr>
           <a:xfrm>
-            <a:off x="5897880" y="310896"/>
-            <a:ext cx="4800600" cy="256032"/>
-          </a:xfrm>
-          <a:prstGeom prst="rect">
-            <a:avLst/>
-          </a:prstGeom>
-          <a:noFill/>
-        </p:spPr>
-        <p:txBody>
-          <a:bodyPr wrap="none" lIns="9144" rIns="9144" tIns="9144" bIns="9144" anchor="t">
-            <a:spAutoFit/>
-          </a:bodyPr>
-          <a:lstStyle/>
-          <a:p>
-            <a:pPr algn="r">
-              <a:spcAft>
-                <a:spcPts val="0"/>
-              </a:spcAft>
-              <a:defRPr sz="680" b="1">
-                <a:solidFill>
-                  <a:srgbClr val="4F6B00"/>
-                </a:solidFill>
-                <a:latin typeface="Inter"/>
-              </a:defRPr>
-            </a:pPr>
-            <a:r>
-              <a:rPr>
-                <a:latin typeface="Inter"/>
-              </a:rPr>
-              <a:t>Illustrative, Gradient Maintained — demo data, not the client's holdings or managers</a:t>
-            </a:r>
-          </a:p>
-        </p:txBody>
-      </p:sp>
-      <p:sp>
-        <p:nvSpPr>
-          <p:cNvPr id="5" name="TextBox 4"/>
-          <p:cNvSpPr txBox="1"/>
-          <p:nvPr/>
-        </p:nvSpPr>
-        <p:spPr>
-          <a:xfrm>
             <a:off x="640080" y="566928"/>
             <a:ext cx="10058400" cy="530352"/>
           </a:xfrm>
@@ -5731,7 +5304,7 @@
       </p:sp>
       <p:sp>
         <p:nvSpPr>
-          <p:cNvPr id="6" name="Rectangle 5"/>
+          <p:cNvPr id="5" name="Rectangle 4"/>
           <p:cNvSpPr/>
           <p:nvPr/>
         </p:nvSpPr>
@@ -5780,7 +5353,7 @@
       </p:sp>
       <p:sp>
         <p:nvSpPr>
-          <p:cNvPr id="7" name="Rectangle 6"/>
+          <p:cNvPr id="6" name="Rectangle 5"/>
           <p:cNvSpPr/>
           <p:nvPr/>
         </p:nvSpPr>
@@ -5829,7 +5402,7 @@
       </p:sp>
       <p:sp>
         <p:nvSpPr>
-          <p:cNvPr id="8" name="TextBox 7"/>
+          <p:cNvPr id="7" name="TextBox 6"/>
           <p:cNvSpPr txBox="1"/>
           <p:nvPr/>
         </p:nvSpPr>
@@ -5871,7 +5444,7 @@
       </p:sp>
       <p:sp>
         <p:nvSpPr>
-          <p:cNvPr id="9" name="Rectangle 8"/>
+          <p:cNvPr id="8" name="Rectangle 7"/>
           <p:cNvSpPr/>
           <p:nvPr/>
         </p:nvSpPr>
@@ -5920,7 +5493,7 @@
       </p:sp>
       <p:sp>
         <p:nvSpPr>
-          <p:cNvPr id="10" name="Rectangle 9"/>
+          <p:cNvPr id="9" name="Rectangle 8"/>
           <p:cNvSpPr/>
           <p:nvPr/>
         </p:nvSpPr>
@@ -5969,7 +5542,7 @@
       </p:sp>
       <p:sp>
         <p:nvSpPr>
-          <p:cNvPr id="11" name="TextBox 10"/>
+          <p:cNvPr id="10" name="TextBox 9"/>
           <p:cNvSpPr txBox="1"/>
           <p:nvPr/>
         </p:nvSpPr>
@@ -6011,7 +5584,7 @@
       </p:sp>
       <p:sp>
         <p:nvSpPr>
-          <p:cNvPr id="12" name="TextBox 11"/>
+          <p:cNvPr id="11" name="TextBox 10"/>
           <p:cNvSpPr txBox="1"/>
           <p:nvPr/>
         </p:nvSpPr>
@@ -6046,14 +5619,14 @@
               <a:rPr>
                 <a:latin typeface="Inter"/>
               </a:rPr>
-              <a:t>Not available — governed comparison result missing [S1].</a:t>
-            </a:r>
-          </a:p>
-        </p:txBody>
-      </p:sp>
-      <p:sp>
-        <p:nvSpPr>
-          <p:cNvPr id="13" name="Rectangle 12"/>
+              <a:t>Governed comparison result missing [S1].</a:t>
+            </a:r>
+          </a:p>
+        </p:txBody>
+      </p:sp>
+      <p:sp>
+        <p:nvSpPr>
+          <p:cNvPr id="12" name="Rectangle 11"/>
           <p:cNvSpPr/>
           <p:nvPr/>
         </p:nvSpPr>
@@ -6102,7 +5675,7 @@
       </p:sp>
       <p:sp>
         <p:nvSpPr>
-          <p:cNvPr id="14" name="Rectangle 13"/>
+          <p:cNvPr id="13" name="Rectangle 12"/>
           <p:cNvSpPr/>
           <p:nvPr/>
         </p:nvSpPr>
@@ -6151,7 +5724,7 @@
       </p:sp>
       <p:sp>
         <p:nvSpPr>
-          <p:cNvPr id="15" name="TextBox 14"/>
+          <p:cNvPr id="14" name="TextBox 13"/>
           <p:cNvSpPr txBox="1"/>
           <p:nvPr/>
         </p:nvSpPr>
@@ -6193,7 +5766,7 @@
       </p:sp>
       <p:sp>
         <p:nvSpPr>
-          <p:cNvPr id="16" name="TextBox 15"/>
+          <p:cNvPr id="15" name="TextBox 14"/>
           <p:cNvSpPr txBox="1"/>
           <p:nvPr/>
         </p:nvSpPr>
@@ -6235,7 +5808,7 @@
       </p:sp>
       <p:sp>
         <p:nvSpPr>
-          <p:cNvPr id="17" name="Rectangle 16"/>
+          <p:cNvPr id="16" name="Rectangle 15"/>
           <p:cNvSpPr/>
           <p:nvPr/>
         </p:nvSpPr>
@@ -6284,7 +5857,7 @@
       </p:sp>
       <p:sp>
         <p:nvSpPr>
-          <p:cNvPr id="18" name="TextBox 17"/>
+          <p:cNvPr id="17" name="TextBox 16"/>
           <p:cNvSpPr txBox="1"/>
           <p:nvPr/>
         </p:nvSpPr>
@@ -6326,7 +5899,7 @@
       </p:sp>
       <p:sp>
         <p:nvSpPr>
-          <p:cNvPr id="19" name="TextBox 18"/>
+          <p:cNvPr id="18" name="TextBox 17"/>
           <p:cNvSpPr txBox="1"/>
           <p:nvPr/>
         </p:nvSpPr>
@@ -6368,7 +5941,7 @@
       </p:sp>
       <p:sp>
         <p:nvSpPr>
-          <p:cNvPr id="20" name="TextBox 19"/>
+          <p:cNvPr id="19" name="TextBox 18"/>
           <p:cNvSpPr txBox="1"/>
           <p:nvPr/>
         </p:nvSpPr>
@@ -6484,7 +6057,7 @@
         <p:spPr>
           <a:xfrm>
             <a:off x="640080" y="329184"/>
-            <a:ext cx="5303520" cy="182880"/>
+            <a:ext cx="9875520" cy="182880"/>
           </a:xfrm>
           <a:prstGeom prst="rect">
             <a:avLst/>
@@ -6525,48 +6098,6 @@
         </p:nvSpPr>
         <p:spPr>
           <a:xfrm>
-            <a:off x="5897880" y="310896"/>
-            <a:ext cx="4800600" cy="256032"/>
-          </a:xfrm>
-          <a:prstGeom prst="rect">
-            <a:avLst/>
-          </a:prstGeom>
-          <a:noFill/>
-        </p:spPr>
-        <p:txBody>
-          <a:bodyPr wrap="none" lIns="9144" rIns="9144" tIns="9144" bIns="9144" anchor="t">
-            <a:spAutoFit/>
-          </a:bodyPr>
-          <a:lstStyle/>
-          <a:p>
-            <a:pPr algn="r">
-              <a:spcAft>
-                <a:spcPts val="0"/>
-              </a:spcAft>
-              <a:defRPr sz="680" b="1">
-                <a:solidFill>
-                  <a:srgbClr val="4F6B00"/>
-                </a:solidFill>
-                <a:latin typeface="Inter"/>
-              </a:defRPr>
-            </a:pPr>
-            <a:r>
-              <a:rPr>
-                <a:latin typeface="Inter"/>
-              </a:rPr>
-              <a:t>Illustrative, Gradient Maintained — demo data, not the client's holdings or managers</a:t>
-            </a:r>
-          </a:p>
-        </p:txBody>
-      </p:sp>
-      <p:sp>
-        <p:nvSpPr>
-          <p:cNvPr id="5" name="TextBox 4"/>
-          <p:cNvSpPr txBox="1"/>
-          <p:nvPr/>
-        </p:nvSpPr>
-        <p:spPr>
-          <a:xfrm>
             <a:off x="640080" y="566928"/>
             <a:ext cx="10058400" cy="530352"/>
           </a:xfrm>
@@ -6603,7 +6134,7 @@
       </p:sp>
       <p:sp>
         <p:nvSpPr>
-          <p:cNvPr id="6" name="Rectangle 5"/>
+          <p:cNvPr id="5" name="Rectangle 4"/>
           <p:cNvSpPr/>
           <p:nvPr/>
         </p:nvSpPr>
@@ -6652,7 +6183,7 @@
       </p:sp>
       <p:sp>
         <p:nvSpPr>
-          <p:cNvPr id="7" name="Rectangle 6"/>
+          <p:cNvPr id="6" name="Rectangle 5"/>
           <p:cNvSpPr/>
           <p:nvPr/>
         </p:nvSpPr>
@@ -6701,7 +6232,7 @@
       </p:sp>
       <p:sp>
         <p:nvSpPr>
-          <p:cNvPr id="8" name="TextBox 7"/>
+          <p:cNvPr id="7" name="TextBox 6"/>
           <p:cNvSpPr txBox="1"/>
           <p:nvPr/>
         </p:nvSpPr>
@@ -6743,7 +6274,7 @@
       </p:sp>
       <p:sp>
         <p:nvSpPr>
-          <p:cNvPr id="9" name="Rectangle 8"/>
+          <p:cNvPr id="8" name="Rectangle 7"/>
           <p:cNvSpPr/>
           <p:nvPr/>
         </p:nvSpPr>
@@ -6792,7 +6323,7 @@
       </p:sp>
       <p:sp>
         <p:nvSpPr>
-          <p:cNvPr id="10" name="Rectangle 9"/>
+          <p:cNvPr id="9" name="Rectangle 8"/>
           <p:cNvSpPr/>
           <p:nvPr/>
         </p:nvSpPr>
@@ -6841,7 +6372,7 @@
       </p:sp>
       <p:sp>
         <p:nvSpPr>
-          <p:cNvPr id="11" name="TextBox 10"/>
+          <p:cNvPr id="10" name="TextBox 9"/>
           <p:cNvSpPr txBox="1"/>
           <p:nvPr/>
         </p:nvSpPr>
@@ -6883,7 +6414,7 @@
       </p:sp>
       <p:sp>
         <p:nvSpPr>
-          <p:cNvPr id="12" name="TextBox 11"/>
+          <p:cNvPr id="11" name="TextBox 10"/>
           <p:cNvSpPr txBox="1"/>
           <p:nvPr/>
         </p:nvSpPr>
@@ -6918,14 +6449,14 @@
               <a:rPr>
                 <a:latin typeface="Inter"/>
               </a:rPr>
-              <a:t>Not available — relative-return result missing [S1].</a:t>
-            </a:r>
-          </a:p>
-        </p:txBody>
-      </p:sp>
-      <p:sp>
-        <p:nvSpPr>
-          <p:cNvPr id="13" name="Rectangle 12"/>
+              <a:t>Relative-return result missing [S1].</a:t>
+            </a:r>
+          </a:p>
+        </p:txBody>
+      </p:sp>
+      <p:sp>
+        <p:nvSpPr>
+          <p:cNvPr id="12" name="Rectangle 11"/>
           <p:cNvSpPr/>
           <p:nvPr/>
         </p:nvSpPr>
@@ -6974,7 +6505,7 @@
       </p:sp>
       <p:sp>
         <p:nvSpPr>
-          <p:cNvPr id="14" name="Rectangle 13"/>
+          <p:cNvPr id="13" name="Rectangle 12"/>
           <p:cNvSpPr/>
           <p:nvPr/>
         </p:nvSpPr>
@@ -7023,7 +6554,7 @@
       </p:sp>
       <p:sp>
         <p:nvSpPr>
-          <p:cNvPr id="15" name="TextBox 14"/>
+          <p:cNvPr id="14" name="TextBox 13"/>
           <p:cNvSpPr txBox="1"/>
           <p:nvPr/>
         </p:nvSpPr>
@@ -7065,7 +6596,7 @@
       </p:sp>
       <p:sp>
         <p:nvSpPr>
-          <p:cNvPr id="16" name="TextBox 15"/>
+          <p:cNvPr id="15" name="TextBox 14"/>
           <p:cNvSpPr txBox="1"/>
           <p:nvPr/>
         </p:nvSpPr>
@@ -7107,7 +6638,7 @@
       </p:sp>
       <p:sp>
         <p:nvSpPr>
-          <p:cNvPr id="17" name="Rectangle 16"/>
+          <p:cNvPr id="16" name="Rectangle 15"/>
           <p:cNvSpPr/>
           <p:nvPr/>
         </p:nvSpPr>
@@ -7156,7 +6687,7 @@
       </p:sp>
       <p:sp>
         <p:nvSpPr>
-          <p:cNvPr id="18" name="TextBox 17"/>
+          <p:cNvPr id="17" name="TextBox 16"/>
           <p:cNvSpPr txBox="1"/>
           <p:nvPr/>
         </p:nvSpPr>
@@ -7198,7 +6729,7 @@
       </p:sp>
       <p:sp>
         <p:nvSpPr>
-          <p:cNvPr id="19" name="TextBox 18"/>
+          <p:cNvPr id="18" name="TextBox 17"/>
           <p:cNvSpPr txBox="1"/>
           <p:nvPr/>
         </p:nvSpPr>
@@ -7240,7 +6771,7 @@
       </p:sp>
       <p:sp>
         <p:nvSpPr>
-          <p:cNvPr id="20" name="TextBox 19"/>
+          <p:cNvPr id="19" name="TextBox 18"/>
           <p:cNvSpPr txBox="1"/>
           <p:nvPr/>
         </p:nvSpPr>
@@ -7356,7 +6887,7 @@
         <p:spPr>
           <a:xfrm>
             <a:off x="640080" y="329184"/>
-            <a:ext cx="5303520" cy="182880"/>
+            <a:ext cx="9875520" cy="182880"/>
           </a:xfrm>
           <a:prstGeom prst="rect">
             <a:avLst/>
@@ -7397,48 +6928,6 @@
         </p:nvSpPr>
         <p:spPr>
           <a:xfrm>
-            <a:off x="5897880" y="310896"/>
-            <a:ext cx="4800600" cy="256032"/>
-          </a:xfrm>
-          <a:prstGeom prst="rect">
-            <a:avLst/>
-          </a:prstGeom>
-          <a:noFill/>
-        </p:spPr>
-        <p:txBody>
-          <a:bodyPr wrap="none" lIns="9144" rIns="9144" tIns="9144" bIns="9144" anchor="t">
-            <a:spAutoFit/>
-          </a:bodyPr>
-          <a:lstStyle/>
-          <a:p>
-            <a:pPr algn="r">
-              <a:spcAft>
-                <a:spcPts val="0"/>
-              </a:spcAft>
-              <a:defRPr sz="680" b="1">
-                <a:solidFill>
-                  <a:srgbClr val="4F6B00"/>
-                </a:solidFill>
-                <a:latin typeface="Inter"/>
-              </a:defRPr>
-            </a:pPr>
-            <a:r>
-              <a:rPr>
-                <a:latin typeface="Inter"/>
-              </a:rPr>
-              <a:t>Illustrative, Gradient Maintained — demo data, not the client's holdings or managers</a:t>
-            </a:r>
-          </a:p>
-        </p:txBody>
-      </p:sp>
-      <p:sp>
-        <p:nvSpPr>
-          <p:cNvPr id="5" name="TextBox 4"/>
-          <p:cNvSpPr txBox="1"/>
-          <p:nvPr/>
-        </p:nvSpPr>
-        <p:spPr>
-          <a:xfrm>
             <a:off x="640080" y="566928"/>
             <a:ext cx="10058400" cy="530352"/>
           </a:xfrm>
@@ -7475,7 +6964,7 @@
       </p:sp>
       <p:sp>
         <p:nvSpPr>
-          <p:cNvPr id="6" name="Rectangle 5"/>
+          <p:cNvPr id="5" name="Rectangle 4"/>
           <p:cNvSpPr/>
           <p:nvPr/>
         </p:nvSpPr>
@@ -7524,7 +7013,7 @@
       </p:sp>
       <p:sp>
         <p:nvSpPr>
-          <p:cNvPr id="7" name="Rectangle 6"/>
+          <p:cNvPr id="6" name="Rectangle 5"/>
           <p:cNvSpPr/>
           <p:nvPr/>
         </p:nvSpPr>
@@ -7573,7 +7062,7 @@
       </p:sp>
       <p:sp>
         <p:nvSpPr>
-          <p:cNvPr id="8" name="TextBox 7"/>
+          <p:cNvPr id="7" name="TextBox 6"/>
           <p:cNvSpPr txBox="1"/>
           <p:nvPr/>
         </p:nvSpPr>
@@ -7615,7 +7104,7 @@
       </p:sp>
       <p:sp>
         <p:nvSpPr>
-          <p:cNvPr id="9" name="Rectangle 8"/>
+          <p:cNvPr id="8" name="Rectangle 7"/>
           <p:cNvSpPr/>
           <p:nvPr/>
         </p:nvSpPr>
@@ -7664,7 +7153,7 @@
       </p:sp>
       <p:sp>
         <p:nvSpPr>
-          <p:cNvPr id="10" name="Rectangle 9"/>
+          <p:cNvPr id="9" name="Rectangle 8"/>
           <p:cNvSpPr/>
           <p:nvPr/>
         </p:nvSpPr>
@@ -7713,7 +7202,7 @@
       </p:sp>
       <p:sp>
         <p:nvSpPr>
-          <p:cNvPr id="11" name="TextBox 10"/>
+          <p:cNvPr id="10" name="TextBox 9"/>
           <p:cNvSpPr txBox="1"/>
           <p:nvPr/>
         </p:nvSpPr>
@@ -7755,7 +7244,7 @@
       </p:sp>
       <p:sp>
         <p:nvSpPr>
-          <p:cNvPr id="12" name="TextBox 11"/>
+          <p:cNvPr id="11" name="TextBox 10"/>
           <p:cNvSpPr txBox="1"/>
           <p:nvPr/>
         </p:nvSpPr>
@@ -7790,14 +7279,14 @@
               <a:rPr>
                 <a:latin typeface="Inter"/>
               </a:rPr>
-              <a:t>Not available — governed robustness and correlation results missing [S1].</a:t>
-            </a:r>
-          </a:p>
-        </p:txBody>
-      </p:sp>
-      <p:sp>
-        <p:nvSpPr>
-          <p:cNvPr id="13" name="Rectangle 12"/>
+              <a:t>Governed robustness and correlation results missing [S1].</a:t>
+            </a:r>
+          </a:p>
+        </p:txBody>
+      </p:sp>
+      <p:sp>
+        <p:nvSpPr>
+          <p:cNvPr id="12" name="Rectangle 11"/>
           <p:cNvSpPr/>
           <p:nvPr/>
         </p:nvSpPr>
@@ -7846,7 +7335,7 @@
       </p:sp>
       <p:sp>
         <p:nvSpPr>
-          <p:cNvPr id="14" name="Rectangle 13"/>
+          <p:cNvPr id="13" name="Rectangle 12"/>
           <p:cNvSpPr/>
           <p:nvPr/>
         </p:nvSpPr>
@@ -7895,7 +7384,7 @@
       </p:sp>
       <p:sp>
         <p:nvSpPr>
-          <p:cNvPr id="15" name="TextBox 14"/>
+          <p:cNvPr id="14" name="TextBox 13"/>
           <p:cNvSpPr txBox="1"/>
           <p:nvPr/>
         </p:nvSpPr>
@@ -7937,7 +7426,7 @@
       </p:sp>
       <p:sp>
         <p:nvSpPr>
-          <p:cNvPr id="16" name="TextBox 15"/>
+          <p:cNvPr id="15" name="TextBox 14"/>
           <p:cNvSpPr txBox="1"/>
           <p:nvPr/>
         </p:nvSpPr>
@@ -7979,7 +7468,7 @@
       </p:sp>
       <p:sp>
         <p:nvSpPr>
-          <p:cNvPr id="17" name="Rectangle 16"/>
+          <p:cNvPr id="16" name="Rectangle 15"/>
           <p:cNvSpPr/>
           <p:nvPr/>
         </p:nvSpPr>
@@ -8028,7 +7517,7 @@
       </p:sp>
       <p:sp>
         <p:nvSpPr>
-          <p:cNvPr id="18" name="TextBox 17"/>
+          <p:cNvPr id="17" name="TextBox 16"/>
           <p:cNvSpPr txBox="1"/>
           <p:nvPr/>
         </p:nvSpPr>
@@ -8070,7 +7559,7 @@
       </p:sp>
       <p:sp>
         <p:nvSpPr>
-          <p:cNvPr id="19" name="TextBox 18"/>
+          <p:cNvPr id="18" name="TextBox 17"/>
           <p:cNvSpPr txBox="1"/>
           <p:nvPr/>
         </p:nvSpPr>
@@ -8112,7 +7601,7 @@
       </p:sp>
       <p:sp>
         <p:nvSpPr>
-          <p:cNvPr id="20" name="TextBox 19"/>
+          <p:cNvPr id="19" name="TextBox 18"/>
           <p:cNvSpPr txBox="1"/>
           <p:nvPr/>
         </p:nvSpPr>
@@ -8228,7 +7717,7 @@
         <p:spPr>
           <a:xfrm>
             <a:off x="640080" y="329184"/>
-            <a:ext cx="5303520" cy="182880"/>
+            <a:ext cx="9875520" cy="182880"/>
           </a:xfrm>
           <a:prstGeom prst="rect">
             <a:avLst/>
@@ -8269,48 +7758,6 @@
         </p:nvSpPr>
         <p:spPr>
           <a:xfrm>
-            <a:off x="5897880" y="310896"/>
-            <a:ext cx="4800600" cy="256032"/>
-          </a:xfrm>
-          <a:prstGeom prst="rect">
-            <a:avLst/>
-          </a:prstGeom>
-          <a:noFill/>
-        </p:spPr>
-        <p:txBody>
-          <a:bodyPr wrap="none" lIns="9144" rIns="9144" tIns="9144" bIns="9144" anchor="t">
-            <a:spAutoFit/>
-          </a:bodyPr>
-          <a:lstStyle/>
-          <a:p>
-            <a:pPr algn="r">
-              <a:spcAft>
-                <a:spcPts val="0"/>
-              </a:spcAft>
-              <a:defRPr sz="680" b="1">
-                <a:solidFill>
-                  <a:srgbClr val="4F6B00"/>
-                </a:solidFill>
-                <a:latin typeface="Inter"/>
-              </a:defRPr>
-            </a:pPr>
-            <a:r>
-              <a:rPr>
-                <a:latin typeface="Inter"/>
-              </a:rPr>
-              <a:t>Illustrative, Gradient Maintained — demo data, not the client's holdings or managers</a:t>
-            </a:r>
-          </a:p>
-        </p:txBody>
-      </p:sp>
-      <p:sp>
-        <p:nvSpPr>
-          <p:cNvPr id="5" name="TextBox 4"/>
-          <p:cNvSpPr txBox="1"/>
-          <p:nvPr/>
-        </p:nvSpPr>
-        <p:spPr>
-          <a:xfrm>
             <a:off x="640080" y="566928"/>
             <a:ext cx="10058400" cy="530352"/>
           </a:xfrm>
@@ -8347,7 +7794,7 @@
       </p:sp>
       <p:sp>
         <p:nvSpPr>
-          <p:cNvPr id="6" name="Rectangle 5"/>
+          <p:cNvPr id="5" name="Rectangle 4"/>
           <p:cNvSpPr/>
           <p:nvPr/>
         </p:nvSpPr>
@@ -8396,7 +7843,7 @@
       </p:sp>
       <p:sp>
         <p:nvSpPr>
-          <p:cNvPr id="7" name="Rectangle 6"/>
+          <p:cNvPr id="6" name="Rectangle 5"/>
           <p:cNvSpPr/>
           <p:nvPr/>
         </p:nvSpPr>
@@ -8445,7 +7892,7 @@
       </p:sp>
       <p:sp>
         <p:nvSpPr>
-          <p:cNvPr id="8" name="TextBox 7"/>
+          <p:cNvPr id="7" name="TextBox 6"/>
           <p:cNvSpPr txBox="1"/>
           <p:nvPr/>
         </p:nvSpPr>
@@ -8487,7 +7934,7 @@
       </p:sp>
       <p:sp>
         <p:nvSpPr>
-          <p:cNvPr id="9" name="TextBox 8"/>
+          <p:cNvPr id="8" name="TextBox 7"/>
           <p:cNvSpPr txBox="1"/>
           <p:nvPr/>
         </p:nvSpPr>
@@ -8536,7 +7983,7 @@
       </p:sp>
       <p:sp>
         <p:nvSpPr>
-          <p:cNvPr id="10" name="Rectangle 9"/>
+          <p:cNvPr id="9" name="Rectangle 8"/>
           <p:cNvSpPr/>
           <p:nvPr/>
         </p:nvSpPr>
@@ -8585,7 +8032,7 @@
       </p:sp>
       <p:sp>
         <p:nvSpPr>
-          <p:cNvPr id="11" name="TextBox 10"/>
+          <p:cNvPr id="10" name="TextBox 9"/>
           <p:cNvSpPr txBox="1"/>
           <p:nvPr/>
         </p:nvSpPr>
@@ -8627,7 +8074,7 @@
       </p:sp>
       <p:sp>
         <p:nvSpPr>
-          <p:cNvPr id="12" name="TextBox 11"/>
+          <p:cNvPr id="11" name="TextBox 10"/>
           <p:cNvSpPr txBox="1"/>
           <p:nvPr/>
         </p:nvSpPr>
@@ -8669,7 +8116,7 @@
       </p:sp>
       <p:sp>
         <p:nvSpPr>
-          <p:cNvPr id="13" name="TextBox 12"/>
+          <p:cNvPr id="12" name="TextBox 11"/>
           <p:cNvSpPr txBox="1"/>
           <p:nvPr/>
         </p:nvSpPr>
@@ -8785,7 +8232,7 @@
         <p:spPr>
           <a:xfrm>
             <a:off x="640080" y="329184"/>
-            <a:ext cx="5303520" cy="182880"/>
+            <a:ext cx="9875520" cy="182880"/>
           </a:xfrm>
           <a:prstGeom prst="rect">
             <a:avLst/>
@@ -8826,48 +8273,6 @@
         </p:nvSpPr>
         <p:spPr>
           <a:xfrm>
-            <a:off x="5897880" y="310896"/>
-            <a:ext cx="4800600" cy="256032"/>
-          </a:xfrm>
-          <a:prstGeom prst="rect">
-            <a:avLst/>
-          </a:prstGeom>
-          <a:noFill/>
-        </p:spPr>
-        <p:txBody>
-          <a:bodyPr wrap="none" lIns="9144" rIns="9144" tIns="9144" bIns="9144" anchor="t">
-            <a:spAutoFit/>
-          </a:bodyPr>
-          <a:lstStyle/>
-          <a:p>
-            <a:pPr algn="r">
-              <a:spcAft>
-                <a:spcPts val="0"/>
-              </a:spcAft>
-              <a:defRPr sz="680" b="1">
-                <a:solidFill>
-                  <a:srgbClr val="4F6B00"/>
-                </a:solidFill>
-                <a:latin typeface="Inter"/>
-              </a:defRPr>
-            </a:pPr>
-            <a:r>
-              <a:rPr>
-                <a:latin typeface="Inter"/>
-              </a:rPr>
-              <a:t>Illustrative, Gradient Maintained — demo data, not the client's holdings or managers</a:t>
-            </a:r>
-          </a:p>
-        </p:txBody>
-      </p:sp>
-      <p:sp>
-        <p:nvSpPr>
-          <p:cNvPr id="5" name="TextBox 4"/>
-          <p:cNvSpPr txBox="1"/>
-          <p:nvPr/>
-        </p:nvSpPr>
-        <p:spPr>
-          <a:xfrm>
             <a:off x="640080" y="566928"/>
             <a:ext cx="10058400" cy="530352"/>
           </a:xfrm>
@@ -8904,7 +8309,7 @@
       </p:sp>
       <p:sp>
         <p:nvSpPr>
-          <p:cNvPr id="6" name="Rectangle 5"/>
+          <p:cNvPr id="5" name="Rectangle 4"/>
           <p:cNvSpPr/>
           <p:nvPr/>
         </p:nvSpPr>
@@ -8953,7 +8358,7 @@
       </p:sp>
       <p:sp>
         <p:nvSpPr>
-          <p:cNvPr id="7" name="Rectangle 6"/>
+          <p:cNvPr id="6" name="Rectangle 5"/>
           <p:cNvSpPr/>
           <p:nvPr/>
         </p:nvSpPr>
@@ -9002,7 +8407,7 @@
       </p:sp>
       <p:sp>
         <p:nvSpPr>
-          <p:cNvPr id="8" name="TextBox 7"/>
+          <p:cNvPr id="7" name="TextBox 6"/>
           <p:cNvSpPr txBox="1"/>
           <p:nvPr/>
         </p:nvSpPr>
@@ -9044,7 +8449,7 @@
       </p:sp>
       <p:graphicFrame>
         <p:nvGraphicFramePr>
-          <p:cNvPr id="9" name="Table 8"/>
+          <p:cNvPr id="8" name="Table 7"/>
           <p:cNvGraphicFramePr>
             <a:graphicFrameLocks noGrp="1"/>
           </p:cNvGraphicFramePr>
@@ -9052,7 +8457,7 @@
         </p:nvGraphicFramePr>
         <p:xfrm>
           <a:off x="640080" y="1325880"/>
-          <a:ext cx="10908792" cy="968494"/>
+          <a:ext cx="10908792" cy="712350"/>
         </p:xfrm>
         <a:graphic>
           <a:graphicData uri="http://schemas.openxmlformats.org/drawingml/2006/table">
@@ -9062,16 +8467,12 @@
               </a:tblPr>
               <a:tblGrid>
                 <a:gridCol w="2011680"/>
-                <a:gridCol w="1112139"/>
-                <a:gridCol w="1112139"/>
-                <a:gridCol w="1112139"/>
-                <a:gridCol w="1112139"/>
-                <a:gridCol w="1112139"/>
-                <a:gridCol w="1112139"/>
-                <a:gridCol w="1112139"/>
-                <a:gridCol w="1112139"/>
+                <a:gridCol w="2224278"/>
+                <a:gridCol w="2224278"/>
+                <a:gridCol w="2224278"/>
+                <a:gridCol w="2224278"/>
               </a:tblGrid>
-              <a:tr h="484247">
+              <a:tr h="356175">
                 <a:tc>
                   <a:txBody>
                     <a:bodyPr/>
@@ -9143,7 +8544,7 @@
                         <a:rPr>
                           <a:latin typeface="Inter"/>
                         </a:rPr>
-                        <a:t>Basis</a:t>
+                        <a:t>Source</a:t>
                       </a:r>
                     </a:p>
                   </a:txBody>
@@ -9170,7 +8571,312 @@
                         <a:rPr>
                           <a:latin typeface="Inter"/>
                         </a:rPr>
-                        <a:t>Tool / view</a:t>
+                        <a:t>As of</a:t>
+                      </a:r>
+                    </a:p>
+                  </a:txBody>
+                  <a:tcPr marL="54864" marR="54864" marT="27432" marB="27432" anchor="ctr">
+                    <a:solidFill>
+                      <a:srgbClr val="0D1117"/>
+                    </a:solidFill>
+                  </a:tcPr>
+                </a:tc>
+                <a:tc>
+                  <a:txBody>
+                    <a:bodyPr/>
+                    <a:lstStyle/>
+                    <a:p>
+                      <a:pPr>
+                        <a:defRPr sz="750" b="1">
+                          <a:solidFill>
+                            <a:srgbClr val="FFFFFF"/>
+                          </a:solidFill>
+                          <a:latin typeface="Inter"/>
+                        </a:defRPr>
+                      </a:pPr>
+                      <a:r>
+                        <a:rPr>
+                          <a:latin typeface="Inter"/>
+                        </a:rPr>
+                        <a:t>Check</a:t>
+                      </a:r>
+                    </a:p>
+                  </a:txBody>
+                  <a:tcPr marL="54864" marR="54864" marT="27432" marB="27432" anchor="ctr">
+                    <a:solidFill>
+                      <a:srgbClr val="0D1117"/>
+                    </a:solidFill>
+                  </a:tcPr>
+                </a:tc>
+              </a:tr>
+              <a:tr h="356175">
+                <a:tc>
+                  <a:txBody>
+                    <a:bodyPr/>
+                    <a:lstStyle/>
+                    <a:p>
+                      <a:pPr>
+                        <a:defRPr sz="720" b="1">
+                          <a:solidFill>
+                            <a:srgbClr val="0D1117"/>
+                          </a:solidFill>
+                          <a:latin typeface="Inter"/>
+                        </a:defRPr>
+                      </a:pPr>
+                      <a:r>
+                        <a:rPr>
+                          <a:latin typeface="Inter"/>
+                        </a:rPr>
+                        <a:t>S1</a:t>
+                      </a:r>
+                    </a:p>
+                  </a:txBody>
+                  <a:tcPr marL="54864" marR="54864" marT="27432" marB="27432" anchor="ctr">
+                    <a:solidFill>
+                      <a:srgbClr val="FFFFFF"/>
+                    </a:solidFill>
+                  </a:tcPr>
+                </a:tc>
+                <a:tc>
+                  <a:txBody>
+                    <a:bodyPr/>
+                    <a:lstStyle/>
+                    <a:p>
+                      <a:pPr>
+                        <a:defRPr sz="720" b="0">
+                          <a:solidFill>
+                            <a:srgbClr val="0D1117"/>
+                          </a:solidFill>
+                          <a:latin typeface="Inter"/>
+                        </a:defRPr>
+                      </a:pPr>
+                      <a:r>
+                        <a:rPr>
+                          <a:latin typeface="Inter"/>
+                        </a:rPr>
+                        <a:t>Typed unavailable test response</a:t>
+                      </a:r>
+                    </a:p>
+                  </a:txBody>
+                  <a:tcPr marL="54864" marR="54864" marT="27432" marB="27432" anchor="ctr">
+                    <a:solidFill>
+                      <a:srgbClr val="FFFFFF"/>
+                    </a:solidFill>
+                  </a:tcPr>
+                </a:tc>
+                <a:tc>
+                  <a:txBody>
+                    <a:bodyPr/>
+                    <a:lstStyle/>
+                    <a:p>
+                      <a:pPr>
+                        <a:defRPr sz="720" b="0">
+                          <a:solidFill>
+                            <a:srgbClr val="0D1117"/>
+                          </a:solidFill>
+                          <a:latin typeface="Inter"/>
+                        </a:defRPr>
+                      </a:pPr>
+                      <a:r>
+                        <a:rPr>
+                          <a:latin typeface="Inter"/>
+                        </a:rPr>
+                        <a:t>get_gradient_capabilities</a:t>
+                      </a:r>
+                    </a:p>
+                  </a:txBody>
+                  <a:tcPr marL="54864" marR="54864" marT="27432" marB="27432" anchor="ctr">
+                    <a:solidFill>
+                      <a:srgbClr val="FFFFFF"/>
+                    </a:solidFill>
+                  </a:tcPr>
+                </a:tc>
+                <a:tc>
+                  <a:txBody>
+                    <a:bodyPr/>
+                    <a:lstStyle/>
+                    <a:p>
+                      <a:pPr>
+                        <a:defRPr sz="720" b="0">
+                          <a:solidFill>
+                            <a:srgbClr val="0D1117"/>
+                          </a:solidFill>
+                          <a:latin typeface="Inter"/>
+                        </a:defRPr>
+                      </a:pPr>
+                      <a:r>
+                        <a:rPr>
+                          <a:latin typeface="Inter"/>
+                        </a:rPr>
+                        <a:t>2025-12-31</a:t>
+                      </a:r>
+                    </a:p>
+                  </a:txBody>
+                  <a:tcPr marL="54864" marR="54864" marT="27432" marB="27432" anchor="ctr">
+                    <a:solidFill>
+                      <a:srgbClr val="FFFFFF"/>
+                    </a:solidFill>
+                  </a:tcPr>
+                </a:tc>
+                <a:tc>
+                  <a:txBody>
+                    <a:bodyPr/>
+                    <a:lstStyle/>
+                    <a:p>
+                      <a:pPr>
+                        <a:defRPr sz="720" b="1">
+                          <a:solidFill>
+                            <a:srgbClr val="C6F432"/>
+                          </a:solidFill>
+                          <a:latin typeface="Inter"/>
+                        </a:defRPr>
+                      </a:pPr>
+                      <a:r>
+                        <a:rPr>
+                          <a:latin typeface="Inter"/>
+                        </a:rPr>
+                        <a:t>● Passed</a:t>
+                      </a:r>
+                    </a:p>
+                  </a:txBody>
+                  <a:tcPr marL="54864" marR="54864" marT="27432" marB="27432" anchor="ctr">
+                    <a:solidFill>
+                      <a:srgbClr val="F5F7F9"/>
+                    </a:solidFill>
+                  </a:tcPr>
+                </a:tc>
+              </a:tr>
+            </a:tbl>
+          </a:graphicData>
+        </a:graphic>
+      </p:graphicFrame>
+      <p:sp>
+        <p:nvSpPr>
+          <p:cNvPr id="9" name="TextBox 8"/>
+          <p:cNvSpPr txBox="1"/>
+          <p:nvPr/>
+        </p:nvSpPr>
+        <p:spPr>
+          <a:xfrm>
+            <a:off x="640080" y="2056518"/>
+            <a:ext cx="10908792" cy="164592"/>
+          </a:xfrm>
+          <a:prstGeom prst="rect">
+            <a:avLst/>
+          </a:prstGeom>
+          <a:noFill/>
+        </p:spPr>
+        <p:txBody>
+          <a:bodyPr wrap="none" lIns="9144" rIns="9144" tIns="9144" bIns="9144" anchor="t">
+            <a:spAutoFit/>
+          </a:bodyPr>
+          <a:lstStyle/>
+          <a:p>
+            <a:pPr algn="l">
+              <a:spcAft>
+                <a:spcPts val="0"/>
+              </a:spcAft>
+              <a:defRPr sz="680" b="0">
+                <a:solidFill>
+                  <a:srgbClr val="8A94A1"/>
+                </a:solidFill>
+                <a:latin typeface="Inter"/>
+              </a:defRPr>
+            </a:pPr>
+            <a:r>
+              <a:rPr>
+                <a:latin typeface="Inter"/>
+              </a:rPr>
+              <a:t>Illustrative, Gradient Maintained — demo data, not the client's holdings or managers. All organizations, portfolios, managers and results in this public example are illustrative.</a:t>
+            </a:r>
+          </a:p>
+        </p:txBody>
+      </p:sp>
+      <p:sp>
+        <p:nvSpPr>
+          <p:cNvPr id="10" name="TextBox 9"/>
+          <p:cNvSpPr txBox="1"/>
+          <p:nvPr/>
+        </p:nvSpPr>
+        <p:spPr>
+          <a:xfrm>
+            <a:off x="640080" y="2349126"/>
+            <a:ext cx="10908792" cy="201168"/>
+          </a:xfrm>
+          <a:prstGeom prst="rect">
+            <a:avLst/>
+          </a:prstGeom>
+          <a:noFill/>
+        </p:spPr>
+        <p:txBody>
+          <a:bodyPr wrap="none" lIns="9144" rIns="9144" tIns="9144" bIns="9144" anchor="t">
+            <a:spAutoFit/>
+          </a:bodyPr>
+          <a:lstStyle/>
+          <a:p>
+            <a:pPr algn="l">
+              <a:spcAft>
+                <a:spcPts val="0"/>
+              </a:spcAft>
+              <a:defRPr sz="720" b="1">
+                <a:solidFill>
+                  <a:srgbClr val="4A5563"/>
+                </a:solidFill>
+                <a:latin typeface="Inter"/>
+              </a:defRPr>
+            </a:pPr>
+            <a:r>
+              <a:rPr>
+                <a:latin typeface="Inter"/>
+              </a:rPr>
+              <a:t>SOURCE AUDIT TRAIL</a:t>
+            </a:r>
+          </a:p>
+        </p:txBody>
+      </p:sp>
+      <p:graphicFrame>
+        <p:nvGraphicFramePr>
+          <p:cNvPr id="11" name="Table 10"/>
+          <p:cNvGraphicFramePr>
+            <a:graphicFrameLocks noGrp="1"/>
+          </p:cNvGraphicFramePr>
+          <p:nvPr/>
+        </p:nvGraphicFramePr>
+        <p:xfrm>
+          <a:off x="640080" y="2623446"/>
+          <a:ext cx="10908792" cy="438030"/>
+        </p:xfrm>
+        <a:graphic>
+          <a:graphicData uri="http://schemas.openxmlformats.org/drawingml/2006/table">
+            <a:tbl>
+              <a:tblPr firstRow="1" bandRow="1">
+                <a:tableStyleId>{5C22544A-7EE6-4342-B048-85BDC9FD1C3A}</a:tableStyleId>
+              </a:tblPr>
+              <a:tblGrid>
+                <a:gridCol w="2011680"/>
+                <a:gridCol w="2965704"/>
+                <a:gridCol w="2965704"/>
+                <a:gridCol w="2965704"/>
+              </a:tblGrid>
+              <a:tr h="219015">
+                <a:tc>
+                  <a:txBody>
+                    <a:bodyPr/>
+                    <a:lstStyle/>
+                    <a:p>
+                      <a:pPr>
+                        <a:defRPr sz="750" b="1">
+                          <a:solidFill>
+                            <a:srgbClr val="FFFFFF"/>
+                          </a:solidFill>
+                          <a:latin typeface="Inter"/>
+                        </a:defRPr>
+                      </a:pPr>
+                      <a:r>
+                        <a:rPr>
+                          <a:latin typeface="Inter"/>
+                        </a:rPr>
+                        <a:t>Tag</a:t>
                       </a:r>
                     </a:p>
                   </a:txBody>
@@ -9224,61 +8930,7 @@
                         <a:rPr>
                           <a:latin typeface="Inter"/>
                         </a:rPr>
-                        <a:t>As of</a:t>
-                      </a:r>
-                    </a:p>
-                  </a:txBody>
-                  <a:tcPr marL="54864" marR="54864" marT="27432" marB="27432" anchor="ctr">
-                    <a:solidFill>
-                      <a:srgbClr val="0D1117"/>
-                    </a:solidFill>
-                  </a:tcPr>
-                </a:tc>
-                <a:tc>
-                  <a:txBody>
-                    <a:bodyPr/>
-                    <a:lstStyle/>
-                    <a:p>
-                      <a:pPr>
-                        <a:defRPr sz="750" b="1">
-                          <a:solidFill>
-                            <a:srgbClr val="FFFFFF"/>
-                          </a:solidFill>
-                          <a:latin typeface="Inter"/>
-                        </a:defRPr>
-                      </a:pPr>
-                      <a:r>
-                        <a:rPr>
-                          <a:latin typeface="Inter"/>
-                        </a:rPr>
                         <a:t>Data scope</a:t>
-                      </a:r>
-                    </a:p>
-                  </a:txBody>
-                  <a:tcPr marL="54864" marR="54864" marT="27432" marB="27432" anchor="ctr">
-                    <a:solidFill>
-                      <a:srgbClr val="0D1117"/>
-                    </a:solidFill>
-                  </a:tcPr>
-                </a:tc>
-                <a:tc>
-                  <a:txBody>
-                    <a:bodyPr/>
-                    <a:lstStyle/>
-                    <a:p>
-                      <a:pPr>
-                        <a:defRPr sz="750" b="1">
-                          <a:solidFill>
-                            <a:srgbClr val="FFFFFF"/>
-                          </a:solidFill>
-                          <a:latin typeface="Inter"/>
-                        </a:defRPr>
-                      </a:pPr>
-                      <a:r>
-                        <a:rPr>
-                          <a:latin typeface="Inter"/>
-                        </a:rPr>
-                        <a:t>Validation</a:t>
                       </a:r>
                     </a:p>
                   </a:txBody>
@@ -9316,14 +8968,14 @@
                   </a:tcPr>
                 </a:tc>
               </a:tr>
-              <a:tr h="484247">
+              <a:tr h="219015">
                 <a:tc>
                   <a:txBody>
                     <a:bodyPr/>
                     <a:lstStyle/>
                     <a:p>
                       <a:pPr>
-                        <a:defRPr sz="650" b="1">
+                        <a:defRPr sz="800" b="1">
                           <a:solidFill>
                             <a:srgbClr val="0D1117"/>
                           </a:solidFill>
@@ -9350,88 +9002,7 @@
                     <a:lstStyle/>
                     <a:p>
                       <a:pPr>
-                        <a:defRPr sz="650" b="0">
-                          <a:solidFill>
-                            <a:srgbClr val="0D1117"/>
-                          </a:solidFill>
-                          <a:latin typeface="Inter"/>
-                        </a:defRPr>
-                      </a:pPr>
-                      <a:r>
-                        <a:rPr>
-                          <a:latin typeface="Inter"/>
-                        </a:rPr>
-                        <a:t>Typed unavailable test response</a:t>
-                      </a:r>
-                    </a:p>
-                  </a:txBody>
-                  <a:tcPr marL="54864" marR="54864" marT="27432" marB="27432" anchor="ctr">
-                    <a:solidFill>
-                      <a:srgbClr val="FFFFFF"/>
-                    </a:solidFill>
-                  </a:tcPr>
-                </a:tc>
-                <a:tc>
-                  <a:txBody>
-                    <a:bodyPr/>
-                    <a:lstStyle/>
-                    <a:p>
-                      <a:pPr>
-                        <a:defRPr sz="650" b="0">
-                          <a:solidFill>
-                            <a:srgbClr val="0D1117"/>
-                          </a:solidFill>
-                          <a:latin typeface="Inter"/>
-                        </a:defRPr>
-                      </a:pPr>
-                      <a:r>
-                        <a:rPr>
-                          <a:latin typeface="Inter"/>
-                        </a:rPr>
-                        <a:t>gradient_tool</a:t>
-                      </a:r>
-                    </a:p>
-                  </a:txBody>
-                  <a:tcPr marL="54864" marR="54864" marT="27432" marB="27432" anchor="ctr">
-                    <a:solidFill>
-                      <a:srgbClr val="FFFFFF"/>
-                    </a:solidFill>
-                  </a:tcPr>
-                </a:tc>
-                <a:tc>
-                  <a:txBody>
-                    <a:bodyPr/>
-                    <a:lstStyle/>
-                    <a:p>
-                      <a:pPr>
-                        <a:defRPr sz="650" b="0">
-                          <a:solidFill>
-                            <a:srgbClr val="0D1117"/>
-                          </a:solidFill>
-                          <a:latin typeface="Inter"/>
-                        </a:defRPr>
-                      </a:pPr>
-                      <a:r>
-                        <a:rPr>
-                          <a:latin typeface="Inter"/>
-                        </a:rPr>
-                        <a:t>get_gradient_capabilities</a:t>
-                      </a:r>
-                    </a:p>
-                  </a:txBody>
-                  <a:tcPr marL="54864" marR="54864" marT="27432" marB="27432" anchor="ctr">
-                    <a:solidFill>
-                      <a:srgbClr val="FFFFFF"/>
-                    </a:solidFill>
-                  </a:tcPr>
-                </a:tc>
-                <a:tc>
-                  <a:txBody>
-                    <a:bodyPr/>
-                    <a:lstStyle/>
-                    <a:p>
-                      <a:pPr>
-                        <a:defRPr sz="650" b="0">
+                        <a:defRPr sz="800" b="0">
                           <a:solidFill>
                             <a:srgbClr val="0D1117"/>
                           </a:solidFill>
@@ -9458,7 +9029,7 @@
                     <a:lstStyle/>
                     <a:p>
                       <a:pPr>
-                        <a:defRPr sz="650" b="0">
+                        <a:defRPr sz="800" b="0">
                           <a:solidFill>
                             <a:srgbClr val="0D1117"/>
                           </a:solidFill>
@@ -9469,7 +9040,7 @@
                         <a:rPr>
                           <a:latin typeface="Inter"/>
                         </a:rPr>
-                        <a:t>2025-12-31</a:t>
+                        <a:t>Illustrative sample data</a:t>
                       </a:r>
                     </a:p>
                   </a:txBody>
@@ -9485,61 +9056,7 @@
                     <a:lstStyle/>
                     <a:p>
                       <a:pPr>
-                        <a:defRPr sz="650" b="0">
-                          <a:solidFill>
-                            <a:srgbClr val="0D1117"/>
-                          </a:solidFill>
-                          <a:latin typeface="Inter"/>
-                        </a:defRPr>
-                      </a:pPr>
-                      <a:r>
-                        <a:rPr>
-                          <a:latin typeface="Inter"/>
-                        </a:rPr>
-                        <a:t>Gradient-governed review evidence</a:t>
-                      </a:r>
-                    </a:p>
-                  </a:txBody>
-                  <a:tcPr marL="54864" marR="54864" marT="27432" marB="27432" anchor="ctr">
-                    <a:solidFill>
-                      <a:srgbClr val="FFFFFF"/>
-                    </a:solidFill>
-                  </a:tcPr>
-                </a:tc>
-                <a:tc>
-                  <a:txBody>
-                    <a:bodyPr/>
-                    <a:lstStyle/>
-                    <a:p>
-                      <a:pPr>
-                        <a:defRPr sz="650" b="0">
-                          <a:solidFill>
-                            <a:srgbClr val="0D1117"/>
-                          </a:solidFill>
-                          <a:latin typeface="Inter"/>
-                        </a:defRPr>
-                      </a:pPr>
-                      <a:r>
-                        <a:rPr>
-                          <a:latin typeface="Inter"/>
-                        </a:rPr>
-                        <a:t>passed</a:t>
-                      </a:r>
-                    </a:p>
-                  </a:txBody>
-                  <a:tcPr marL="54864" marR="54864" marT="27432" marB="27432" anchor="ctr">
-                    <a:solidFill>
-                      <a:srgbClr val="FFFFFF"/>
-                    </a:solidFill>
-                  </a:tcPr>
-                </a:tc>
-                <a:tc>
-                  <a:txBody>
-                    <a:bodyPr/>
-                    <a:lstStyle/>
-                    <a:p>
-                      <a:pPr>
-                        <a:defRPr sz="650" b="0">
+                        <a:defRPr sz="800" b="0">
                           <a:solidFill>
                             <a:srgbClr val="0D1117"/>
                           </a:solidFill>
@@ -9567,13 +9084,13 @@
       </p:graphicFrame>
       <p:sp>
         <p:nvSpPr>
-          <p:cNvPr id="10" name="TextBox 9"/>
+          <p:cNvPr id="12" name="TextBox 11"/>
           <p:cNvSpPr txBox="1"/>
           <p:nvPr/>
         </p:nvSpPr>
         <p:spPr>
           <a:xfrm>
-            <a:off x="640080" y="2312662"/>
+            <a:off x="640080" y="3079765"/>
             <a:ext cx="10908792" cy="164592"/>
           </a:xfrm>
           <a:prstGeom prst="rect">
@@ -9602,21 +9119,21 @@
               <a:rPr>
                 <a:latin typeface="Inter"/>
               </a:rPr>
-              <a:t>Illustrative, Gradient Maintained — demo data, not the client's holdings or managers. All organizations, portfolios, managers and results in this public example are illustrative.</a:t>
-            </a:r>
-          </a:p>
-        </p:txBody>
-      </p:sp>
-      <p:sp>
-        <p:nvSpPr>
-          <p:cNvPr id="11" name="Rectangle 10"/>
+              <a:t>Each digest is the SHA-256 fingerprint of the exact data the report used.</a:t>
+            </a:r>
+          </a:p>
+        </p:txBody>
+      </p:sp>
+      <p:sp>
+        <p:nvSpPr>
+          <p:cNvPr id="13" name="Rectangle 12"/>
           <p:cNvSpPr/>
           <p:nvPr/>
         </p:nvSpPr>
         <p:spPr>
           <a:xfrm>
-            <a:off x="640080" y="2605270"/>
-            <a:ext cx="10908792" cy="1632674"/>
+            <a:off x="640080" y="3372373"/>
+            <a:ext cx="10908792" cy="1275136"/>
           </a:xfrm>
           <a:prstGeom prst="rect">
             <a:avLst/>
@@ -9658,14 +9175,14 @@
       </p:sp>
       <p:sp>
         <p:nvSpPr>
-          <p:cNvPr id="12" name="Rectangle 11"/>
+          <p:cNvPr id="14" name="Rectangle 13"/>
           <p:cNvSpPr/>
           <p:nvPr/>
         </p:nvSpPr>
         <p:spPr>
           <a:xfrm>
-            <a:off x="640080" y="2605270"/>
-            <a:ext cx="54864" cy="1632674"/>
+            <a:off x="640080" y="3372373"/>
+            <a:ext cx="54864" cy="1275136"/>
           </a:xfrm>
           <a:prstGeom prst="rect">
             <a:avLst/>
@@ -9707,13 +9224,13 @@
       </p:sp>
       <p:sp>
         <p:nvSpPr>
-          <p:cNvPr id="13" name="TextBox 12"/>
+          <p:cNvPr id="15" name="TextBox 14"/>
           <p:cNvSpPr txBox="1"/>
           <p:nvPr/>
         </p:nvSpPr>
         <p:spPr>
           <a:xfrm>
-            <a:off x="804671" y="2714998"/>
+            <a:off x="804671" y="3482101"/>
             <a:ext cx="10616184" cy="228600"/>
           </a:xfrm>
           <a:prstGeom prst="rect">
@@ -9749,14 +9266,14 @@
       </p:sp>
       <p:sp>
         <p:nvSpPr>
-          <p:cNvPr id="14" name="TextBox 13"/>
+          <p:cNvPr id="16" name="TextBox 15"/>
           <p:cNvSpPr txBox="1"/>
           <p:nvPr/>
         </p:nvSpPr>
         <p:spPr>
           <a:xfrm>
-            <a:off x="804671" y="2998462"/>
-            <a:ext cx="10616184" cy="1148042"/>
+            <a:off x="804671" y="3765565"/>
+            <a:ext cx="10616184" cy="790504"/>
           </a:xfrm>
           <a:prstGeom prst="rect">
             <a:avLst/>
@@ -9791,14 +9308,14 @@
       </p:sp>
       <p:sp>
         <p:nvSpPr>
-          <p:cNvPr id="15" name="Rectangle 14"/>
+          <p:cNvPr id="17" name="Rectangle 16"/>
           <p:cNvSpPr/>
           <p:nvPr/>
         </p:nvSpPr>
         <p:spPr>
           <a:xfrm>
-            <a:off x="640080" y="4347673"/>
-            <a:ext cx="10908792" cy="1870246"/>
+            <a:off x="640080" y="4757237"/>
+            <a:ext cx="10908792" cy="1460682"/>
           </a:xfrm>
           <a:prstGeom prst="rect">
             <a:avLst/>
@@ -9840,14 +9357,14 @@
       </p:sp>
       <p:sp>
         <p:nvSpPr>
-          <p:cNvPr id="16" name="Rectangle 15"/>
+          <p:cNvPr id="18" name="Rectangle 17"/>
           <p:cNvSpPr/>
           <p:nvPr/>
         </p:nvSpPr>
         <p:spPr>
           <a:xfrm>
-            <a:off x="640080" y="4347673"/>
-            <a:ext cx="54864" cy="1870246"/>
+            <a:off x="640080" y="4757237"/>
+            <a:ext cx="54864" cy="1460682"/>
           </a:xfrm>
           <a:prstGeom prst="rect">
             <a:avLst/>
@@ -9889,13 +9406,13 @@
       </p:sp>
       <p:sp>
         <p:nvSpPr>
-          <p:cNvPr id="17" name="TextBox 16"/>
+          <p:cNvPr id="19" name="TextBox 18"/>
           <p:cNvSpPr txBox="1"/>
           <p:nvPr/>
         </p:nvSpPr>
         <p:spPr>
           <a:xfrm>
-            <a:off x="804671" y="4457401"/>
+            <a:off x="804671" y="4866965"/>
             <a:ext cx="10616184" cy="228600"/>
           </a:xfrm>
           <a:prstGeom prst="rect">
@@ -9931,14 +9448,14 @@
       </p:sp>
       <p:sp>
         <p:nvSpPr>
-          <p:cNvPr id="18" name="TextBox 17"/>
+          <p:cNvPr id="20" name="TextBox 19"/>
           <p:cNvSpPr txBox="1"/>
           <p:nvPr/>
         </p:nvSpPr>
         <p:spPr>
           <a:xfrm>
-            <a:off x="804671" y="4740865"/>
-            <a:ext cx="10616184" cy="1385614"/>
+            <a:off x="804671" y="5150429"/>
+            <a:ext cx="10616184" cy="976050"/>
           </a:xfrm>
           <a:prstGeom prst="rect">
             <a:avLst/>
@@ -9973,7 +9490,7 @@
       </p:sp>
       <p:sp>
         <p:nvSpPr>
-          <p:cNvPr id="19" name="Rectangle 18"/>
+          <p:cNvPr id="21" name="Rectangle 20"/>
           <p:cNvSpPr/>
           <p:nvPr/>
         </p:nvSpPr>
@@ -10022,7 +9539,7 @@
       </p:sp>
       <p:sp>
         <p:nvSpPr>
-          <p:cNvPr id="20" name="TextBox 19"/>
+          <p:cNvPr id="22" name="TextBox 21"/>
           <p:cNvSpPr txBox="1"/>
           <p:nvPr/>
         </p:nvSpPr>
@@ -10064,7 +9581,7 @@
       </p:sp>
       <p:sp>
         <p:nvSpPr>
-          <p:cNvPr id="21" name="TextBox 20"/>
+          <p:cNvPr id="23" name="TextBox 22"/>
           <p:cNvSpPr txBox="1"/>
           <p:nvPr/>
         </p:nvSpPr>
@@ -10106,7 +9623,7 @@
       </p:sp>
       <p:sp>
         <p:nvSpPr>
-          <p:cNvPr id="22" name="TextBox 21"/>
+          <p:cNvPr id="24" name="TextBox 23"/>
           <p:cNvSpPr txBox="1"/>
           <p:nvPr/>
         </p:nvSpPr>
@@ -10222,7 +9739,7 @@
         <p:spPr>
           <a:xfrm>
             <a:off x="640080" y="329184"/>
-            <a:ext cx="5303520" cy="182880"/>
+            <a:ext cx="9875520" cy="182880"/>
           </a:xfrm>
           <a:prstGeom prst="rect">
             <a:avLst/>
@@ -10263,48 +9780,6 @@
         </p:nvSpPr>
         <p:spPr>
           <a:xfrm>
-            <a:off x="5897880" y="310896"/>
-            <a:ext cx="4800600" cy="256032"/>
-          </a:xfrm>
-          <a:prstGeom prst="rect">
-            <a:avLst/>
-          </a:prstGeom>
-          <a:noFill/>
-        </p:spPr>
-        <p:txBody>
-          <a:bodyPr wrap="none" lIns="9144" rIns="9144" tIns="9144" bIns="9144" anchor="t">
-            <a:spAutoFit/>
-          </a:bodyPr>
-          <a:lstStyle/>
-          <a:p>
-            <a:pPr algn="r">
-              <a:spcAft>
-                <a:spcPts val="0"/>
-              </a:spcAft>
-              <a:defRPr sz="680" b="1">
-                <a:solidFill>
-                  <a:srgbClr val="4F6B00"/>
-                </a:solidFill>
-                <a:latin typeface="Inter"/>
-              </a:defRPr>
-            </a:pPr>
-            <a:r>
-              <a:rPr>
-                <a:latin typeface="Inter"/>
-              </a:rPr>
-              <a:t>Illustrative, Gradient Maintained — demo data, not the client's holdings or managers</a:t>
-            </a:r>
-          </a:p>
-        </p:txBody>
-      </p:sp>
-      <p:sp>
-        <p:nvSpPr>
-          <p:cNvPr id="5" name="TextBox 4"/>
-          <p:cNvSpPr txBox="1"/>
-          <p:nvPr/>
-        </p:nvSpPr>
-        <p:spPr>
-          <a:xfrm>
             <a:off x="640080" y="566928"/>
             <a:ext cx="10058400" cy="530352"/>
           </a:xfrm>
@@ -10341,7 +9816,7 @@
       </p:sp>
       <p:sp>
         <p:nvSpPr>
-          <p:cNvPr id="6" name="Rectangle 5"/>
+          <p:cNvPr id="5" name="Rectangle 4"/>
           <p:cNvSpPr/>
           <p:nvPr/>
         </p:nvSpPr>
@@ -10390,7 +9865,7 @@
       </p:sp>
       <p:sp>
         <p:nvSpPr>
-          <p:cNvPr id="7" name="Rectangle 6"/>
+          <p:cNvPr id="6" name="Rectangle 5"/>
           <p:cNvSpPr/>
           <p:nvPr/>
         </p:nvSpPr>
@@ -10439,7 +9914,7 @@
       </p:sp>
       <p:sp>
         <p:nvSpPr>
-          <p:cNvPr id="8" name="TextBox 7"/>
+          <p:cNvPr id="7" name="TextBox 6"/>
           <p:cNvSpPr txBox="1"/>
           <p:nvPr/>
         </p:nvSpPr>
@@ -10481,7 +9956,7 @@
       </p:sp>
       <p:sp>
         <p:nvSpPr>
-          <p:cNvPr id="9" name="Rectangle 8"/>
+          <p:cNvPr id="8" name="Rectangle 7"/>
           <p:cNvSpPr/>
           <p:nvPr/>
         </p:nvSpPr>
@@ -10530,7 +10005,7 @@
       </p:sp>
       <p:sp>
         <p:nvSpPr>
-          <p:cNvPr id="10" name="Rectangle 9"/>
+          <p:cNvPr id="9" name="Rectangle 8"/>
           <p:cNvSpPr/>
           <p:nvPr/>
         </p:nvSpPr>
@@ -10579,7 +10054,7 @@
       </p:sp>
       <p:sp>
         <p:nvSpPr>
-          <p:cNvPr id="11" name="TextBox 10"/>
+          <p:cNvPr id="10" name="TextBox 9"/>
           <p:cNvSpPr txBox="1"/>
           <p:nvPr/>
         </p:nvSpPr>
@@ -10621,7 +10096,7 @@
       </p:sp>
       <p:sp>
         <p:nvSpPr>
-          <p:cNvPr id="12" name="TextBox 11"/>
+          <p:cNvPr id="11" name="TextBox 10"/>
           <p:cNvSpPr txBox="1"/>
           <p:nvPr/>
         </p:nvSpPr>
@@ -10663,7 +10138,7 @@
       </p:sp>
       <p:sp>
         <p:nvSpPr>
-          <p:cNvPr id="13" name="Rectangle 12"/>
+          <p:cNvPr id="12" name="Rectangle 11"/>
           <p:cNvSpPr/>
           <p:nvPr/>
         </p:nvSpPr>
@@ -10712,7 +10187,7 @@
       </p:sp>
       <p:sp>
         <p:nvSpPr>
-          <p:cNvPr id="14" name="TextBox 13"/>
+          <p:cNvPr id="13" name="TextBox 12"/>
           <p:cNvSpPr txBox="1"/>
           <p:nvPr/>
         </p:nvSpPr>
@@ -10754,7 +10229,7 @@
       </p:sp>
       <p:sp>
         <p:nvSpPr>
-          <p:cNvPr id="15" name="TextBox 14"/>
+          <p:cNvPr id="14" name="TextBox 13"/>
           <p:cNvSpPr txBox="1"/>
           <p:nvPr/>
         </p:nvSpPr>
@@ -10796,7 +10271,7 @@
       </p:sp>
       <p:sp>
         <p:nvSpPr>
-          <p:cNvPr id="16" name="TextBox 15"/>
+          <p:cNvPr id="15" name="TextBox 14"/>
           <p:cNvSpPr txBox="1"/>
           <p:nvPr/>
         </p:nvSpPr>

</xml_diff>

<commit_message>
fix: clean layout QA for every example and denser decks
- PowerPoint planner pairs charts with lead-in and commentary, sets consecutive simple charts side by side, and sizes text to slide width
- Closing pages and pre-chapter pages need only orphan-tail fill; short final sections pass the heading check
- Layout repair runs up to three passes and can lift appendix preferred breaks; wrapped short tables paginate by row
- Setup stacks skill tables; IC memo soft target 12-18; trimmed sample fixtures; regenerated examples

Co-authored-by: Cursor <cursoragent@cursor.com>
</commit_message>
<xml_diff>
--- a/plugins/gradient-cio/assets/examples/gradient-idd-manager-performance-compare.pptx
+++ b/plugins/gradient-cio/assets/examples/gradient-idd-manager-performance-compare.pptx
@@ -13,7 +13,6 @@
     <ns0:sldId id="261" ns1:id="rId12"/>
     <ns0:sldId id="262" ns1:id="rId13"/>
     <ns0:sldId id="263" ns1:id="rId14"/>
-    <ns0:sldId id="264" ns1:id="rId15"/>
   </ns0:sldIdLst>
   <ns0:sldSz cx="12191695" cy="6858000" type="screen16x9"/>
   <ns0:notesSz cx="6858000" cy="9144000"/>
@@ -5878,7 +5877,7 @@
         <p:spPr>
           <a:xfrm>
             <a:off x="640080" y="1325880"/>
-            <a:ext cx="10908792" cy="2391156"/>
+            <a:ext cx="10908792" cy="2140268"/>
           </a:xfrm>
           <a:prstGeom prst="rect">
             <a:avLst/>
@@ -5927,7 +5926,7 @@
         <p:spPr>
           <a:xfrm>
             <a:off x="640080" y="1325880"/>
-            <a:ext cx="54864" cy="2391156"/>
+            <a:ext cx="54864" cy="2140268"/>
           </a:xfrm>
           <a:prstGeom prst="rect">
             <a:avLst/>
@@ -6018,7 +6017,7 @@
         <p:spPr>
           <a:xfrm>
             <a:off x="804671" y="1719072"/>
-            <a:ext cx="10616184" cy="1906523"/>
+            <a:ext cx="10616184" cy="1655636"/>
           </a:xfrm>
           <a:prstGeom prst="rect">
             <a:avLst/>
@@ -6059,8 +6058,8 @@
         </p:nvSpPr>
         <p:spPr>
           <a:xfrm>
-            <a:off x="640080" y="3826763"/>
-            <a:ext cx="10908792" cy="2391156"/>
+            <a:off x="640080" y="3575876"/>
+            <a:ext cx="10908792" cy="2642043"/>
           </a:xfrm>
           <a:prstGeom prst="rect">
             <a:avLst/>
@@ -6108,8 +6107,8 @@
         </p:nvSpPr>
         <p:spPr>
           <a:xfrm>
-            <a:off x="640080" y="3826763"/>
-            <a:ext cx="54864" cy="2391156"/>
+            <a:off x="640080" y="3575876"/>
+            <a:ext cx="54864" cy="2642043"/>
           </a:xfrm>
           <a:prstGeom prst="rect">
             <a:avLst/>
@@ -6157,7 +6156,7 @@
         </p:nvSpPr>
         <p:spPr>
           <a:xfrm>
-            <a:off x="804671" y="3936491"/>
+            <a:off x="804671" y="3685604"/>
             <a:ext cx="10616184" cy="228600"/>
           </a:xfrm>
           <a:prstGeom prst="rect">
@@ -6199,8 +6198,8 @@
         </p:nvSpPr>
         <p:spPr>
           <a:xfrm>
-            <a:off x="804671" y="4219955"/>
-            <a:ext cx="10616184" cy="1906524"/>
+            <a:off x="804671" y="3969068"/>
+            <a:ext cx="10616184" cy="2157411"/>
           </a:xfrm>
           <a:prstGeom prst="rect">
             <a:avLst/>
@@ -6750,7 +6749,7 @@
         <p:spPr>
           <a:xfrm>
             <a:off x="640080" y="1325880"/>
-            <a:ext cx="10908792" cy="2374035"/>
+            <a:ext cx="10908792" cy="2140268"/>
           </a:xfrm>
           <a:prstGeom prst="rect">
             <a:avLst/>
@@ -6799,7 +6798,7 @@
         <p:spPr>
           <a:xfrm>
             <a:off x="640080" y="1325880"/>
-            <a:ext cx="54864" cy="2374035"/>
+            <a:ext cx="54864" cy="2140268"/>
           </a:xfrm>
           <a:prstGeom prst="rect">
             <a:avLst/>
@@ -6890,7 +6889,7 @@
         <p:spPr>
           <a:xfrm>
             <a:off x="804671" y="1719072"/>
-            <a:ext cx="10616184" cy="1889403"/>
+            <a:ext cx="10616184" cy="1655636"/>
           </a:xfrm>
           <a:prstGeom prst="rect">
             <a:avLst/>
@@ -6931,8 +6930,8 @@
         </p:nvSpPr>
         <p:spPr>
           <a:xfrm>
-            <a:off x="640080" y="3809643"/>
-            <a:ext cx="10908792" cy="2408276"/>
+            <a:off x="640080" y="3575876"/>
+            <a:ext cx="10908792" cy="2642043"/>
           </a:xfrm>
           <a:prstGeom prst="rect">
             <a:avLst/>
@@ -6980,8 +6979,8 @@
         </p:nvSpPr>
         <p:spPr>
           <a:xfrm>
-            <a:off x="640080" y="3809643"/>
-            <a:ext cx="54864" cy="2408276"/>
+            <a:off x="640080" y="3575876"/>
+            <a:ext cx="54864" cy="2642043"/>
           </a:xfrm>
           <a:prstGeom prst="rect">
             <a:avLst/>
@@ -7029,7 +7028,7 @@
         </p:nvSpPr>
         <p:spPr>
           <a:xfrm>
-            <a:off x="804671" y="3919371"/>
+            <a:off x="804671" y="3685604"/>
             <a:ext cx="10616184" cy="228600"/>
           </a:xfrm>
           <a:prstGeom prst="rect">
@@ -7071,8 +7070,8 @@
         </p:nvSpPr>
         <p:spPr>
           <a:xfrm>
-            <a:off x="804671" y="4202835"/>
-            <a:ext cx="10616184" cy="1923644"/>
+            <a:off x="804671" y="3969068"/>
+            <a:ext cx="10616184" cy="2157411"/>
           </a:xfrm>
           <a:prstGeom prst="rect">
             <a:avLst/>
@@ -7622,7 +7621,7 @@
         <p:spPr>
           <a:xfrm>
             <a:off x="640080" y="1325880"/>
-            <a:ext cx="10908792" cy="2391156"/>
+            <a:ext cx="10908792" cy="2140268"/>
           </a:xfrm>
           <a:prstGeom prst="rect">
             <a:avLst/>
@@ -7671,7 +7670,7 @@
         <p:spPr>
           <a:xfrm>
             <a:off x="640080" y="1325880"/>
-            <a:ext cx="54864" cy="2391156"/>
+            <a:ext cx="54864" cy="2140268"/>
           </a:xfrm>
           <a:prstGeom prst="rect">
             <a:avLst/>
@@ -7762,7 +7761,7 @@
         <p:spPr>
           <a:xfrm>
             <a:off x="804671" y="1719072"/>
-            <a:ext cx="10616184" cy="1906523"/>
+            <a:ext cx="10616184" cy="1655636"/>
           </a:xfrm>
           <a:prstGeom prst="rect">
             <a:avLst/>
@@ -7803,8 +7802,8 @@
         </p:nvSpPr>
         <p:spPr>
           <a:xfrm>
-            <a:off x="640080" y="3826763"/>
-            <a:ext cx="10908792" cy="2391156"/>
+            <a:off x="640080" y="3575876"/>
+            <a:ext cx="10908792" cy="2642043"/>
           </a:xfrm>
           <a:prstGeom prst="rect">
             <a:avLst/>
@@ -7852,8 +7851,8 @@
         </p:nvSpPr>
         <p:spPr>
           <a:xfrm>
-            <a:off x="640080" y="3826763"/>
-            <a:ext cx="54864" cy="2391156"/>
+            <a:off x="640080" y="3575876"/>
+            <a:ext cx="54864" cy="2642043"/>
           </a:xfrm>
           <a:prstGeom prst="rect">
             <a:avLst/>
@@ -7901,7 +7900,7 @@
         </p:nvSpPr>
         <p:spPr>
           <a:xfrm>
-            <a:off x="804671" y="3936491"/>
+            <a:off x="804671" y="3685604"/>
             <a:ext cx="10616184" cy="228600"/>
           </a:xfrm>
           <a:prstGeom prst="rect">
@@ -7943,8 +7942,8 @@
         </p:nvSpPr>
         <p:spPr>
           <a:xfrm>
-            <a:off x="804671" y="4219955"/>
-            <a:ext cx="10616184" cy="1906524"/>
+            <a:off x="804671" y="3969068"/>
+            <a:ext cx="10616184" cy="2157411"/>
           </a:xfrm>
           <a:prstGeom prst="rect">
             <a:avLst/>
@@ -9052,7 +9051,7 @@
         </p:nvGraphicFramePr>
         <p:xfrm>
           <a:off x="640080" y="1325880"/>
-          <a:ext cx="10908792" cy="968494"/>
+          <a:ext cx="10908792" cy="798243"/>
         </p:xfrm>
         <a:graphic>
           <a:graphicData uri="http://schemas.openxmlformats.org/drawingml/2006/table">
@@ -9071,7 +9070,7 @@
                 <a:gridCol w="1112139"/>
                 <a:gridCol w="1112139"/>
               </a:tblGrid>
-              <a:tr h="484247">
+              <a:tr h="399121">
                 <a:tc>
                   <a:txBody>
                     <a:bodyPr/>
@@ -9316,7 +9315,7 @@
                   </a:tcPr>
                 </a:tc>
               </a:tr>
-              <a:tr h="484247">
+              <a:tr h="399122">
                 <a:tc>
                   <a:txBody>
                     <a:bodyPr/>
@@ -9573,7 +9572,7 @@
         </p:nvSpPr>
         <p:spPr>
           <a:xfrm>
-            <a:off x="640080" y="2312662"/>
+            <a:off x="640080" y="2142411"/>
             <a:ext cx="10908792" cy="164592"/>
           </a:xfrm>
           <a:prstGeom prst="rect">
@@ -9615,8 +9614,8 @@
         </p:nvSpPr>
         <p:spPr>
           <a:xfrm>
-            <a:off x="640080" y="2605270"/>
-            <a:ext cx="10908792" cy="1632674"/>
+            <a:off x="640080" y="2435019"/>
+            <a:ext cx="10908792" cy="1039649"/>
           </a:xfrm>
           <a:prstGeom prst="rect">
             <a:avLst/>
@@ -9664,8 +9663,8 @@
         </p:nvSpPr>
         <p:spPr>
           <a:xfrm>
-            <a:off x="640080" y="2605270"/>
-            <a:ext cx="54864" cy="1632674"/>
+            <a:off x="640080" y="2435019"/>
+            <a:ext cx="54864" cy="1039649"/>
           </a:xfrm>
           <a:prstGeom prst="rect">
             <a:avLst/>
@@ -9713,7 +9712,7 @@
         </p:nvSpPr>
         <p:spPr>
           <a:xfrm>
-            <a:off x="804671" y="2714998"/>
+            <a:off x="804671" y="2544747"/>
             <a:ext cx="10616184" cy="228600"/>
           </a:xfrm>
           <a:prstGeom prst="rect">
@@ -9755,8 +9754,8 @@
         </p:nvSpPr>
         <p:spPr>
           <a:xfrm>
-            <a:off x="804671" y="2998462"/>
-            <a:ext cx="10616184" cy="1148042"/>
+            <a:off x="804671" y="2828211"/>
+            <a:ext cx="10616184" cy="555017"/>
           </a:xfrm>
           <a:prstGeom prst="rect">
             <a:avLst/>
@@ -9797,8 +9796,8 @@
         </p:nvSpPr>
         <p:spPr>
           <a:xfrm>
-            <a:off x="640080" y="4347673"/>
-            <a:ext cx="10908792" cy="1870246"/>
+            <a:off x="640080" y="3584397"/>
+            <a:ext cx="10908792" cy="1261897"/>
           </a:xfrm>
           <a:prstGeom prst="rect">
             <a:avLst/>
@@ -9846,8 +9845,8 @@
         </p:nvSpPr>
         <p:spPr>
           <a:xfrm>
-            <a:off x="640080" y="4347673"/>
-            <a:ext cx="54864" cy="1870246"/>
+            <a:off x="640080" y="3584397"/>
+            <a:ext cx="54864" cy="1261897"/>
           </a:xfrm>
           <a:prstGeom prst="rect">
             <a:avLst/>
@@ -9895,7 +9894,7 @@
         </p:nvSpPr>
         <p:spPr>
           <a:xfrm>
-            <a:off x="804671" y="4457401"/>
+            <a:off x="804671" y="3694125"/>
             <a:ext cx="10616184" cy="228600"/>
           </a:xfrm>
           <a:prstGeom prst="rect">
@@ -9937,8 +9936,8 @@
         </p:nvSpPr>
         <p:spPr>
           <a:xfrm>
-            <a:off x="804671" y="4740865"/>
-            <a:ext cx="10616184" cy="1385614"/>
+            <a:off x="804671" y="3977589"/>
+            <a:ext cx="10616184" cy="777265"/>
           </a:xfrm>
           <a:prstGeom prst="rect">
             <a:avLst/>
@@ -9974,6 +9973,188 @@
       <p:sp>
         <p:nvSpPr>
           <p:cNvPr id="19" name="Rectangle 18"/>
+          <p:cNvSpPr/>
+          <p:nvPr/>
+        </p:nvSpPr>
+        <p:spPr>
+          <a:xfrm>
+            <a:off x="640080" y="4956022"/>
+            <a:ext cx="10908792" cy="1261897"/>
+          </a:xfrm>
+          <a:prstGeom prst="rect">
+            <a:avLst/>
+          </a:prstGeom>
+          <a:solidFill>
+            <a:srgbClr val="F5F7F9"/>
+          </a:solidFill>
+          <a:ln>
+            <a:solidFill>
+              <a:srgbClr val="E3E7EC"/>
+            </a:solidFill>
+          </a:ln>
+        </p:spPr>
+        <p:style>
+          <a:lnRef idx="1">
+            <a:schemeClr val="accent1"/>
+          </a:lnRef>
+          <a:fillRef idx="3">
+            <a:schemeClr val="accent1"/>
+          </a:fillRef>
+          <a:effectRef idx="2">
+            <a:schemeClr val="accent1"/>
+          </a:effectRef>
+          <a:fontRef idx="minor">
+            <a:schemeClr val="lt1"/>
+          </a:fontRef>
+        </p:style>
+        <p:txBody>
+          <a:bodyPr rtlCol="0" anchor="ctr"/>
+          <a:lstStyle/>
+          <a:p>
+            <a:pPr algn="ctr">
+              <a:defRPr>
+                <a:latin typeface="Inter"/>
+              </a:defRPr>
+            </a:pPr>
+          </a:p>
+        </p:txBody>
+      </p:sp>
+      <p:sp>
+        <p:nvSpPr>
+          <p:cNvPr id="20" name="Rectangle 19"/>
+          <p:cNvSpPr/>
+          <p:nvPr/>
+        </p:nvSpPr>
+        <p:spPr>
+          <a:xfrm>
+            <a:off x="640080" y="4956022"/>
+            <a:ext cx="54864" cy="1261897"/>
+          </a:xfrm>
+          <a:prstGeom prst="rect">
+            <a:avLst/>
+          </a:prstGeom>
+          <a:solidFill>
+            <a:srgbClr val="0D1117"/>
+          </a:solidFill>
+          <a:ln>
+            <a:solidFill>
+              <a:srgbClr val="0D1117"/>
+            </a:solidFill>
+          </a:ln>
+        </p:spPr>
+        <p:style>
+          <a:lnRef idx="1">
+            <a:schemeClr val="accent1"/>
+          </a:lnRef>
+          <a:fillRef idx="3">
+            <a:schemeClr val="accent1"/>
+          </a:fillRef>
+          <a:effectRef idx="2">
+            <a:schemeClr val="accent1"/>
+          </a:effectRef>
+          <a:fontRef idx="minor">
+            <a:schemeClr val="lt1"/>
+          </a:fontRef>
+        </p:style>
+        <p:txBody>
+          <a:bodyPr rtlCol="0" anchor="ctr"/>
+          <a:lstStyle/>
+          <a:p>
+            <a:pPr algn="ctr">
+              <a:defRPr>
+                <a:latin typeface="Inter"/>
+              </a:defRPr>
+            </a:pPr>
+          </a:p>
+        </p:txBody>
+      </p:sp>
+      <p:sp>
+        <p:nvSpPr>
+          <p:cNvPr id="21" name="TextBox 20"/>
+          <p:cNvSpPr txBox="1"/>
+          <p:nvPr/>
+        </p:nvSpPr>
+        <p:spPr>
+          <a:xfrm>
+            <a:off x="804671" y="5065750"/>
+            <a:ext cx="10616184" cy="228600"/>
+          </a:xfrm>
+          <a:prstGeom prst="rect">
+            <a:avLst/>
+          </a:prstGeom>
+          <a:noFill/>
+        </p:spPr>
+        <p:txBody>
+          <a:bodyPr wrap="none" lIns="9144" rIns="9144" tIns="9144" bIns="9144" anchor="t">
+            <a:spAutoFit/>
+          </a:bodyPr>
+          <a:lstStyle/>
+          <a:p>
+            <a:pPr algn="l">
+              <a:spcAft>
+                <a:spcPts val="0"/>
+              </a:spcAft>
+              <a:defRPr sz="1000" b="1">
+                <a:solidFill>
+                  <a:srgbClr val="0D1117"/>
+                </a:solidFill>
+                <a:latin typeface="Inter"/>
+              </a:defRPr>
+            </a:pPr>
+            <a:r>
+              <a:rPr>
+                <a:latin typeface="Inter"/>
+              </a:rPr>
+              <a:t>Metric and digest interpretation</a:t>
+            </a:r>
+          </a:p>
+        </p:txBody>
+      </p:sp>
+      <p:sp>
+        <p:nvSpPr>
+          <p:cNvPr id="22" name="TextBox 21"/>
+          <p:cNvSpPr txBox="1"/>
+          <p:nvPr/>
+        </p:nvSpPr>
+        <p:spPr>
+          <a:xfrm>
+            <a:off x="804671" y="5349214"/>
+            <a:ext cx="10616184" cy="777265"/>
+          </a:xfrm>
+          <a:prstGeom prst="rect">
+            <a:avLst/>
+          </a:prstGeom>
+          <a:noFill/>
+        </p:spPr>
+        <p:txBody>
+          <a:bodyPr wrap="none" lIns="9144" rIns="9144" tIns="9144" bIns="9144" anchor="t">
+            <a:spAutoFit/>
+          </a:bodyPr>
+          <a:lstStyle/>
+          <a:p>
+            <a:pPr algn="l">
+              <a:spcAft>
+                <a:spcPts val="0"/>
+              </a:spcAft>
+              <a:defRPr sz="950" b="0">
+                <a:solidFill>
+                  <a:srgbClr val="4A5563"/>
+                </a:solidFill>
+                <a:latin typeface="Inter"/>
+              </a:defRPr>
+            </a:pPr>
+            <a:r>
+              <a:rPr>
+                <a:latin typeface="Inter"/>
+              </a:rPr>
+              <a:t>Historical claims use returned realized metrics with their exact periods; path-distribution statistics stay labelled simulated [S1]. Each source row records the response digest, or for a failed call the typed no-payload sentinel with its error code and request ID, so a reviewer can reproduce the evidence boundary. Advisory benchmark selections stay labelled advisory.</a:t>
+            </a:r>
+          </a:p>
+        </p:txBody>
+      </p:sp>
+      <p:sp>
+        <p:nvSpPr>
+          <p:cNvPr id="23" name="Rectangle 22"/>
           <p:cNvSpPr/>
           <p:nvPr/>
         </p:nvSpPr>
@@ -10022,7 +10203,7 @@
       </p:sp>
       <p:sp>
         <p:nvSpPr>
-          <p:cNvPr id="20" name="TextBox 19"/>
+          <p:cNvPr id="24" name="TextBox 23"/>
           <p:cNvSpPr txBox="1"/>
           <p:nvPr/>
         </p:nvSpPr>
@@ -10064,7 +10245,7 @@
       </p:sp>
       <p:sp>
         <p:nvSpPr>
-          <p:cNvPr id="21" name="TextBox 20"/>
+          <p:cNvPr id="25" name="TextBox 24"/>
           <p:cNvSpPr txBox="1"/>
           <p:nvPr/>
         </p:nvSpPr>
@@ -10106,7 +10287,7 @@
       </p:sp>
       <p:sp>
         <p:nvSpPr>
-          <p:cNvPr id="22" name="TextBox 21"/>
+          <p:cNvPr id="26" name="TextBox 25"/>
           <p:cNvSpPr txBox="1"/>
           <p:nvPr/>
         </p:nvSpPr>
@@ -10142,696 +10323,6 @@
                 <a:latin typeface="Inter"/>
               </a:rPr>
               <a:t>8</a:t>
-            </a:r>
-          </a:p>
-        </p:txBody>
-      </p:sp>
-    </p:spTree>
-  </p:cSld>
-  <p:clrMapOvr>
-    <a:masterClrMapping/>
-  </p:clrMapOvr>
-</p:sld>
-</file>
-
-<file path=ppt/slides/slide9.xml><?xml version="1.0" encoding="utf-8"?>
-<p:sld xmlns:a="http://schemas.openxmlformats.org/drawingml/2006/main" xmlns:p="http://schemas.openxmlformats.org/presentationml/2006/main" xmlns:r="http://schemas.openxmlformats.org/officeDocument/2006/relationships">
-  <p:cSld>
-    <p:spTree>
-      <p:nvGrpSpPr>
-        <p:cNvPr id="1" name=""/>
-        <p:cNvGrpSpPr/>
-        <p:nvPr/>
-      </p:nvGrpSpPr>
-      <p:grpSpPr/>
-      <p:sp>
-        <p:nvSpPr>
-          <p:cNvPr id="2" name="Rectangle 1"/>
-          <p:cNvSpPr/>
-          <p:nvPr/>
-        </p:nvSpPr>
-        <p:spPr>
-          <a:xfrm>
-            <a:off x="0" y="0"/>
-            <a:ext cx="12191695" cy="6858000"/>
-          </a:xfrm>
-          <a:prstGeom prst="rect">
-            <a:avLst/>
-          </a:prstGeom>
-          <a:solidFill>
-            <a:srgbClr val="FFFFFF"/>
-          </a:solidFill>
-          <a:ln>
-            <a:solidFill>
-              <a:srgbClr val="FFFFFF"/>
-            </a:solidFill>
-          </a:ln>
-        </p:spPr>
-        <p:style>
-          <a:lnRef idx="1">
-            <a:schemeClr val="accent1"/>
-          </a:lnRef>
-          <a:fillRef idx="3">
-            <a:schemeClr val="accent1"/>
-          </a:fillRef>
-          <a:effectRef idx="2">
-            <a:schemeClr val="accent1"/>
-          </a:effectRef>
-          <a:fontRef idx="minor">
-            <a:schemeClr val="lt1"/>
-          </a:fontRef>
-        </p:style>
-        <p:txBody>
-          <a:bodyPr rtlCol="0" anchor="ctr"/>
-          <a:lstStyle/>
-          <a:p>
-            <a:pPr algn="ctr">
-              <a:defRPr>
-                <a:latin typeface="Inter"/>
-              </a:defRPr>
-            </a:pPr>
-          </a:p>
-        </p:txBody>
-      </p:sp>
-      <p:sp>
-        <p:nvSpPr>
-          <p:cNvPr id="3" name="TextBox 2"/>
-          <p:cNvSpPr txBox="1"/>
-          <p:nvPr/>
-        </p:nvSpPr>
-        <p:spPr>
-          <a:xfrm>
-            <a:off x="640080" y="329184"/>
-            <a:ext cx="5303520" cy="182880"/>
-          </a:xfrm>
-          <a:prstGeom prst="rect">
-            <a:avLst/>
-          </a:prstGeom>
-          <a:noFill/>
-        </p:spPr>
-        <p:txBody>
-          <a:bodyPr wrap="none" lIns="9144" rIns="9144" tIns="9144" bIns="9144" anchor="t">
-            <a:spAutoFit/>
-          </a:bodyPr>
-          <a:lstStyle/>
-          <a:p>
-            <a:pPr algn="l">
-              <a:spcAft>
-                <a:spcPts val="0"/>
-              </a:spcAft>
-              <a:defRPr sz="750" b="1">
-                <a:solidFill>
-                  <a:srgbClr val="4F6B00"/>
-                </a:solidFill>
-                <a:latin typeface="Inter"/>
-              </a:defRPr>
-            </a:pPr>
-            <a:r>
-              <a:rPr>
-                <a:latin typeface="Inter"/>
-              </a:rPr>
-              <a:t>SAVED ILLUSTRATIVE SAMPLE EVIDENCE</a:t>
-            </a:r>
-          </a:p>
-        </p:txBody>
-      </p:sp>
-      <p:sp>
-        <p:nvSpPr>
-          <p:cNvPr id="4" name="TextBox 3"/>
-          <p:cNvSpPr txBox="1"/>
-          <p:nvPr/>
-        </p:nvSpPr>
-        <p:spPr>
-          <a:xfrm>
-            <a:off x="5897880" y="310896"/>
-            <a:ext cx="4800600" cy="256032"/>
-          </a:xfrm>
-          <a:prstGeom prst="rect">
-            <a:avLst/>
-          </a:prstGeom>
-          <a:noFill/>
-        </p:spPr>
-        <p:txBody>
-          <a:bodyPr wrap="none" lIns="9144" rIns="9144" tIns="9144" bIns="9144" anchor="t">
-            <a:spAutoFit/>
-          </a:bodyPr>
-          <a:lstStyle/>
-          <a:p>
-            <a:pPr algn="r">
-              <a:spcAft>
-                <a:spcPts val="0"/>
-              </a:spcAft>
-              <a:defRPr sz="680" b="1">
-                <a:solidFill>
-                  <a:srgbClr val="4F6B00"/>
-                </a:solidFill>
-                <a:latin typeface="Inter"/>
-              </a:defRPr>
-            </a:pPr>
-            <a:r>
-              <a:rPr>
-                <a:latin typeface="Inter"/>
-              </a:rPr>
-              <a:t>Illustrative, Gradient Maintained — demo data, not the client's holdings or managers</a:t>
-            </a:r>
-          </a:p>
-        </p:txBody>
-      </p:sp>
-      <p:sp>
-        <p:nvSpPr>
-          <p:cNvPr id="5" name="TextBox 4"/>
-          <p:cNvSpPr txBox="1"/>
-          <p:nvPr/>
-        </p:nvSpPr>
-        <p:spPr>
-          <a:xfrm>
-            <a:off x="640080" y="566928"/>
-            <a:ext cx="10058400" cy="530352"/>
-          </a:xfrm>
-          <a:prstGeom prst="rect">
-            <a:avLst/>
-          </a:prstGeom>
-          <a:noFill/>
-        </p:spPr>
-        <p:txBody>
-          <a:bodyPr wrap="none" lIns="9144" rIns="9144" tIns="9144" bIns="9144" anchor="t">
-            <a:spAutoFit/>
-          </a:bodyPr>
-          <a:lstStyle/>
-          <a:p>
-            <a:pPr algn="l">
-              <a:spcAft>
-                <a:spcPts val="0"/>
-              </a:spcAft>
-              <a:defRPr sz="2300" b="1">
-                <a:solidFill>
-                  <a:srgbClr val="0D1117"/>
-                </a:solidFill>
-                <a:latin typeface="Inter"/>
-              </a:defRPr>
-            </a:pPr>
-            <a:r>
-              <a:rPr>
-                <a:latin typeface="Inter"/>
-              </a:rPr>
-              <a:t>Appendix — Sources and methods — continued</a:t>
-            </a:r>
-          </a:p>
-        </p:txBody>
-      </p:sp>
-      <p:sp>
-        <p:nvSpPr>
-          <p:cNvPr id="6" name="Rectangle 5"/>
-          <p:cNvSpPr/>
-          <p:nvPr/>
-        </p:nvSpPr>
-        <p:spPr>
-          <a:xfrm>
-            <a:off x="640080" y="1115568"/>
-            <a:ext cx="10908792" cy="18288"/>
-          </a:xfrm>
-          <a:prstGeom prst="rect">
-            <a:avLst/>
-          </a:prstGeom>
-          <a:solidFill>
-            <a:srgbClr val="0D1117"/>
-          </a:solidFill>
-          <a:ln>
-            <a:solidFill>
-              <a:srgbClr val="0D1117"/>
-            </a:solidFill>
-          </a:ln>
-        </p:spPr>
-        <p:style>
-          <a:lnRef idx="1">
-            <a:schemeClr val="accent1"/>
-          </a:lnRef>
-          <a:fillRef idx="3">
-            <a:schemeClr val="accent1"/>
-          </a:fillRef>
-          <a:effectRef idx="2">
-            <a:schemeClr val="accent1"/>
-          </a:effectRef>
-          <a:fontRef idx="minor">
-            <a:schemeClr val="lt1"/>
-          </a:fontRef>
-        </p:style>
-        <p:txBody>
-          <a:bodyPr rtlCol="0" anchor="ctr"/>
-          <a:lstStyle/>
-          <a:p>
-            <a:pPr algn="ctr">
-              <a:defRPr>
-                <a:latin typeface="Inter"/>
-              </a:defRPr>
-            </a:pPr>
-          </a:p>
-        </p:txBody>
-      </p:sp>
-      <p:sp>
-        <p:nvSpPr>
-          <p:cNvPr id="7" name="Rectangle 6"/>
-          <p:cNvSpPr/>
-          <p:nvPr/>
-        </p:nvSpPr>
-        <p:spPr>
-          <a:xfrm>
-            <a:off x="11018520" y="502920"/>
-            <a:ext cx="530352" cy="393192"/>
-          </a:xfrm>
-          <a:prstGeom prst="rect">
-            <a:avLst/>
-          </a:prstGeom>
-          <a:solidFill>
-            <a:srgbClr val="9AA5B1"/>
-          </a:solidFill>
-          <a:ln>
-            <a:solidFill>
-              <a:srgbClr val="9AA5B1"/>
-            </a:solidFill>
-          </a:ln>
-        </p:spPr>
-        <p:style>
-          <a:lnRef idx="1">
-            <a:schemeClr val="accent1"/>
-          </a:lnRef>
-          <a:fillRef idx="3">
-            <a:schemeClr val="accent1"/>
-          </a:fillRef>
-          <a:effectRef idx="2">
-            <a:schemeClr val="accent1"/>
-          </a:effectRef>
-          <a:fontRef idx="minor">
-            <a:schemeClr val="lt1"/>
-          </a:fontRef>
-        </p:style>
-        <p:txBody>
-          <a:bodyPr rtlCol="0" anchor="ctr"/>
-          <a:lstStyle/>
-          <a:p>
-            <a:pPr algn="ctr">
-              <a:defRPr>
-                <a:latin typeface="Inter"/>
-              </a:defRPr>
-            </a:pPr>
-          </a:p>
-        </p:txBody>
-      </p:sp>
-      <p:sp>
-        <p:nvSpPr>
-          <p:cNvPr id="8" name="TextBox 7"/>
-          <p:cNvSpPr txBox="1"/>
-          <p:nvPr/>
-        </p:nvSpPr>
-        <p:spPr>
-          <a:xfrm>
-            <a:off x="11045952" y="557784"/>
-            <a:ext cx="475488" cy="182880"/>
-          </a:xfrm>
-          <a:prstGeom prst="rect">
-            <a:avLst/>
-          </a:prstGeom>
-          <a:noFill/>
-        </p:spPr>
-        <p:txBody>
-          <a:bodyPr wrap="none" lIns="9144" rIns="9144" tIns="9144" bIns="9144" anchor="t">
-            <a:spAutoFit/>
-          </a:bodyPr>
-          <a:lstStyle/>
-          <a:p>
-            <a:pPr algn="ctr">
-              <a:spcAft>
-                <a:spcPts val="0"/>
-              </a:spcAft>
-              <a:defRPr sz="1000" b="1">
-                <a:solidFill>
-                  <a:srgbClr val="0D1117"/>
-                </a:solidFill>
-                <a:latin typeface="Inter"/>
-              </a:defRPr>
-            </a:pPr>
-            <a:r>
-              <a:rPr>
-                <a:latin typeface="Inter"/>
-              </a:rPr>
-              <a:t>A</a:t>
-            </a:r>
-          </a:p>
-        </p:txBody>
-      </p:sp>
-      <p:sp>
-        <p:nvSpPr>
-          <p:cNvPr id="9" name="Rectangle 8"/>
-          <p:cNvSpPr/>
-          <p:nvPr/>
-        </p:nvSpPr>
-        <p:spPr>
-          <a:xfrm>
-            <a:off x="640080" y="1325880"/>
-            <a:ext cx="10908792" cy="4892040"/>
-          </a:xfrm>
-          <a:prstGeom prst="rect">
-            <a:avLst/>
-          </a:prstGeom>
-          <a:solidFill>
-            <a:srgbClr val="F5F7F9"/>
-          </a:solidFill>
-          <a:ln>
-            <a:solidFill>
-              <a:srgbClr val="E3E7EC"/>
-            </a:solidFill>
-          </a:ln>
-        </p:spPr>
-        <p:style>
-          <a:lnRef idx="1">
-            <a:schemeClr val="accent1"/>
-          </a:lnRef>
-          <a:fillRef idx="3">
-            <a:schemeClr val="accent1"/>
-          </a:fillRef>
-          <a:effectRef idx="2">
-            <a:schemeClr val="accent1"/>
-          </a:effectRef>
-          <a:fontRef idx="minor">
-            <a:schemeClr val="lt1"/>
-          </a:fontRef>
-        </p:style>
-        <p:txBody>
-          <a:bodyPr rtlCol="0" anchor="ctr"/>
-          <a:lstStyle/>
-          <a:p>
-            <a:pPr algn="ctr">
-              <a:defRPr>
-                <a:latin typeface="Inter"/>
-              </a:defRPr>
-            </a:pPr>
-          </a:p>
-        </p:txBody>
-      </p:sp>
-      <p:sp>
-        <p:nvSpPr>
-          <p:cNvPr id="10" name="Rectangle 9"/>
-          <p:cNvSpPr/>
-          <p:nvPr/>
-        </p:nvSpPr>
-        <p:spPr>
-          <a:xfrm>
-            <a:off x="640080" y="1325880"/>
-            <a:ext cx="54864" cy="4892040"/>
-          </a:xfrm>
-          <a:prstGeom prst="rect">
-            <a:avLst/>
-          </a:prstGeom>
-          <a:solidFill>
-            <a:srgbClr val="0D1117"/>
-          </a:solidFill>
-          <a:ln>
-            <a:solidFill>
-              <a:srgbClr val="0D1117"/>
-            </a:solidFill>
-          </a:ln>
-        </p:spPr>
-        <p:style>
-          <a:lnRef idx="1">
-            <a:schemeClr val="accent1"/>
-          </a:lnRef>
-          <a:fillRef idx="3">
-            <a:schemeClr val="accent1"/>
-          </a:fillRef>
-          <a:effectRef idx="2">
-            <a:schemeClr val="accent1"/>
-          </a:effectRef>
-          <a:fontRef idx="minor">
-            <a:schemeClr val="lt1"/>
-          </a:fontRef>
-        </p:style>
-        <p:txBody>
-          <a:bodyPr rtlCol="0" anchor="ctr"/>
-          <a:lstStyle/>
-          <a:p>
-            <a:pPr algn="ctr">
-              <a:defRPr>
-                <a:latin typeface="Inter"/>
-              </a:defRPr>
-            </a:pPr>
-          </a:p>
-        </p:txBody>
-      </p:sp>
-      <p:sp>
-        <p:nvSpPr>
-          <p:cNvPr id="11" name="TextBox 10"/>
-          <p:cNvSpPr txBox="1"/>
-          <p:nvPr/>
-        </p:nvSpPr>
-        <p:spPr>
-          <a:xfrm>
-            <a:off x="804671" y="1435607"/>
-            <a:ext cx="10616184" cy="228600"/>
-          </a:xfrm>
-          <a:prstGeom prst="rect">
-            <a:avLst/>
-          </a:prstGeom>
-          <a:noFill/>
-        </p:spPr>
-        <p:txBody>
-          <a:bodyPr wrap="none" lIns="9144" rIns="9144" tIns="9144" bIns="9144" anchor="t">
-            <a:spAutoFit/>
-          </a:bodyPr>
-          <a:lstStyle/>
-          <a:p>
-            <a:pPr algn="l">
-              <a:spcAft>
-                <a:spcPts val="0"/>
-              </a:spcAft>
-              <a:defRPr sz="1000" b="1">
-                <a:solidFill>
-                  <a:srgbClr val="0D1117"/>
-                </a:solidFill>
-                <a:latin typeface="Inter"/>
-              </a:defRPr>
-            </a:pPr>
-            <a:r>
-              <a:rPr>
-                <a:latin typeface="Inter"/>
-              </a:rPr>
-              <a:t>Metric and digest interpretation</a:t>
-            </a:r>
-          </a:p>
-        </p:txBody>
-      </p:sp>
-      <p:sp>
-        <p:nvSpPr>
-          <p:cNvPr id="12" name="TextBox 11"/>
-          <p:cNvSpPr txBox="1"/>
-          <p:nvPr/>
-        </p:nvSpPr>
-        <p:spPr>
-          <a:xfrm>
-            <a:off x="804671" y="1719072"/>
-            <a:ext cx="10616184" cy="4407408"/>
-          </a:xfrm>
-          <a:prstGeom prst="rect">
-            <a:avLst/>
-          </a:prstGeom>
-          <a:noFill/>
-        </p:spPr>
-        <p:txBody>
-          <a:bodyPr wrap="none" lIns="9144" rIns="9144" tIns="9144" bIns="9144" anchor="t">
-            <a:spAutoFit/>
-          </a:bodyPr>
-          <a:lstStyle/>
-          <a:p>
-            <a:pPr algn="l">
-              <a:spcAft>
-                <a:spcPts val="0"/>
-              </a:spcAft>
-              <a:defRPr sz="950" b="0">
-                <a:solidFill>
-                  <a:srgbClr val="4A5563"/>
-                </a:solidFill>
-                <a:latin typeface="Inter"/>
-              </a:defRPr>
-            </a:pPr>
-            <a:r>
-              <a:rPr>
-                <a:latin typeface="Inter"/>
-              </a:rPr>
-              <a:t>Historical claims must use returned realized metrics with their exact periods, while path-distribution statistics must remain explicitly simulated [S1]. Successful tool evidence records the SHA-256 digest of the saved response; a failed call instead uses the typed no-payload sentinel and preserves its error code and request ID in the validation field. These controls prevent simulated statistics or request identifiers from being presented as observed evidence. The source row also retains the tool name, key parameters, as-of date and data scope so a reviewer can reproduce the evidence boundary without treating an unavailable payload as a successful observation. Advisory benchmark selections remain visibly advisory throughout the report and handoff. This distinction tells reviewers which comparisons are server-matched and which still require independent benchmark confirmation.</a:t>
-            </a:r>
-          </a:p>
-        </p:txBody>
-      </p:sp>
-      <p:sp>
-        <p:nvSpPr>
-          <p:cNvPr id="13" name="Rectangle 12"/>
-          <p:cNvSpPr/>
-          <p:nvPr/>
-        </p:nvSpPr>
-        <p:spPr>
-          <a:xfrm>
-            <a:off x="640080" y="6446520"/>
-            <a:ext cx="10908792" cy="9144"/>
-          </a:xfrm>
-          <a:prstGeom prst="rect">
-            <a:avLst/>
-          </a:prstGeom>
-          <a:solidFill>
-            <a:srgbClr val="E3E7EC"/>
-          </a:solidFill>
-          <a:ln>
-            <a:solidFill>
-              <a:srgbClr val="E3E7EC"/>
-            </a:solidFill>
-          </a:ln>
-        </p:spPr>
-        <p:style>
-          <a:lnRef idx="1">
-            <a:schemeClr val="accent1"/>
-          </a:lnRef>
-          <a:fillRef idx="3">
-            <a:schemeClr val="accent1"/>
-          </a:fillRef>
-          <a:effectRef idx="2">
-            <a:schemeClr val="accent1"/>
-          </a:effectRef>
-          <a:fontRef idx="minor">
-            <a:schemeClr val="lt1"/>
-          </a:fontRef>
-        </p:style>
-        <p:txBody>
-          <a:bodyPr rtlCol="0" anchor="ctr"/>
-          <a:lstStyle/>
-          <a:p>
-            <a:pPr algn="ctr">
-              <a:defRPr>
-                <a:latin typeface="Inter"/>
-              </a:defRPr>
-            </a:pPr>
-          </a:p>
-        </p:txBody>
-      </p:sp>
-      <p:sp>
-        <p:nvSpPr>
-          <p:cNvPr id="14" name="TextBox 13"/>
-          <p:cNvSpPr txBox="1"/>
-          <p:nvPr/>
-        </p:nvSpPr>
-        <p:spPr>
-          <a:xfrm>
-            <a:off x="640080" y="6501384"/>
-            <a:ext cx="4297680" cy="146304"/>
-          </a:xfrm>
-          <a:prstGeom prst="rect">
-            <a:avLst/>
-          </a:prstGeom>
-          <a:noFill/>
-        </p:spPr>
-        <p:txBody>
-          <a:bodyPr wrap="none" lIns="9144" rIns="9144" tIns="9144" bIns="9144" anchor="t">
-            <a:spAutoFit/>
-          </a:bodyPr>
-          <a:lstStyle/>
-          <a:p>
-            <a:pPr algn="l">
-              <a:spcAft>
-                <a:spcPts val="0"/>
-              </a:spcAft>
-              <a:defRPr sz="650" b="0">
-                <a:solidFill>
-                  <a:srgbClr val="8A94A1"/>
-                </a:solidFill>
-                <a:latin typeface="Inter"/>
-              </a:defRPr>
-            </a:pPr>
-            <a:r>
-              <a:rPr>
-                <a:latin typeface="Inter"/>
-              </a:rPr>
-              <a:t>Sources: S1</a:t>
-            </a:r>
-          </a:p>
-        </p:txBody>
-      </p:sp>
-      <p:sp>
-        <p:nvSpPr>
-          <p:cNvPr id="15" name="TextBox 14"/>
-          <p:cNvSpPr txBox="1"/>
-          <p:nvPr/>
-        </p:nvSpPr>
-        <p:spPr>
-          <a:xfrm>
-            <a:off x="4480560" y="6501384"/>
-            <a:ext cx="5303520" cy="146304"/>
-          </a:xfrm>
-          <a:prstGeom prst="rect">
-            <a:avLst/>
-          </a:prstGeom>
-          <a:noFill/>
-        </p:spPr>
-        <p:txBody>
-          <a:bodyPr wrap="none" lIns="9144" rIns="9144" tIns="9144" bIns="9144" anchor="t">
-            <a:spAutoFit/>
-          </a:bodyPr>
-          <a:lstStyle/>
-          <a:p>
-            <a:pPr algn="ctr">
-              <a:spcAft>
-                <a:spcPts val="0"/>
-              </a:spcAft>
-              <a:defRPr sz="650" b="0">
-                <a:solidFill>
-                  <a:srgbClr val="8A94A1"/>
-                </a:solidFill>
-                <a:latin typeface="Inter"/>
-              </a:defRPr>
-            </a:pPr>
-            <a:r>
-              <a:rPr>
-                <a:latin typeface="Inter"/>
-              </a:rPr>
-              <a:t>Confidential — manager selection review · Data as of 2025-12-31</a:t>
-            </a:r>
-          </a:p>
-        </p:txBody>
-      </p:sp>
-      <p:sp>
-        <p:nvSpPr>
-          <p:cNvPr id="16" name="TextBox 15"/>
-          <p:cNvSpPr txBox="1"/>
-          <p:nvPr/>
-        </p:nvSpPr>
-        <p:spPr>
-          <a:xfrm>
-            <a:off x="10287000" y="6501384"/>
-            <a:ext cx="1261872" cy="146304"/>
-          </a:xfrm>
-          <a:prstGeom prst="rect">
-            <a:avLst/>
-          </a:prstGeom>
-          <a:noFill/>
-        </p:spPr>
-        <p:txBody>
-          <a:bodyPr wrap="none" lIns="9144" rIns="9144" tIns="9144" bIns="9144" anchor="t">
-            <a:spAutoFit/>
-          </a:bodyPr>
-          <a:lstStyle/>
-          <a:p>
-            <a:pPr algn="r">
-              <a:spcAft>
-                <a:spcPts val="0"/>
-              </a:spcAft>
-              <a:defRPr sz="650" b="0">
-                <a:solidFill>
-                  <a:srgbClr val="8A94A1"/>
-                </a:solidFill>
-                <a:latin typeface="Inter"/>
-              </a:defRPr>
-            </a:pPr>
-            <a:r>
-              <a:rPr>
-                <a:latin typeface="Inter"/>
-              </a:rPr>
-              <a:t>9</a:t>
             </a:r>
           </a:p>
         </p:txBody>

</xml_diff>